<commit_message>
Reconcile QBR with 2026 and 2027 open pipeline
Co-authored-by: Sahil Patni <sahilpat28@users.noreply.github.com>
</commit_message>
<xml_diff>
--- a/qbr/output/Sahil_QBR_2026-07-29.pptx
+++ b/qbr/output/Sahil_QBR_2026-07-29.pptx
@@ -3425,7 +3425,7 @@
               </a:defRPr>
             </a:pPr>
             <a:r>
-              <a:t>11.82M</a:t>
+              <a:t>8.22M</a:t>
             </a:r>
           </a:p>
         </p:txBody>
@@ -3461,7 +3461,7 @@
               </a:defRPr>
             </a:pPr>
             <a:r>
-              <a:t>peak value</a:t>
+              <a:t>qualified open value</a:t>
             </a:r>
           </a:p>
         </p:txBody>
@@ -3497,7 +3497,7 @@
               </a:defRPr>
             </a:pPr>
             <a:r>
-              <a:t>14</a:t>
+              <a:t>12</a:t>
             </a:r>
           </a:p>
         </p:txBody>
@@ -3533,7 +3533,7 @@
               </a:defRPr>
             </a:pPr>
             <a:r>
-              <a:t>distinct opportunities</a:t>
+              <a:t>qualified open opportunities</a:t>
             </a:r>
           </a:p>
         </p:txBody>
@@ -3569,7 +3569,7 @@
               </a:defRPr>
             </a:pPr>
             <a:r>
-              <a:t>7</a:t>
+              <a:t>6</a:t>
             </a:r>
           </a:p>
         </p:txBody>
@@ -3659,7 +3659,7 @@
         <p:spPr>
           <a:xfrm>
             <a:off x="731520" y="6199632"/>
-            <a:ext cx="6858000" cy="219456"/>
+            <a:ext cx="7589520" cy="219456"/>
           </a:xfrm>
           <a:prstGeom prst="rect">
             <a:avLst/>
@@ -3681,7 +3681,7 @@
               </a:defRPr>
             </a:pPr>
             <a:r>
-              <a:t>Prepared from Sahil Report.xlsx  •  Source values shown without assumed currency</a:t>
+              <a:t>Prepared from master + 2026/2027 open-pipeline exports  •  Values shown without assumed currency</a:t>
             </a:r>
           </a:p>
         </p:txBody>
@@ -5392,7 +5392,7 @@
                         </a:defRPr>
                       </a:pPr>
                       <a:r>
-                        <a:t>14 opportunities; value/stage/customer view is auditable</a:t>
+                        <a:t>12 qualified open opportunities + 2 unqualified Identify plays</a:t>
                       </a:r>
                     </a:p>
                   </a:txBody>
@@ -5688,7 +5688,7 @@
                         </a:defRPr>
                       </a:pPr>
                       <a:r>
-                        <a:t>0/14 opportunities linked to a distributor account</a:t>
+                        <a:t>0/12 qualified open opportunities linked to a distributor</a:t>
                       </a:r>
                     </a:p>
                   </a:txBody>
@@ -15565,7 +15565,7 @@
               </a:defRPr>
             </a:pPr>
             <a:r>
-              <a:t>Executive snapshot: value exists; conversion discipline is the gap</a:t>
+              <a:t>Executive snapshot: 8.22M qualified open; 3.60M still unqualified</a:t>
             </a:r>
           </a:p>
         </p:txBody>
@@ -15761,7 +15761,7 @@
               </a:defRPr>
             </a:pPr>
             <a:r>
-              <a:t>PEAK PIPELINE</a:t>
+              <a:t>QUALIFIED OPEN</a:t>
             </a:r>
           </a:p>
         </p:txBody>
@@ -15797,7 +15797,7 @@
               </a:defRPr>
             </a:pPr>
             <a:r>
-              <a:t>11.82M</a:t>
+              <a:t>8.22M</a:t>
             </a:r>
           </a:p>
         </p:txBody>
@@ -15833,7 +15833,7 @@
               </a:defRPr>
             </a:pPr>
             <a:r>
-              <a:t>14 opportunities</a:t>
+              <a:t>12 opportunities</a:t>
             </a:r>
           </a:p>
         </p:txBody>
@@ -16067,7 +16067,7 @@
               </a:defRPr>
             </a:pPr>
             <a:r>
-              <a:t>ADDED IN 2026</a:t>
+              <a:t>2026 OPEN EXPORT</a:t>
             </a:r>
           </a:p>
         </p:txBody>
@@ -16103,7 +16103,7 @@
               </a:defRPr>
             </a:pPr>
             <a:r>
-              <a:t>6.70M</a:t>
+              <a:t>4.12M</a:t>
             </a:r>
           </a:p>
         </p:txBody>
@@ -16139,7 +16139,7 @@
               </a:defRPr>
             </a:pPr>
             <a:r>
-              <a:t>8 new opportunities</a:t>
+              <a:t>1 opportunity</a:t>
             </a:r>
           </a:p>
         </p:txBody>
@@ -16220,7 +16220,7 @@
               </a:defRPr>
             </a:pPr>
             <a:r>
-              <a:t>2026 DWIN-DATED</a:t>
+              <a:t>2027 OPEN EXPORT</a:t>
             </a:r>
           </a:p>
         </p:txBody>
@@ -16256,7 +16256,7 @@
               </a:defRPr>
             </a:pPr>
             <a:r>
-              <a:t>5.30M</a:t>
+              <a:t>4.09M</a:t>
             </a:r>
           </a:p>
         </p:txBody>
@@ -16292,7 +16292,7 @@
               </a:defRPr>
             </a:pPr>
             <a:r>
-              <a:t>5 opportunities</a:t>
+              <a:t>11 opportunities</a:t>
             </a:r>
           </a:p>
         </p:txBody>
@@ -16392,7 +16392,7 @@
               </a:defRPr>
             </a:pPr>
             <a:r>
-              <a:t>• 3.60M sits at Identify / 0% probability; qualification is the first value unlock.</a:t>
+              <a:t>• 3.60M across two Identify / 0% plays is absent from both open-pipeline exports.</a:t>
             </a:r>
           </a:p>
           <a:p>
@@ -16408,7 +16408,7 @@
               </a:defRPr>
             </a:pPr>
             <a:r>
-              <a:t>• Outdu AI is 4.12M (35% of portfolio) but remains Define with a 21 Oct 2026 DWIN date.</a:t>
+              <a:t>• Outdu AI is 4.12M (50% of qualified open value) but remains Define.</a:t>
             </a:r>
           </a:p>
           <a:p>
@@ -16440,7 +16440,7 @@
               </a:defRPr>
             </a:pPr>
             <a:r>
-              <a:t>• Source contains direct opportunities only; no distributor-owned pipeline is present.</a:t>
+              <a:t>• Bucket membership comes from the uploaded files; it is not derived from Design Win Date.</a:t>
             </a:r>
           </a:p>
         </p:txBody>
@@ -22216,7 +22216,7 @@
               </a:defRPr>
             </a:pPr>
             <a:r>
-              <a:t>Rows where Technical Owner = Sahil Patni; 20 product lines consolidated by Opportunity ID into 14 opportunities.</a:t>
+              <a:t>Master report: 20 Sahil product lines / 14 opportunities. Uploaded open exports: 12 qualified opportunities; 2 Identify plays remain outside.</a:t>
             </a:r>
           </a:p>
         </p:txBody>
@@ -22252,7 +22252,7 @@
               </a:defRPr>
             </a:pPr>
             <a:r>
-              <a:t>PEAK VALUE</a:t>
+              <a:t>BUCKETS</a:t>
             </a:r>
           </a:p>
         </p:txBody>
@@ -22288,7 +22288,7 @@
               </a:defRPr>
             </a:pPr>
             <a:r>
-              <a:t>Product-line Peak Value summed within each Opportunity ID. Source file does not encode currency.</a:t>
+              <a:t>“2026” and “2027” are the user-provided export labels. Membership is not inferred from Design Win Date; the 2027 export includes some 2026 DWIN dates.</a:t>
             </a:r>
           </a:p>
         </p:txBody>
@@ -22324,7 +22324,7 @@
               </a:defRPr>
             </a:pPr>
             <a:r>
-              <a:t>WEIGHTED VALUE</a:t>
+              <a:t>PEAK VALUE</a:t>
             </a:r>
           </a:p>
         </p:txBody>
@@ -22360,7 +22360,7 @@
               </a:defRPr>
             </a:pPr>
             <a:r>
-              <a:t>Consolidated peak value × source probability. Identify opportunities at 0% therefore contribute zero.</a:t>
+              <a:t>Product-line Peak Value summed within each Opportunity ID. Source file does not encode currency.</a:t>
             </a:r>
           </a:p>
         </p:txBody>
@@ -22396,7 +22396,7 @@
               </a:defRPr>
             </a:pPr>
             <a:r>
-              <a:t>DWIN-DATED</a:t>
+              <a:t>WEIGHTED VALUE</a:t>
             </a:r>
           </a:p>
         </p:txBody>
@@ -22432,7 +22432,7 @@
               </a:defRPr>
             </a:pPr>
             <a:r>
-              <a:t>Opportunity Design Win Date falls in the stated year. This is a scheduled date, not proof of an achieved design win.</a:t>
+              <a:t>Consolidated peak value × source probability. Identify opportunities at 0% therefore contribute zero.</a:t>
             </a:r>
           </a:p>
         </p:txBody>
@@ -22468,7 +22468,7 @@
               </a:defRPr>
             </a:pPr>
             <a:r>
-              <a:t>DATES</a:t>
+              <a:t>DWIN-DATED</a:t>
             </a:r>
           </a:p>
         </p:txBody>
@@ -22504,7 +22504,7 @@
               </a:defRPr>
             </a:pPr>
             <a:r>
-              <a:t>Source mixes Excel dates and text dates; both were normalized for analysis.</a:t>
+              <a:t>Opportunity Design Win Date falls in the stated year. This is a scheduled date, not proof of an achieved design win.</a:t>
             </a:r>
           </a:p>
         </p:txBody>
@@ -22540,7 +22540,7 @@
               </a:defRPr>
             </a:pPr>
             <a:r>
-              <a:t>COVERAGE</a:t>
+              <a:t>DATES</a:t>
             </a:r>
           </a:p>
         </p:txBody>
@@ -22576,7 +22576,7 @@
               </a:defRPr>
             </a:pPr>
             <a:r>
-              <a:t>All Sahil records are “Altera Opportunity”; Distributor Account is blank. No channel pipeline can be inferred.</a:t>
+              <a:t>Source mixes Excel dates and text dates; both were normalized for analysis.</a:t>
             </a:r>
           </a:p>
         </p:txBody>
@@ -22612,7 +22612,7 @@
               </a:defRPr>
             </a:pPr>
             <a:r>
-              <a:t>NOT AVAILABLE</a:t>
+              <a:t>COVERAGE</a:t>
             </a:r>
           </a:p>
         </p:txBody>
@@ -22648,7 +22648,7 @@
               </a:defRPr>
             </a:pPr>
             <a:r>
-              <a:t>Target, actual achievement, revenue/bookings, support history, market share, next actions, and named DFAE assignments.</a:t>
+              <a:t>All 12 uploaded open opportunities are direct and Distributor Account is blank. No channel-owned pipeline is evidenced.</a:t>
             </a:r>
           </a:p>
         </p:txBody>
@@ -26167,7 +26167,7 @@
               </a:defRPr>
             </a:pPr>
             <a:r>
-              <a:t>Peak pipeline</a:t>
+              <a:t>Qualified open</a:t>
             </a:r>
           </a:p>
         </p:txBody>
@@ -26203,7 +26203,7 @@
               </a:defRPr>
             </a:pPr>
             <a:r>
-              <a:t>11.82M</a:t>
+              <a:t>12 / 8.22M</a:t>
             </a:r>
           </a:p>
         </p:txBody>
@@ -26311,7 +26311,7 @@
               </a:defRPr>
             </a:pPr>
             <a:r>
-              <a:t>2026-created</a:t>
+              <a:t>2026 export</a:t>
             </a:r>
           </a:p>
         </p:txBody>
@@ -26347,7 +26347,7 @@
               </a:defRPr>
             </a:pPr>
             <a:r>
-              <a:t>8 / 6.70M</a:t>
+              <a:t>1 / 4.12M</a:t>
             </a:r>
           </a:p>
         </p:txBody>
@@ -26383,7 +26383,7 @@
               </a:defRPr>
             </a:pPr>
             <a:r>
-              <a:t>2026 DWIN-dated</a:t>
+              <a:t>2027 export</a:t>
             </a:r>
           </a:p>
         </p:txBody>
@@ -26419,7 +26419,7 @@
               </a:defRPr>
             </a:pPr>
             <a:r>
-              <a:t>5 / 5.30M</a:t>
+              <a:t>11 / 4.09M</a:t>
             </a:r>
           </a:p>
         </p:txBody>
@@ -26553,7 +26553,7 @@
               </a:defRPr>
             </a:pPr>
             <a:r>
-              <a:t>Opportunity funnel: 58% of value remains at 0–25% probability</a:t>
+              <a:t>Opportunity funnel: separate qualified open from 0% identification</a:t>
             </a:r>
           </a:p>
         </p:txBody>
@@ -27677,7 +27677,7 @@
               </a:defRPr>
             </a:pPr>
             <a:r>
-              <a:t>Top 3 = 68% of peak value</a:t>
+              <a:t>Qualified top 3 = 71%</a:t>
             </a:r>
           </a:p>
         </p:txBody>
@@ -27707,13 +27707,13 @@
             <a:pPr algn="l">
               <a:defRPr sz="1300" b="1">
                 <a:solidFill>
-                  <a:srgbClr val="FF5A5F"/>
-                </a:solidFill>
-                <a:latin typeface="Aptos"/>
-              </a:defRPr>
-            </a:pPr>
-            <a:r>
-              <a:t>2 Identify opportunities = 0 weighted value</a:t>
+                  <a:srgbClr val="00B8A9"/>
+                </a:solidFill>
+                <a:latin typeface="Aptos"/>
+              </a:defRPr>
+            </a:pPr>
+            <a:r>
+              <a:t>Open exports = 8.22M</a:t>
             </a:r>
           </a:p>
         </p:txBody>
@@ -27743,13 +27743,13 @@
             <a:pPr algn="l">
               <a:defRPr sz="1300" b="1">
                 <a:solidFill>
-                  <a:srgbClr val="00B8A9"/>
-                </a:solidFill>
-                <a:latin typeface="Aptos"/>
-              </a:defRPr>
-            </a:pPr>
-            <a:r>
-              <a:t>Priority: qualify → define → evidence</a:t>
+                  <a:srgbClr val="FF5A5F"/>
+                </a:solidFill>
+                <a:latin typeface="Aptos"/>
+              </a:defRPr>
+            </a:pPr>
+            <a:r>
+              <a:t>Identify outside exports = 3.60M</a:t>
             </a:r>
           </a:p>
         </p:txBody>
@@ -29228,7 +29228,7 @@
               </a:defRPr>
             </a:pPr>
             <a:r>
-              <a:t>Top opportunities 1–7: protect the concentration</a:t>
+              <a:t>Top qualified opportunities 1–7: protect the concentration</a:t>
             </a:r>
           </a:p>
         </p:txBody>
@@ -29803,200 +29803,6 @@
                         </a:defRPr>
                       </a:pPr>
                       <a:r>
-                        <a:t>Honeywell Aerospace</a:t>
-                      </a:r>
-                    </a:p>
-                  </a:txBody>
-                  <a:tcPr marL="54864" marR="36576" marT="22860" marB="18288">
-                    <a:solidFill>
-                      <a:srgbClr val="14213D"/>
-                    </a:solidFill>
-                  </a:tcPr>
-                </a:tc>
-                <a:tc>
-                  <a:txBody>
-                    <a:bodyPr wrap="square" anchor="ctr"/>
-                    <a:lstStyle/>
-                    <a:p>
-                      <a:pPr>
-                        <a:defRPr sz="810">
-                          <a:solidFill>
-                            <a:srgbClr val="F7FAFC"/>
-                          </a:solidFill>
-                          <a:latin typeface="Aptos"/>
-                        </a:defRPr>
-                      </a:pPr>
-                      <a:r>
-                        <a:t>Weather Monitoring Radar</a:t>
-                      </a:r>
-                    </a:p>
-                  </a:txBody>
-                  <a:tcPr marL="54864" marR="36576" marT="22860" marB="18288">
-                    <a:solidFill>
-                      <a:srgbClr val="14213D"/>
-                    </a:solidFill>
-                  </a:tcPr>
-                </a:tc>
-                <a:tc>
-                  <a:txBody>
-                    <a:bodyPr wrap="square" anchor="ctr"/>
-                    <a:lstStyle/>
-                    <a:p>
-                      <a:pPr>
-                        <a:defRPr sz="810">
-                          <a:solidFill>
-                            <a:srgbClr val="F7FAFC"/>
-                          </a:solidFill>
-                          <a:latin typeface="Aptos"/>
-                        </a:defRPr>
-                      </a:pPr>
-                      <a:r>
-                        <a:t>Identify</a:t>
-                      </a:r>
-                    </a:p>
-                  </a:txBody>
-                  <a:tcPr marL="54864" marR="36576" marT="22860" marB="18288">
-                    <a:solidFill>
-                      <a:srgbClr val="14213D"/>
-                    </a:solidFill>
-                  </a:tcPr>
-                </a:tc>
-                <a:tc>
-                  <a:txBody>
-                    <a:bodyPr wrap="square" anchor="ctr"/>
-                    <a:lstStyle/>
-                    <a:p>
-                      <a:pPr>
-                        <a:defRPr sz="810">
-                          <a:solidFill>
-                            <a:srgbClr val="F7FAFC"/>
-                          </a:solidFill>
-                          <a:latin typeface="Aptos"/>
-                        </a:defRPr>
-                      </a:pPr>
-                      <a:r>
-                        <a:t>0%</a:t>
-                      </a:r>
-                    </a:p>
-                  </a:txBody>
-                  <a:tcPr marL="54864" marR="36576" marT="22860" marB="18288">
-                    <a:solidFill>
-                      <a:srgbClr val="14213D"/>
-                    </a:solidFill>
-                  </a:tcPr>
-                </a:tc>
-                <a:tc>
-                  <a:txBody>
-                    <a:bodyPr wrap="square" anchor="ctr"/>
-                    <a:lstStyle/>
-                    <a:p>
-                      <a:pPr>
-                        <a:defRPr sz="810">
-                          <a:solidFill>
-                            <a:srgbClr val="F7FAFC"/>
-                          </a:solidFill>
-                          <a:latin typeface="Aptos"/>
-                        </a:defRPr>
-                      </a:pPr>
-                      <a:r>
-                        <a:t>24 Nov 2027</a:t>
-                      </a:r>
-                    </a:p>
-                  </a:txBody>
-                  <a:tcPr marL="54864" marR="36576" marT="22860" marB="18288">
-                    <a:solidFill>
-                      <a:srgbClr val="14213D"/>
-                    </a:solidFill>
-                  </a:tcPr>
-                </a:tc>
-                <a:tc>
-                  <a:txBody>
-                    <a:bodyPr wrap="square" anchor="ctr"/>
-                    <a:lstStyle/>
-                    <a:p>
-                      <a:pPr>
-                        <a:defRPr sz="810">
-                          <a:solidFill>
-                            <a:srgbClr val="F7FAFC"/>
-                          </a:solidFill>
-                          <a:latin typeface="Aptos"/>
-                        </a:defRPr>
-                      </a:pPr>
-                      <a:r>
-                        <a:t>3.00M</a:t>
-                      </a:r>
-                    </a:p>
-                  </a:txBody>
-                  <a:tcPr marL="54864" marR="36576" marT="22860" marB="18288">
-                    <a:solidFill>
-                      <a:srgbClr val="14213D"/>
-                    </a:solidFill>
-                  </a:tcPr>
-                </a:tc>
-                <a:tc>
-                  <a:txBody>
-                    <a:bodyPr wrap="square" anchor="ctr"/>
-                    <a:lstStyle/>
-                    <a:p>
-                      <a:pPr>
-                        <a:defRPr sz="810">
-                          <a:solidFill>
-                            <a:srgbClr val="F7FAFC"/>
-                          </a:solidFill>
-                          <a:latin typeface="Aptos"/>
-                        </a:defRPr>
-                      </a:pPr>
-                      <a:r>
-                        <a:t>Qualify use case, sponsor, budget and 0→25% gate</a:t>
-                      </a:r>
-                    </a:p>
-                  </a:txBody>
-                  <a:tcPr marL="54864" marR="36576" marT="22860" marB="18288">
-                    <a:solidFill>
-                      <a:srgbClr val="14213D"/>
-                    </a:solidFill>
-                  </a:tcPr>
-                </a:tc>
-              </a:tr>
-              <a:tr h="562356">
-                <a:tc>
-                  <a:txBody>
-                    <a:bodyPr wrap="square" anchor="ctr"/>
-                    <a:lstStyle/>
-                    <a:p>
-                      <a:pPr>
-                        <a:defRPr sz="810">
-                          <a:solidFill>
-                            <a:srgbClr val="F7FAFC"/>
-                          </a:solidFill>
-                          <a:latin typeface="Aptos"/>
-                        </a:defRPr>
-                      </a:pPr>
-                      <a:r>
-                        <a:t>3</a:t>
-                      </a:r>
-                    </a:p>
-                  </a:txBody>
-                  <a:tcPr marL="54864" marR="36576" marT="22860" marB="18288">
-                    <a:solidFill>
-                      <a:srgbClr val="14213D"/>
-                    </a:solidFill>
-                  </a:tcPr>
-                </a:tc>
-                <a:tc>
-                  <a:txBody>
-                    <a:bodyPr wrap="square" anchor="ctr"/>
-                    <a:lstStyle/>
-                    <a:p>
-                      <a:pPr>
-                        <a:defRPr sz="810">
-                          <a:solidFill>
-                            <a:srgbClr val="F7FAFC"/>
-                          </a:solidFill>
-                          <a:latin typeface="Aptos"/>
-                        </a:defRPr>
-                      </a:pPr>
-                      <a:r>
                         <a:t>Juniper</a:t>
                       </a:r>
                     </a:p>
@@ -30167,6 +29973,200 @@
                         </a:defRPr>
                       </a:pPr>
                       <a:r>
+                        <a:t>3</a:t>
+                      </a:r>
+                    </a:p>
+                  </a:txBody>
+                  <a:tcPr marL="54864" marR="36576" marT="22860" marB="18288">
+                    <a:solidFill>
+                      <a:srgbClr val="14213D"/>
+                    </a:solidFill>
+                  </a:tcPr>
+                </a:tc>
+                <a:tc>
+                  <a:txBody>
+                    <a:bodyPr wrap="square" anchor="ctr"/>
+                    <a:lstStyle/>
+                    <a:p>
+                      <a:pPr>
+                        <a:defRPr sz="810">
+                          <a:solidFill>
+                            <a:srgbClr val="F7FAFC"/>
+                          </a:solidFill>
+                          <a:latin typeface="Aptos"/>
+                        </a:defRPr>
+                      </a:pPr>
+                      <a:r>
+                        <a:t>Outdu</a:t>
+                      </a:r>
+                    </a:p>
+                  </a:txBody>
+                  <a:tcPr marL="54864" marR="36576" marT="22860" marB="18288">
+                    <a:solidFill>
+                      <a:srgbClr val="14213D"/>
+                    </a:solidFill>
+                  </a:tcPr>
+                </a:tc>
+                <a:tc>
+                  <a:txBody>
+                    <a:bodyPr wrap="square" anchor="ctr"/>
+                    <a:lstStyle/>
+                    <a:p>
+                      <a:pPr>
+                        <a:defRPr sz="810">
+                          <a:solidFill>
+                            <a:srgbClr val="F7FAFC"/>
+                          </a:solidFill>
+                          <a:latin typeface="Aptos"/>
+                        </a:defRPr>
+                      </a:pPr>
+                      <a:r>
+                        <a:t>Long Range Tracking System</a:t>
+                      </a:r>
+                    </a:p>
+                  </a:txBody>
+                  <a:tcPr marL="54864" marR="36576" marT="22860" marB="18288">
+                    <a:solidFill>
+                      <a:srgbClr val="14213D"/>
+                    </a:solidFill>
+                  </a:tcPr>
+                </a:tc>
+                <a:tc>
+                  <a:txBody>
+                    <a:bodyPr wrap="square" anchor="ctr"/>
+                    <a:lstStyle/>
+                    <a:p>
+                      <a:pPr>
+                        <a:defRPr sz="810">
+                          <a:solidFill>
+                            <a:srgbClr val="F7FAFC"/>
+                          </a:solidFill>
+                          <a:latin typeface="Aptos"/>
+                        </a:defRPr>
+                      </a:pPr>
+                      <a:r>
+                        <a:t>Define</a:t>
+                      </a:r>
+                    </a:p>
+                  </a:txBody>
+                  <a:tcPr marL="54864" marR="36576" marT="22860" marB="18288">
+                    <a:solidFill>
+                      <a:srgbClr val="14213D"/>
+                    </a:solidFill>
+                  </a:tcPr>
+                </a:tc>
+                <a:tc>
+                  <a:txBody>
+                    <a:bodyPr wrap="square" anchor="ctr"/>
+                    <a:lstStyle/>
+                    <a:p>
+                      <a:pPr>
+                        <a:defRPr sz="810">
+                          <a:solidFill>
+                            <a:srgbClr val="F7FAFC"/>
+                          </a:solidFill>
+                          <a:latin typeface="Aptos"/>
+                        </a:defRPr>
+                      </a:pPr>
+                      <a:r>
+                        <a:t>25%</a:t>
+                      </a:r>
+                    </a:p>
+                  </a:txBody>
+                  <a:tcPr marL="54864" marR="36576" marT="22860" marB="18288">
+                    <a:solidFill>
+                      <a:srgbClr val="14213D"/>
+                    </a:solidFill>
+                  </a:tcPr>
+                </a:tc>
+                <a:tc>
+                  <a:txBody>
+                    <a:bodyPr wrap="square" anchor="ctr"/>
+                    <a:lstStyle/>
+                    <a:p>
+                      <a:pPr>
+                        <a:defRPr sz="810">
+                          <a:solidFill>
+                            <a:srgbClr val="F7FAFC"/>
+                          </a:solidFill>
+                          <a:latin typeface="Aptos"/>
+                        </a:defRPr>
+                      </a:pPr>
+                      <a:r>
+                        <a:t>17 Mar 2027</a:t>
+                      </a:r>
+                    </a:p>
+                  </a:txBody>
+                  <a:tcPr marL="54864" marR="36576" marT="22860" marB="18288">
+                    <a:solidFill>
+                      <a:srgbClr val="14213D"/>
+                    </a:solidFill>
+                  </a:tcPr>
+                </a:tc>
+                <a:tc>
+                  <a:txBody>
+                    <a:bodyPr wrap="square" anchor="ctr"/>
+                    <a:lstStyle/>
+                    <a:p>
+                      <a:pPr>
+                        <a:defRPr sz="810">
+                          <a:solidFill>
+                            <a:srgbClr val="F7FAFC"/>
+                          </a:solidFill>
+                          <a:latin typeface="Aptos"/>
+                        </a:defRPr>
+                      </a:pPr>
+                      <a:r>
+                        <a:t>825K</a:t>
+                      </a:r>
+                    </a:p>
+                  </a:txBody>
+                  <a:tcPr marL="54864" marR="36576" marT="22860" marB="18288">
+                    <a:solidFill>
+                      <a:srgbClr val="14213D"/>
+                    </a:solidFill>
+                  </a:tcPr>
+                </a:tc>
+                <a:tc>
+                  <a:txBody>
+                    <a:bodyPr wrap="square" anchor="ctr"/>
+                    <a:lstStyle/>
+                    <a:p>
+                      <a:pPr>
+                        <a:defRPr sz="810">
+                          <a:solidFill>
+                            <a:srgbClr val="F7FAFC"/>
+                          </a:solidFill>
+                          <a:latin typeface="Aptos"/>
+                        </a:defRPr>
+                      </a:pPr>
+                      <a:r>
+                        <a:t>Freeze architecture/BOM and evaluation plan</a:t>
+                      </a:r>
+                    </a:p>
+                  </a:txBody>
+                  <a:tcPr marL="54864" marR="36576" marT="22860" marB="18288">
+                    <a:solidFill>
+                      <a:srgbClr val="14213D"/>
+                    </a:solidFill>
+                  </a:tcPr>
+                </a:tc>
+              </a:tr>
+              <a:tr h="562356">
+                <a:tc>
+                  <a:txBody>
+                    <a:bodyPr wrap="square" anchor="ctr"/>
+                    <a:lstStyle/>
+                    <a:p>
+                      <a:pPr>
+                        <a:defRPr sz="810">
+                          <a:solidFill>
+                            <a:srgbClr val="F7FAFC"/>
+                          </a:solidFill>
+                          <a:latin typeface="Aptos"/>
+                        </a:defRPr>
+                      </a:pPr>
+                      <a:r>
                         <a:t>4</a:t>
                       </a:r>
                     </a:p>
@@ -30191,7 +30191,7 @@
                         </a:defRPr>
                       </a:pPr>
                       <a:r>
-                        <a:t>Outdu</a:t>
+                        <a:t>Emerson</a:t>
                       </a:r>
                     </a:p>
                   </a:txBody>
@@ -30215,7 +30215,7 @@
                         </a:defRPr>
                       </a:pPr>
                       <a:r>
-                        <a:t>Long Range Tracking System</a:t>
+                        <a:t>RX3i CEP002</a:t>
                       </a:r>
                     </a:p>
                   </a:txBody>
@@ -30287,7 +30287,7 @@
                         </a:defRPr>
                       </a:pPr>
                       <a:r>
-                        <a:t>17 Mar 2027</a:t>
+                        <a:t>16 Dec 2026</a:t>
                       </a:r>
                     </a:p>
                   </a:txBody>
@@ -30311,7 +30311,7 @@
                         </a:defRPr>
                       </a:pPr>
                       <a:r>
-                        <a:t>825K</a:t>
+                        <a:t>775K</a:t>
                       </a:r>
                     </a:p>
                   </a:txBody>
@@ -30362,394 +30362,6 @@
                       </a:pPr>
                       <a:r>
                         <a:t>5</a:t>
-                      </a:r>
-                    </a:p>
-                  </a:txBody>
-                  <a:tcPr marL="54864" marR="36576" marT="22860" marB="18288">
-                    <a:solidFill>
-                      <a:srgbClr val="111C3A"/>
-                    </a:solidFill>
-                  </a:tcPr>
-                </a:tc>
-                <a:tc>
-                  <a:txBody>
-                    <a:bodyPr wrap="square" anchor="ctr"/>
-                    <a:lstStyle/>
-                    <a:p>
-                      <a:pPr>
-                        <a:defRPr sz="810">
-                          <a:solidFill>
-                            <a:srgbClr val="F7FAFC"/>
-                          </a:solidFill>
-                          <a:latin typeface="Aptos"/>
-                        </a:defRPr>
-                      </a:pPr>
-                      <a:r>
-                        <a:t>Emerson</a:t>
-                      </a:r>
-                    </a:p>
-                  </a:txBody>
-                  <a:tcPr marL="54864" marR="36576" marT="22860" marB="18288">
-                    <a:solidFill>
-                      <a:srgbClr val="111C3A"/>
-                    </a:solidFill>
-                  </a:tcPr>
-                </a:tc>
-                <a:tc>
-                  <a:txBody>
-                    <a:bodyPr wrap="square" anchor="ctr"/>
-                    <a:lstStyle/>
-                    <a:p>
-                      <a:pPr>
-                        <a:defRPr sz="810">
-                          <a:solidFill>
-                            <a:srgbClr val="F7FAFC"/>
-                          </a:solidFill>
-                          <a:latin typeface="Aptos"/>
-                        </a:defRPr>
-                      </a:pPr>
-                      <a:r>
-                        <a:t>RX3i CEP002</a:t>
-                      </a:r>
-                    </a:p>
-                  </a:txBody>
-                  <a:tcPr marL="54864" marR="36576" marT="22860" marB="18288">
-                    <a:solidFill>
-                      <a:srgbClr val="111C3A"/>
-                    </a:solidFill>
-                  </a:tcPr>
-                </a:tc>
-                <a:tc>
-                  <a:txBody>
-                    <a:bodyPr wrap="square" anchor="ctr"/>
-                    <a:lstStyle/>
-                    <a:p>
-                      <a:pPr>
-                        <a:defRPr sz="810">
-                          <a:solidFill>
-                            <a:srgbClr val="F7FAFC"/>
-                          </a:solidFill>
-                          <a:latin typeface="Aptos"/>
-                        </a:defRPr>
-                      </a:pPr>
-                      <a:r>
-                        <a:t>Define</a:t>
-                      </a:r>
-                    </a:p>
-                  </a:txBody>
-                  <a:tcPr marL="54864" marR="36576" marT="22860" marB="18288">
-                    <a:solidFill>
-                      <a:srgbClr val="111C3A"/>
-                    </a:solidFill>
-                  </a:tcPr>
-                </a:tc>
-                <a:tc>
-                  <a:txBody>
-                    <a:bodyPr wrap="square" anchor="ctr"/>
-                    <a:lstStyle/>
-                    <a:p>
-                      <a:pPr>
-                        <a:defRPr sz="810">
-                          <a:solidFill>
-                            <a:srgbClr val="F7FAFC"/>
-                          </a:solidFill>
-                          <a:latin typeface="Aptos"/>
-                        </a:defRPr>
-                      </a:pPr>
-                      <a:r>
-                        <a:t>25%</a:t>
-                      </a:r>
-                    </a:p>
-                  </a:txBody>
-                  <a:tcPr marL="54864" marR="36576" marT="22860" marB="18288">
-                    <a:solidFill>
-                      <a:srgbClr val="111C3A"/>
-                    </a:solidFill>
-                  </a:tcPr>
-                </a:tc>
-                <a:tc>
-                  <a:txBody>
-                    <a:bodyPr wrap="square" anchor="ctr"/>
-                    <a:lstStyle/>
-                    <a:p>
-                      <a:pPr>
-                        <a:defRPr sz="810">
-                          <a:solidFill>
-                            <a:srgbClr val="F7FAFC"/>
-                          </a:solidFill>
-                          <a:latin typeface="Aptos"/>
-                        </a:defRPr>
-                      </a:pPr>
-                      <a:r>
-                        <a:t>16 Dec 2026</a:t>
-                      </a:r>
-                    </a:p>
-                  </a:txBody>
-                  <a:tcPr marL="54864" marR="36576" marT="22860" marB="18288">
-                    <a:solidFill>
-                      <a:srgbClr val="111C3A"/>
-                    </a:solidFill>
-                  </a:tcPr>
-                </a:tc>
-                <a:tc>
-                  <a:txBody>
-                    <a:bodyPr wrap="square" anchor="ctr"/>
-                    <a:lstStyle/>
-                    <a:p>
-                      <a:pPr>
-                        <a:defRPr sz="810">
-                          <a:solidFill>
-                            <a:srgbClr val="F7FAFC"/>
-                          </a:solidFill>
-                          <a:latin typeface="Aptos"/>
-                        </a:defRPr>
-                      </a:pPr>
-                      <a:r>
-                        <a:t>775K</a:t>
-                      </a:r>
-                    </a:p>
-                  </a:txBody>
-                  <a:tcPr marL="54864" marR="36576" marT="22860" marB="18288">
-                    <a:solidFill>
-                      <a:srgbClr val="111C3A"/>
-                    </a:solidFill>
-                  </a:tcPr>
-                </a:tc>
-                <a:tc>
-                  <a:txBody>
-                    <a:bodyPr wrap="square" anchor="ctr"/>
-                    <a:lstStyle/>
-                    <a:p>
-                      <a:pPr>
-                        <a:defRPr sz="810">
-                          <a:solidFill>
-                            <a:srgbClr val="F7FAFC"/>
-                          </a:solidFill>
-                          <a:latin typeface="Aptos"/>
-                        </a:defRPr>
-                      </a:pPr>
-                      <a:r>
-                        <a:t>Freeze architecture/BOM and evaluation plan</a:t>
-                      </a:r>
-                    </a:p>
-                  </a:txBody>
-                  <a:tcPr marL="54864" marR="36576" marT="22860" marB="18288">
-                    <a:solidFill>
-                      <a:srgbClr val="111C3A"/>
-                    </a:solidFill>
-                  </a:tcPr>
-                </a:tc>
-              </a:tr>
-              <a:tr h="562356">
-                <a:tc>
-                  <a:txBody>
-                    <a:bodyPr wrap="square" anchor="ctr"/>
-                    <a:lstStyle/>
-                    <a:p>
-                      <a:pPr>
-                        <a:defRPr sz="810">
-                          <a:solidFill>
-                            <a:srgbClr val="F7FAFC"/>
-                          </a:solidFill>
-                          <a:latin typeface="Aptos"/>
-                        </a:defRPr>
-                      </a:pPr>
-                      <a:r>
-                        <a:t>6</a:t>
-                      </a:r>
-                    </a:p>
-                  </a:txBody>
-                  <a:tcPr marL="54864" marR="36576" marT="22860" marB="18288">
-                    <a:solidFill>
-                      <a:srgbClr val="152446"/>
-                    </a:solidFill>
-                  </a:tcPr>
-                </a:tc>
-                <a:tc>
-                  <a:txBody>
-                    <a:bodyPr wrap="square" anchor="ctr"/>
-                    <a:lstStyle/>
-                    <a:p>
-                      <a:pPr>
-                        <a:defRPr sz="810">
-                          <a:solidFill>
-                            <a:srgbClr val="F7FAFC"/>
-                          </a:solidFill>
-                          <a:latin typeface="Aptos"/>
-                        </a:defRPr>
-                      </a:pPr>
-                      <a:r>
-                        <a:t>Juniper</a:t>
-                      </a:r>
-                    </a:p>
-                  </a:txBody>
-                  <a:tcPr marL="54864" marR="36576" marT="22860" marB="18288">
-                    <a:solidFill>
-                      <a:srgbClr val="152446"/>
-                    </a:solidFill>
-                  </a:tcPr>
-                </a:tc>
-                <a:tc>
-                  <a:txBody>
-                    <a:bodyPr wrap="square" anchor="ctr"/>
-                    <a:lstStyle/>
-                    <a:p>
-                      <a:pPr>
-                        <a:defRPr sz="810">
-                          <a:solidFill>
-                            <a:srgbClr val="F7FAFC"/>
-                          </a:solidFill>
-                          <a:latin typeface="Aptos"/>
-                        </a:defRPr>
-                      </a:pPr>
-                      <a:r>
-                        <a:t>CPU Interface Card_PQC</a:t>
-                      </a:r>
-                    </a:p>
-                  </a:txBody>
-                  <a:tcPr marL="54864" marR="36576" marT="22860" marB="18288">
-                    <a:solidFill>
-                      <a:srgbClr val="152446"/>
-                    </a:solidFill>
-                  </a:tcPr>
-                </a:tc>
-                <a:tc>
-                  <a:txBody>
-                    <a:bodyPr wrap="square" anchor="ctr"/>
-                    <a:lstStyle/>
-                    <a:p>
-                      <a:pPr>
-                        <a:defRPr sz="810">
-                          <a:solidFill>
-                            <a:srgbClr val="F7FAFC"/>
-                          </a:solidFill>
-                          <a:latin typeface="Aptos"/>
-                        </a:defRPr>
-                      </a:pPr>
-                      <a:r>
-                        <a:t>Identify</a:t>
-                      </a:r>
-                    </a:p>
-                  </a:txBody>
-                  <a:tcPr marL="54864" marR="36576" marT="22860" marB="18288">
-                    <a:solidFill>
-                      <a:srgbClr val="152446"/>
-                    </a:solidFill>
-                  </a:tcPr>
-                </a:tc>
-                <a:tc>
-                  <a:txBody>
-                    <a:bodyPr wrap="square" anchor="ctr"/>
-                    <a:lstStyle/>
-                    <a:p>
-                      <a:pPr>
-                        <a:defRPr sz="810">
-                          <a:solidFill>
-                            <a:srgbClr val="F7FAFC"/>
-                          </a:solidFill>
-                          <a:latin typeface="Aptos"/>
-                        </a:defRPr>
-                      </a:pPr>
-                      <a:r>
-                        <a:t>0%</a:t>
-                      </a:r>
-                    </a:p>
-                  </a:txBody>
-                  <a:tcPr marL="54864" marR="36576" marT="22860" marB="18288">
-                    <a:solidFill>
-                      <a:srgbClr val="152446"/>
-                    </a:solidFill>
-                  </a:tcPr>
-                </a:tc>
-                <a:tc>
-                  <a:txBody>
-                    <a:bodyPr wrap="square" anchor="ctr"/>
-                    <a:lstStyle/>
-                    <a:p>
-                      <a:pPr>
-                        <a:defRPr sz="810">
-                          <a:solidFill>
-                            <a:srgbClr val="F7FAFC"/>
-                          </a:solidFill>
-                          <a:latin typeface="Aptos"/>
-                        </a:defRPr>
-                      </a:pPr>
-                      <a:r>
-                        <a:t>29 Dec 2027</a:t>
-                      </a:r>
-                    </a:p>
-                  </a:txBody>
-                  <a:tcPr marL="54864" marR="36576" marT="22860" marB="18288">
-                    <a:solidFill>
-                      <a:srgbClr val="152446"/>
-                    </a:solidFill>
-                  </a:tcPr>
-                </a:tc>
-                <a:tc>
-                  <a:txBody>
-                    <a:bodyPr wrap="square" anchor="ctr"/>
-                    <a:lstStyle/>
-                    <a:p>
-                      <a:pPr>
-                        <a:defRPr sz="810">
-                          <a:solidFill>
-                            <a:srgbClr val="F7FAFC"/>
-                          </a:solidFill>
-                          <a:latin typeface="Aptos"/>
-                        </a:defRPr>
-                      </a:pPr>
-                      <a:r>
-                        <a:t>600K</a:t>
-                      </a:r>
-                    </a:p>
-                  </a:txBody>
-                  <a:tcPr marL="54864" marR="36576" marT="22860" marB="18288">
-                    <a:solidFill>
-                      <a:srgbClr val="152446"/>
-                    </a:solidFill>
-                  </a:tcPr>
-                </a:tc>
-                <a:tc>
-                  <a:txBody>
-                    <a:bodyPr wrap="square" anchor="ctr"/>
-                    <a:lstStyle/>
-                    <a:p>
-                      <a:pPr>
-                        <a:defRPr sz="810">
-                          <a:solidFill>
-                            <a:srgbClr val="F7FAFC"/>
-                          </a:solidFill>
-                          <a:latin typeface="Aptos"/>
-                        </a:defRPr>
-                      </a:pPr>
-                      <a:r>
-                        <a:t>Qualify use case, sponsor, budget and 0→25% gate</a:t>
-                      </a:r>
-                    </a:p>
-                  </a:txBody>
-                  <a:tcPr marL="54864" marR="36576" marT="22860" marB="18288">
-                    <a:solidFill>
-                      <a:srgbClr val="152446"/>
-                    </a:solidFill>
-                  </a:tcPr>
-                </a:tc>
-              </a:tr>
-              <a:tr h="562356">
-                <a:tc>
-                  <a:txBody>
-                    <a:bodyPr wrap="square" anchor="ctr"/>
-                    <a:lstStyle/>
-                    <a:p>
-                      <a:pPr>
-                        <a:defRPr sz="810">
-                          <a:solidFill>
-                            <a:srgbClr val="F7FAFC"/>
-                          </a:solidFill>
-                          <a:latin typeface="Aptos"/>
-                        </a:defRPr>
-                      </a:pPr>
-                      <a:r>
-                        <a:t>7</a:t>
                       </a:r>
                     </a:p>
                   </a:txBody>
@@ -30928,6 +30540,394 @@
                   </a:tcPr>
                 </a:tc>
               </a:tr>
+              <a:tr h="562356">
+                <a:tc>
+                  <a:txBody>
+                    <a:bodyPr wrap="square" anchor="ctr"/>
+                    <a:lstStyle/>
+                    <a:p>
+                      <a:pPr>
+                        <a:defRPr sz="810">
+                          <a:solidFill>
+                            <a:srgbClr val="F7FAFC"/>
+                          </a:solidFill>
+                          <a:latin typeface="Aptos"/>
+                        </a:defRPr>
+                      </a:pPr>
+                      <a:r>
+                        <a:t>6</a:t>
+                      </a:r>
+                    </a:p>
+                  </a:txBody>
+                  <a:tcPr marL="54864" marR="36576" marT="22860" marB="18288">
+                    <a:solidFill>
+                      <a:srgbClr val="152446"/>
+                    </a:solidFill>
+                  </a:tcPr>
+                </a:tc>
+                <a:tc>
+                  <a:txBody>
+                    <a:bodyPr wrap="square" anchor="ctr"/>
+                    <a:lstStyle/>
+                    <a:p>
+                      <a:pPr>
+                        <a:defRPr sz="810">
+                          <a:solidFill>
+                            <a:srgbClr val="F7FAFC"/>
+                          </a:solidFill>
+                          <a:latin typeface="Aptos"/>
+                        </a:defRPr>
+                      </a:pPr>
+                      <a:r>
+                        <a:t>GE HealthCare</a:t>
+                      </a:r>
+                    </a:p>
+                  </a:txBody>
+                  <a:tcPr marL="54864" marR="36576" marT="22860" marB="18288">
+                    <a:solidFill>
+                      <a:srgbClr val="152446"/>
+                    </a:solidFill>
+                  </a:tcPr>
+                </a:tc>
+                <a:tc>
+                  <a:txBody>
+                    <a:bodyPr wrap="square" anchor="ctr"/>
+                    <a:lstStyle/>
+                    <a:p>
+                      <a:pPr>
+                        <a:defRPr sz="810">
+                          <a:solidFill>
+                            <a:srgbClr val="F7FAFC"/>
+                          </a:solidFill>
+                          <a:latin typeface="Aptos"/>
+                        </a:defRPr>
+                      </a:pPr>
+                      <a:r>
+                        <a:t>CT Scanner_DCB</a:t>
+                      </a:r>
+                    </a:p>
+                  </a:txBody>
+                  <a:tcPr marL="54864" marR="36576" marT="22860" marB="18288">
+                    <a:solidFill>
+                      <a:srgbClr val="152446"/>
+                    </a:solidFill>
+                  </a:tcPr>
+                </a:tc>
+                <a:tc>
+                  <a:txBody>
+                    <a:bodyPr wrap="square" anchor="ctr"/>
+                    <a:lstStyle/>
+                    <a:p>
+                      <a:pPr>
+                        <a:defRPr sz="810">
+                          <a:solidFill>
+                            <a:srgbClr val="F7FAFC"/>
+                          </a:solidFill>
+                          <a:latin typeface="Aptos"/>
+                        </a:defRPr>
+                      </a:pPr>
+                      <a:r>
+                        <a:t>Define</a:t>
+                      </a:r>
+                    </a:p>
+                  </a:txBody>
+                  <a:tcPr marL="54864" marR="36576" marT="22860" marB="18288">
+                    <a:solidFill>
+                      <a:srgbClr val="152446"/>
+                    </a:solidFill>
+                  </a:tcPr>
+                </a:tc>
+                <a:tc>
+                  <a:txBody>
+                    <a:bodyPr wrap="square" anchor="ctr"/>
+                    <a:lstStyle/>
+                    <a:p>
+                      <a:pPr>
+                        <a:defRPr sz="810">
+                          <a:solidFill>
+                            <a:srgbClr val="F7FAFC"/>
+                          </a:solidFill>
+                          <a:latin typeface="Aptos"/>
+                        </a:defRPr>
+                      </a:pPr>
+                      <a:r>
+                        <a:t>25%</a:t>
+                      </a:r>
+                    </a:p>
+                  </a:txBody>
+                  <a:tcPr marL="54864" marR="36576" marT="22860" marB="18288">
+                    <a:solidFill>
+                      <a:srgbClr val="152446"/>
+                    </a:solidFill>
+                  </a:tcPr>
+                </a:tc>
+                <a:tc>
+                  <a:txBody>
+                    <a:bodyPr wrap="square" anchor="ctr"/>
+                    <a:lstStyle/>
+                    <a:p>
+                      <a:pPr>
+                        <a:defRPr sz="810">
+                          <a:solidFill>
+                            <a:srgbClr val="F7FAFC"/>
+                          </a:solidFill>
+                          <a:latin typeface="Aptos"/>
+                        </a:defRPr>
+                      </a:pPr>
+                      <a:r>
+                        <a:t>07 Jul 2027</a:t>
+                      </a:r>
+                    </a:p>
+                  </a:txBody>
+                  <a:tcPr marL="54864" marR="36576" marT="22860" marB="18288">
+                    <a:solidFill>
+                      <a:srgbClr val="152446"/>
+                    </a:solidFill>
+                  </a:tcPr>
+                </a:tc>
+                <a:tc>
+                  <a:txBody>
+                    <a:bodyPr wrap="square" anchor="ctr"/>
+                    <a:lstStyle/>
+                    <a:p>
+                      <a:pPr>
+                        <a:defRPr sz="810">
+                          <a:solidFill>
+                            <a:srgbClr val="F7FAFC"/>
+                          </a:solidFill>
+                          <a:latin typeface="Aptos"/>
+                        </a:defRPr>
+                      </a:pPr>
+                      <a:r>
+                        <a:t>400K</a:t>
+                      </a:r>
+                    </a:p>
+                  </a:txBody>
+                  <a:tcPr marL="54864" marR="36576" marT="22860" marB="18288">
+                    <a:solidFill>
+                      <a:srgbClr val="152446"/>
+                    </a:solidFill>
+                  </a:tcPr>
+                </a:tc>
+                <a:tc>
+                  <a:txBody>
+                    <a:bodyPr wrap="square" anchor="ctr"/>
+                    <a:lstStyle/>
+                    <a:p>
+                      <a:pPr>
+                        <a:defRPr sz="810">
+                          <a:solidFill>
+                            <a:srgbClr val="F7FAFC"/>
+                          </a:solidFill>
+                          <a:latin typeface="Aptos"/>
+                        </a:defRPr>
+                      </a:pPr>
+                      <a:r>
+                        <a:t>Freeze architecture/BOM and evaluation plan</a:t>
+                      </a:r>
+                    </a:p>
+                  </a:txBody>
+                  <a:tcPr marL="54864" marR="36576" marT="22860" marB="18288">
+                    <a:solidFill>
+                      <a:srgbClr val="152446"/>
+                    </a:solidFill>
+                  </a:tcPr>
+                </a:tc>
+              </a:tr>
+              <a:tr h="562356">
+                <a:tc>
+                  <a:txBody>
+                    <a:bodyPr wrap="square" anchor="ctr"/>
+                    <a:lstStyle/>
+                    <a:p>
+                      <a:pPr>
+                        <a:defRPr sz="810">
+                          <a:solidFill>
+                            <a:srgbClr val="F7FAFC"/>
+                          </a:solidFill>
+                          <a:latin typeface="Aptos"/>
+                        </a:defRPr>
+                      </a:pPr>
+                      <a:r>
+                        <a:t>7</a:t>
+                      </a:r>
+                    </a:p>
+                  </a:txBody>
+                  <a:tcPr marL="54864" marR="36576" marT="22860" marB="18288">
+                    <a:solidFill>
+                      <a:srgbClr val="111C3A"/>
+                    </a:solidFill>
+                  </a:tcPr>
+                </a:tc>
+                <a:tc>
+                  <a:txBody>
+                    <a:bodyPr wrap="square" anchor="ctr"/>
+                    <a:lstStyle/>
+                    <a:p>
+                      <a:pPr>
+                        <a:defRPr sz="810">
+                          <a:solidFill>
+                            <a:srgbClr val="F7FAFC"/>
+                          </a:solidFill>
+                          <a:latin typeface="Aptos"/>
+                        </a:defRPr>
+                      </a:pPr>
+                      <a:r>
+                        <a:t>Philips</a:t>
+                      </a:r>
+                    </a:p>
+                  </a:txBody>
+                  <a:tcPr marL="54864" marR="36576" marT="22860" marB="18288">
+                    <a:solidFill>
+                      <a:srgbClr val="111C3A"/>
+                    </a:solidFill>
+                  </a:tcPr>
+                </a:tc>
+                <a:tc>
+                  <a:txBody>
+                    <a:bodyPr wrap="square" anchor="ctr"/>
+                    <a:lstStyle/>
+                    <a:p>
+                      <a:pPr>
+                        <a:defRPr sz="810">
+                          <a:solidFill>
+                            <a:srgbClr val="F7FAFC"/>
+                          </a:solidFill>
+                          <a:latin typeface="Aptos"/>
+                        </a:defRPr>
+                      </a:pPr>
+                      <a:r>
+                        <a:t>XSC/CT Scanner</a:t>
+                      </a:r>
+                    </a:p>
+                  </a:txBody>
+                  <a:tcPr marL="54864" marR="36576" marT="22860" marB="18288">
+                    <a:solidFill>
+                      <a:srgbClr val="111C3A"/>
+                    </a:solidFill>
+                  </a:tcPr>
+                </a:tc>
+                <a:tc>
+                  <a:txBody>
+                    <a:bodyPr wrap="square" anchor="ctr"/>
+                    <a:lstStyle/>
+                    <a:p>
+                      <a:pPr>
+                        <a:defRPr sz="810">
+                          <a:solidFill>
+                            <a:srgbClr val="F7FAFC"/>
+                          </a:solidFill>
+                          <a:latin typeface="Aptos"/>
+                        </a:defRPr>
+                      </a:pPr>
+                      <a:r>
+                        <a:t>Design</a:t>
+                      </a:r>
+                    </a:p>
+                  </a:txBody>
+                  <a:tcPr marL="54864" marR="36576" marT="22860" marB="18288">
+                    <a:solidFill>
+                      <a:srgbClr val="111C3A"/>
+                    </a:solidFill>
+                  </a:tcPr>
+                </a:tc>
+                <a:tc>
+                  <a:txBody>
+                    <a:bodyPr wrap="square" anchor="ctr"/>
+                    <a:lstStyle/>
+                    <a:p>
+                      <a:pPr>
+                        <a:defRPr sz="810">
+                          <a:solidFill>
+                            <a:srgbClr val="F7FAFC"/>
+                          </a:solidFill>
+                          <a:latin typeface="Aptos"/>
+                        </a:defRPr>
+                      </a:pPr>
+                      <a:r>
+                        <a:t>75%</a:t>
+                      </a:r>
+                    </a:p>
+                  </a:txBody>
+                  <a:tcPr marL="54864" marR="36576" marT="22860" marB="18288">
+                    <a:solidFill>
+                      <a:srgbClr val="111C3A"/>
+                    </a:solidFill>
+                  </a:tcPr>
+                </a:tc>
+                <a:tc>
+                  <a:txBody>
+                    <a:bodyPr wrap="square" anchor="ctr"/>
+                    <a:lstStyle/>
+                    <a:p>
+                      <a:pPr>
+                        <a:defRPr sz="810">
+                          <a:solidFill>
+                            <a:srgbClr val="F7FAFC"/>
+                          </a:solidFill>
+                          <a:latin typeface="Aptos"/>
+                        </a:defRPr>
+                      </a:pPr>
+                      <a:r>
+                        <a:t>11 Sep 2026</a:t>
+                      </a:r>
+                    </a:p>
+                  </a:txBody>
+                  <a:tcPr marL="54864" marR="36576" marT="22860" marB="18288">
+                    <a:solidFill>
+                      <a:srgbClr val="111C3A"/>
+                    </a:solidFill>
+                  </a:tcPr>
+                </a:tc>
+                <a:tc>
+                  <a:txBody>
+                    <a:bodyPr wrap="square" anchor="ctr"/>
+                    <a:lstStyle/>
+                    <a:p>
+                      <a:pPr>
+                        <a:defRPr sz="810">
+                          <a:solidFill>
+                            <a:srgbClr val="F7FAFC"/>
+                          </a:solidFill>
+                          <a:latin typeface="Aptos"/>
+                        </a:defRPr>
+                      </a:pPr>
+                      <a:r>
+                        <a:t>270K</a:t>
+                      </a:r>
+                    </a:p>
+                  </a:txBody>
+                  <a:tcPr marL="54864" marR="36576" marT="22860" marB="18288">
+                    <a:solidFill>
+                      <a:srgbClr val="111C3A"/>
+                    </a:solidFill>
+                  </a:tcPr>
+                </a:tc>
+                <a:tc>
+                  <a:txBody>
+                    <a:bodyPr wrap="square" anchor="ctr"/>
+                    <a:lstStyle/>
+                    <a:p>
+                      <a:pPr>
+                        <a:defRPr sz="810">
+                          <a:solidFill>
+                            <a:srgbClr val="F7FAFC"/>
+                          </a:solidFill>
+                          <a:latin typeface="Aptos"/>
+                        </a:defRPr>
+                      </a:pPr>
+                      <a:r>
+                        <a:t>Secure DW evidence and production handoff</a:t>
+                      </a:r>
+                    </a:p>
+                  </a:txBody>
+                  <a:tcPr marL="54864" marR="36576" marT="22860" marB="18288">
+                    <a:solidFill>
+                      <a:srgbClr val="111C3A"/>
+                    </a:solidFill>
+                  </a:tcPr>
+                </a:tc>
+              </a:tr>
             </a:tbl>
           </a:graphicData>
         </a:graphic>
@@ -30963,7 +30963,7 @@
               </a:defRPr>
             </a:pPr>
             <a:r>
-              <a:t>Ranks 1–3 contribute 67.9% of total peak value; weekly executive inspection is warranted.</a:t>
+              <a:t>Qualified ranks 1–3 contribute 71.2% of qualified open value; inspect weekly.</a:t>
             </a:r>
           </a:p>
         </p:txBody>
@@ -31061,7 +31061,7 @@
               </a:defRPr>
             </a:pPr>
             <a:r>
-              <a:t>Top opportunities 8–14: build breadth and add #15</a:t>
+              <a:t>Top 8–14: qualified open plus two Identify bets</a:t>
             </a:r>
           </a:p>
         </p:txBody>
@@ -31442,394 +31442,6 @@
                         </a:defRPr>
                       </a:pPr>
                       <a:r>
-                        <a:t>GE HealthCare</a:t>
-                      </a:r>
-                    </a:p>
-                  </a:txBody>
-                  <a:tcPr marL="54864" marR="36576" marT="22860" marB="18288">
-                    <a:solidFill>
-                      <a:srgbClr val="152446"/>
-                    </a:solidFill>
-                  </a:tcPr>
-                </a:tc>
-                <a:tc>
-                  <a:txBody>
-                    <a:bodyPr wrap="square" anchor="ctr"/>
-                    <a:lstStyle/>
-                    <a:p>
-                      <a:pPr>
-                        <a:defRPr sz="810">
-                          <a:solidFill>
-                            <a:srgbClr val="F7FAFC"/>
-                          </a:solidFill>
-                          <a:latin typeface="Aptos"/>
-                        </a:defRPr>
-                      </a:pPr>
-                      <a:r>
-                        <a:t>CT Scanner_DCB</a:t>
-                      </a:r>
-                    </a:p>
-                  </a:txBody>
-                  <a:tcPr marL="54864" marR="36576" marT="22860" marB="18288">
-                    <a:solidFill>
-                      <a:srgbClr val="152446"/>
-                    </a:solidFill>
-                  </a:tcPr>
-                </a:tc>
-                <a:tc>
-                  <a:txBody>
-                    <a:bodyPr wrap="square" anchor="ctr"/>
-                    <a:lstStyle/>
-                    <a:p>
-                      <a:pPr>
-                        <a:defRPr sz="810">
-                          <a:solidFill>
-                            <a:srgbClr val="F7FAFC"/>
-                          </a:solidFill>
-                          <a:latin typeface="Aptos"/>
-                        </a:defRPr>
-                      </a:pPr>
-                      <a:r>
-                        <a:t>Define</a:t>
-                      </a:r>
-                    </a:p>
-                  </a:txBody>
-                  <a:tcPr marL="54864" marR="36576" marT="22860" marB="18288">
-                    <a:solidFill>
-                      <a:srgbClr val="152446"/>
-                    </a:solidFill>
-                  </a:tcPr>
-                </a:tc>
-                <a:tc>
-                  <a:txBody>
-                    <a:bodyPr wrap="square" anchor="ctr"/>
-                    <a:lstStyle/>
-                    <a:p>
-                      <a:pPr>
-                        <a:defRPr sz="810">
-                          <a:solidFill>
-                            <a:srgbClr val="F7FAFC"/>
-                          </a:solidFill>
-                          <a:latin typeface="Aptos"/>
-                        </a:defRPr>
-                      </a:pPr>
-                      <a:r>
-                        <a:t>25%</a:t>
-                      </a:r>
-                    </a:p>
-                  </a:txBody>
-                  <a:tcPr marL="54864" marR="36576" marT="22860" marB="18288">
-                    <a:solidFill>
-                      <a:srgbClr val="152446"/>
-                    </a:solidFill>
-                  </a:tcPr>
-                </a:tc>
-                <a:tc>
-                  <a:txBody>
-                    <a:bodyPr wrap="square" anchor="ctr"/>
-                    <a:lstStyle/>
-                    <a:p>
-                      <a:pPr>
-                        <a:defRPr sz="810">
-                          <a:solidFill>
-                            <a:srgbClr val="F7FAFC"/>
-                          </a:solidFill>
-                          <a:latin typeface="Aptos"/>
-                        </a:defRPr>
-                      </a:pPr>
-                      <a:r>
-                        <a:t>07 Jul 2027</a:t>
-                      </a:r>
-                    </a:p>
-                  </a:txBody>
-                  <a:tcPr marL="54864" marR="36576" marT="22860" marB="18288">
-                    <a:solidFill>
-                      <a:srgbClr val="152446"/>
-                    </a:solidFill>
-                  </a:tcPr>
-                </a:tc>
-                <a:tc>
-                  <a:txBody>
-                    <a:bodyPr wrap="square" anchor="ctr"/>
-                    <a:lstStyle/>
-                    <a:p>
-                      <a:pPr>
-                        <a:defRPr sz="810">
-                          <a:solidFill>
-                            <a:srgbClr val="F7FAFC"/>
-                          </a:solidFill>
-                          <a:latin typeface="Aptos"/>
-                        </a:defRPr>
-                      </a:pPr>
-                      <a:r>
-                        <a:t>400K</a:t>
-                      </a:r>
-                    </a:p>
-                  </a:txBody>
-                  <a:tcPr marL="54864" marR="36576" marT="22860" marB="18288">
-                    <a:solidFill>
-                      <a:srgbClr val="152446"/>
-                    </a:solidFill>
-                  </a:tcPr>
-                </a:tc>
-                <a:tc>
-                  <a:txBody>
-                    <a:bodyPr wrap="square" anchor="ctr"/>
-                    <a:lstStyle/>
-                    <a:p>
-                      <a:pPr>
-                        <a:defRPr sz="810">
-                          <a:solidFill>
-                            <a:srgbClr val="F7FAFC"/>
-                          </a:solidFill>
-                          <a:latin typeface="Aptos"/>
-                        </a:defRPr>
-                      </a:pPr>
-                      <a:r>
-                        <a:t>Freeze architecture/BOM and evaluation plan</a:t>
-                      </a:r>
-                    </a:p>
-                  </a:txBody>
-                  <a:tcPr marL="54864" marR="36576" marT="22860" marB="18288">
-                    <a:solidFill>
-                      <a:srgbClr val="152446"/>
-                    </a:solidFill>
-                  </a:tcPr>
-                </a:tc>
-              </a:tr>
-              <a:tr h="499872">
-                <a:tc>
-                  <a:txBody>
-                    <a:bodyPr wrap="square" anchor="ctr"/>
-                    <a:lstStyle/>
-                    <a:p>
-                      <a:pPr>
-                        <a:defRPr sz="810">
-                          <a:solidFill>
-                            <a:srgbClr val="F7FAFC"/>
-                          </a:solidFill>
-                          <a:latin typeface="Aptos"/>
-                        </a:defRPr>
-                      </a:pPr>
-                      <a:r>
-                        <a:t>9</a:t>
-                      </a:r>
-                    </a:p>
-                  </a:txBody>
-                  <a:tcPr marL="54864" marR="36576" marT="22860" marB="18288">
-                    <a:solidFill>
-                      <a:srgbClr val="111C3A"/>
-                    </a:solidFill>
-                  </a:tcPr>
-                </a:tc>
-                <a:tc>
-                  <a:txBody>
-                    <a:bodyPr wrap="square" anchor="ctr"/>
-                    <a:lstStyle/>
-                    <a:p>
-                      <a:pPr>
-                        <a:defRPr sz="810">
-                          <a:solidFill>
-                            <a:srgbClr val="F7FAFC"/>
-                          </a:solidFill>
-                          <a:latin typeface="Aptos"/>
-                        </a:defRPr>
-                      </a:pPr>
-                      <a:r>
-                        <a:t>Philips</a:t>
-                      </a:r>
-                    </a:p>
-                  </a:txBody>
-                  <a:tcPr marL="54864" marR="36576" marT="22860" marB="18288">
-                    <a:solidFill>
-                      <a:srgbClr val="111C3A"/>
-                    </a:solidFill>
-                  </a:tcPr>
-                </a:tc>
-                <a:tc>
-                  <a:txBody>
-                    <a:bodyPr wrap="square" anchor="ctr"/>
-                    <a:lstStyle/>
-                    <a:p>
-                      <a:pPr>
-                        <a:defRPr sz="810">
-                          <a:solidFill>
-                            <a:srgbClr val="F7FAFC"/>
-                          </a:solidFill>
-                          <a:latin typeface="Aptos"/>
-                        </a:defRPr>
-                      </a:pPr>
-                      <a:r>
-                        <a:t>XSC/CT Scanner</a:t>
-                      </a:r>
-                    </a:p>
-                  </a:txBody>
-                  <a:tcPr marL="54864" marR="36576" marT="22860" marB="18288">
-                    <a:solidFill>
-                      <a:srgbClr val="111C3A"/>
-                    </a:solidFill>
-                  </a:tcPr>
-                </a:tc>
-                <a:tc>
-                  <a:txBody>
-                    <a:bodyPr wrap="square" anchor="ctr"/>
-                    <a:lstStyle/>
-                    <a:p>
-                      <a:pPr>
-                        <a:defRPr sz="810">
-                          <a:solidFill>
-                            <a:srgbClr val="F7FAFC"/>
-                          </a:solidFill>
-                          <a:latin typeface="Aptos"/>
-                        </a:defRPr>
-                      </a:pPr>
-                      <a:r>
-                        <a:t>Design</a:t>
-                      </a:r>
-                    </a:p>
-                  </a:txBody>
-                  <a:tcPr marL="54864" marR="36576" marT="22860" marB="18288">
-                    <a:solidFill>
-                      <a:srgbClr val="111C3A"/>
-                    </a:solidFill>
-                  </a:tcPr>
-                </a:tc>
-                <a:tc>
-                  <a:txBody>
-                    <a:bodyPr wrap="square" anchor="ctr"/>
-                    <a:lstStyle/>
-                    <a:p>
-                      <a:pPr>
-                        <a:defRPr sz="810">
-                          <a:solidFill>
-                            <a:srgbClr val="F7FAFC"/>
-                          </a:solidFill>
-                          <a:latin typeface="Aptos"/>
-                        </a:defRPr>
-                      </a:pPr>
-                      <a:r>
-                        <a:t>75%</a:t>
-                      </a:r>
-                    </a:p>
-                  </a:txBody>
-                  <a:tcPr marL="54864" marR="36576" marT="22860" marB="18288">
-                    <a:solidFill>
-                      <a:srgbClr val="111C3A"/>
-                    </a:solidFill>
-                  </a:tcPr>
-                </a:tc>
-                <a:tc>
-                  <a:txBody>
-                    <a:bodyPr wrap="square" anchor="ctr"/>
-                    <a:lstStyle/>
-                    <a:p>
-                      <a:pPr>
-                        <a:defRPr sz="810">
-                          <a:solidFill>
-                            <a:srgbClr val="F7FAFC"/>
-                          </a:solidFill>
-                          <a:latin typeface="Aptos"/>
-                        </a:defRPr>
-                      </a:pPr>
-                      <a:r>
-                        <a:t>11 Sep 2026</a:t>
-                      </a:r>
-                    </a:p>
-                  </a:txBody>
-                  <a:tcPr marL="54864" marR="36576" marT="22860" marB="18288">
-                    <a:solidFill>
-                      <a:srgbClr val="111C3A"/>
-                    </a:solidFill>
-                  </a:tcPr>
-                </a:tc>
-                <a:tc>
-                  <a:txBody>
-                    <a:bodyPr wrap="square" anchor="ctr"/>
-                    <a:lstStyle/>
-                    <a:p>
-                      <a:pPr>
-                        <a:defRPr sz="810">
-                          <a:solidFill>
-                            <a:srgbClr val="F7FAFC"/>
-                          </a:solidFill>
-                          <a:latin typeface="Aptos"/>
-                        </a:defRPr>
-                      </a:pPr>
-                      <a:r>
-                        <a:t>270K</a:t>
-                      </a:r>
-                    </a:p>
-                  </a:txBody>
-                  <a:tcPr marL="54864" marR="36576" marT="22860" marB="18288">
-                    <a:solidFill>
-                      <a:srgbClr val="111C3A"/>
-                    </a:solidFill>
-                  </a:tcPr>
-                </a:tc>
-                <a:tc>
-                  <a:txBody>
-                    <a:bodyPr wrap="square" anchor="ctr"/>
-                    <a:lstStyle/>
-                    <a:p>
-                      <a:pPr>
-                        <a:defRPr sz="810">
-                          <a:solidFill>
-                            <a:srgbClr val="F7FAFC"/>
-                          </a:solidFill>
-                          <a:latin typeface="Aptos"/>
-                        </a:defRPr>
-                      </a:pPr>
-                      <a:r>
-                        <a:t>Secure DW evidence and production handoff</a:t>
-                      </a:r>
-                    </a:p>
-                  </a:txBody>
-                  <a:tcPr marL="54864" marR="36576" marT="22860" marB="18288">
-                    <a:solidFill>
-                      <a:srgbClr val="111C3A"/>
-                    </a:solidFill>
-                  </a:tcPr>
-                </a:tc>
-              </a:tr>
-              <a:tr h="499872">
-                <a:tc>
-                  <a:txBody>
-                    <a:bodyPr wrap="square" anchor="ctr"/>
-                    <a:lstStyle/>
-                    <a:p>
-                      <a:pPr>
-                        <a:defRPr sz="810">
-                          <a:solidFill>
-                            <a:srgbClr val="F7FAFC"/>
-                          </a:solidFill>
-                          <a:latin typeface="Aptos"/>
-                        </a:defRPr>
-                      </a:pPr>
-                      <a:r>
-                        <a:t>10</a:t>
-                      </a:r>
-                    </a:p>
-                  </a:txBody>
-                  <a:tcPr marL="54864" marR="36576" marT="22860" marB="18288">
-                    <a:solidFill>
-                      <a:srgbClr val="152446"/>
-                    </a:solidFill>
-                  </a:tcPr>
-                </a:tc>
-                <a:tc>
-                  <a:txBody>
-                    <a:bodyPr wrap="square" anchor="ctr"/>
-                    <a:lstStyle/>
-                    <a:p>
-                      <a:pPr>
-                        <a:defRPr sz="810">
-                          <a:solidFill>
-                            <a:srgbClr val="F7FAFC"/>
-                          </a:solidFill>
-                          <a:latin typeface="Aptos"/>
-                        </a:defRPr>
-                      </a:pPr>
-                      <a:r>
                         <a:t>Honeywell Tech.</a:t>
                       </a:r>
                     </a:p>
@@ -32000,7 +31612,7 @@
                         </a:defRPr>
                       </a:pPr>
                       <a:r>
-                        <a:t>11</a:t>
+                        <a:t>9</a:t>
                       </a:r>
                     </a:p>
                   </a:txBody>
@@ -32194,7 +31806,7 @@
                         </a:defRPr>
                       </a:pPr>
                       <a:r>
-                        <a:t>12</a:t>
+                        <a:t>10</a:t>
                       </a:r>
                     </a:p>
                   </a:txBody>
@@ -32388,7 +32000,7 @@
                         </a:defRPr>
                       </a:pPr>
                       <a:r>
-                        <a:t>13</a:t>
+                        <a:t>11</a:t>
                       </a:r>
                     </a:p>
                   </a:txBody>
@@ -32582,7 +32194,7 @@
                         </a:defRPr>
                       </a:pPr>
                       <a:r>
-                        <a:t>14</a:t>
+                        <a:t>12</a:t>
                       </a:r>
                     </a:p>
                   </a:txBody>
@@ -32757,6 +32369,394 @@
                   <a:tcPr marL="54864" marR="36576" marT="22860" marB="18288">
                     <a:solidFill>
                       <a:srgbClr val="152446"/>
+                    </a:solidFill>
+                  </a:tcPr>
+                </a:tc>
+              </a:tr>
+              <a:tr h="499872">
+                <a:tc>
+                  <a:txBody>
+                    <a:bodyPr wrap="square" anchor="ctr"/>
+                    <a:lstStyle/>
+                    <a:p>
+                      <a:pPr>
+                        <a:defRPr sz="810">
+                          <a:solidFill>
+                            <a:srgbClr val="F7FAFC"/>
+                          </a:solidFill>
+                          <a:latin typeface="Aptos"/>
+                        </a:defRPr>
+                      </a:pPr>
+                      <a:r>
+                        <a:t>13</a:t>
+                      </a:r>
+                    </a:p>
+                  </a:txBody>
+                  <a:tcPr marL="54864" marR="36576" marT="22860" marB="18288">
+                    <a:solidFill>
+                      <a:srgbClr val="3B1D28"/>
+                    </a:solidFill>
+                  </a:tcPr>
+                </a:tc>
+                <a:tc>
+                  <a:txBody>
+                    <a:bodyPr wrap="square" anchor="ctr"/>
+                    <a:lstStyle/>
+                    <a:p>
+                      <a:pPr>
+                        <a:defRPr sz="810">
+                          <a:solidFill>
+                            <a:srgbClr val="F7FAFC"/>
+                          </a:solidFill>
+                          <a:latin typeface="Aptos"/>
+                        </a:defRPr>
+                      </a:pPr>
+                      <a:r>
+                        <a:t>Honeywell Aerospace</a:t>
+                      </a:r>
+                    </a:p>
+                  </a:txBody>
+                  <a:tcPr marL="54864" marR="36576" marT="22860" marB="18288">
+                    <a:solidFill>
+                      <a:srgbClr val="3B1D28"/>
+                    </a:solidFill>
+                  </a:tcPr>
+                </a:tc>
+                <a:tc>
+                  <a:txBody>
+                    <a:bodyPr wrap="square" anchor="ctr"/>
+                    <a:lstStyle/>
+                    <a:p>
+                      <a:pPr>
+                        <a:defRPr sz="810">
+                          <a:solidFill>
+                            <a:srgbClr val="F7FAFC"/>
+                          </a:solidFill>
+                          <a:latin typeface="Aptos"/>
+                        </a:defRPr>
+                      </a:pPr>
+                      <a:r>
+                        <a:t>Weather Monitoring Radar</a:t>
+                      </a:r>
+                    </a:p>
+                  </a:txBody>
+                  <a:tcPr marL="54864" marR="36576" marT="22860" marB="18288">
+                    <a:solidFill>
+                      <a:srgbClr val="3B1D28"/>
+                    </a:solidFill>
+                  </a:tcPr>
+                </a:tc>
+                <a:tc>
+                  <a:txBody>
+                    <a:bodyPr wrap="square" anchor="ctr"/>
+                    <a:lstStyle/>
+                    <a:p>
+                      <a:pPr>
+                        <a:defRPr sz="810">
+                          <a:solidFill>
+                            <a:srgbClr val="F7FAFC"/>
+                          </a:solidFill>
+                          <a:latin typeface="Aptos"/>
+                        </a:defRPr>
+                      </a:pPr>
+                      <a:r>
+                        <a:t>Identify</a:t>
+                      </a:r>
+                    </a:p>
+                  </a:txBody>
+                  <a:tcPr marL="54864" marR="36576" marT="22860" marB="18288">
+                    <a:solidFill>
+                      <a:srgbClr val="3B1D28"/>
+                    </a:solidFill>
+                  </a:tcPr>
+                </a:tc>
+                <a:tc>
+                  <a:txBody>
+                    <a:bodyPr wrap="square" anchor="ctr"/>
+                    <a:lstStyle/>
+                    <a:p>
+                      <a:pPr>
+                        <a:defRPr sz="810">
+                          <a:solidFill>
+                            <a:srgbClr val="F7FAFC"/>
+                          </a:solidFill>
+                          <a:latin typeface="Aptos"/>
+                        </a:defRPr>
+                      </a:pPr>
+                      <a:r>
+                        <a:t>0%</a:t>
+                      </a:r>
+                    </a:p>
+                  </a:txBody>
+                  <a:tcPr marL="54864" marR="36576" marT="22860" marB="18288">
+                    <a:solidFill>
+                      <a:srgbClr val="3B1D28"/>
+                    </a:solidFill>
+                  </a:tcPr>
+                </a:tc>
+                <a:tc>
+                  <a:txBody>
+                    <a:bodyPr wrap="square" anchor="ctr"/>
+                    <a:lstStyle/>
+                    <a:p>
+                      <a:pPr>
+                        <a:defRPr sz="810">
+                          <a:solidFill>
+                            <a:srgbClr val="F7FAFC"/>
+                          </a:solidFill>
+                          <a:latin typeface="Aptos"/>
+                        </a:defRPr>
+                      </a:pPr>
+                      <a:r>
+                        <a:t>24 Nov 2027</a:t>
+                      </a:r>
+                    </a:p>
+                  </a:txBody>
+                  <a:tcPr marL="54864" marR="36576" marT="22860" marB="18288">
+                    <a:solidFill>
+                      <a:srgbClr val="3B1D28"/>
+                    </a:solidFill>
+                  </a:tcPr>
+                </a:tc>
+                <a:tc>
+                  <a:txBody>
+                    <a:bodyPr wrap="square" anchor="ctr"/>
+                    <a:lstStyle/>
+                    <a:p>
+                      <a:pPr>
+                        <a:defRPr sz="810">
+                          <a:solidFill>
+                            <a:srgbClr val="F7FAFC"/>
+                          </a:solidFill>
+                          <a:latin typeface="Aptos"/>
+                        </a:defRPr>
+                      </a:pPr>
+                      <a:r>
+                        <a:t>3.00M</a:t>
+                      </a:r>
+                    </a:p>
+                  </a:txBody>
+                  <a:tcPr marL="54864" marR="36576" marT="22860" marB="18288">
+                    <a:solidFill>
+                      <a:srgbClr val="3B1D28"/>
+                    </a:solidFill>
+                  </a:tcPr>
+                </a:tc>
+                <a:tc>
+                  <a:txBody>
+                    <a:bodyPr wrap="square" anchor="ctr"/>
+                    <a:lstStyle/>
+                    <a:p>
+                      <a:pPr>
+                        <a:defRPr sz="810">
+                          <a:solidFill>
+                            <a:srgbClr val="F7FAFC"/>
+                          </a:solidFill>
+                          <a:latin typeface="Aptos"/>
+                        </a:defRPr>
+                      </a:pPr>
+                      <a:r>
+                        <a:t>Qualify use case, sponsor, budget and 0→25% gate</a:t>
+                      </a:r>
+                    </a:p>
+                  </a:txBody>
+                  <a:tcPr marL="54864" marR="36576" marT="22860" marB="18288">
+                    <a:solidFill>
+                      <a:srgbClr val="3B1D28"/>
+                    </a:solidFill>
+                  </a:tcPr>
+                </a:tc>
+              </a:tr>
+              <a:tr h="499872">
+                <a:tc>
+                  <a:txBody>
+                    <a:bodyPr wrap="square" anchor="ctr"/>
+                    <a:lstStyle/>
+                    <a:p>
+                      <a:pPr>
+                        <a:defRPr sz="810">
+                          <a:solidFill>
+                            <a:srgbClr val="F7FAFC"/>
+                          </a:solidFill>
+                          <a:latin typeface="Aptos"/>
+                        </a:defRPr>
+                      </a:pPr>
+                      <a:r>
+                        <a:t>14</a:t>
+                      </a:r>
+                    </a:p>
+                  </a:txBody>
+                  <a:tcPr marL="54864" marR="36576" marT="22860" marB="18288">
+                    <a:solidFill>
+                      <a:srgbClr val="3B1D28"/>
+                    </a:solidFill>
+                  </a:tcPr>
+                </a:tc>
+                <a:tc>
+                  <a:txBody>
+                    <a:bodyPr wrap="square" anchor="ctr"/>
+                    <a:lstStyle/>
+                    <a:p>
+                      <a:pPr>
+                        <a:defRPr sz="810">
+                          <a:solidFill>
+                            <a:srgbClr val="F7FAFC"/>
+                          </a:solidFill>
+                          <a:latin typeface="Aptos"/>
+                        </a:defRPr>
+                      </a:pPr>
+                      <a:r>
+                        <a:t>Juniper</a:t>
+                      </a:r>
+                    </a:p>
+                  </a:txBody>
+                  <a:tcPr marL="54864" marR="36576" marT="22860" marB="18288">
+                    <a:solidFill>
+                      <a:srgbClr val="3B1D28"/>
+                    </a:solidFill>
+                  </a:tcPr>
+                </a:tc>
+                <a:tc>
+                  <a:txBody>
+                    <a:bodyPr wrap="square" anchor="ctr"/>
+                    <a:lstStyle/>
+                    <a:p>
+                      <a:pPr>
+                        <a:defRPr sz="810">
+                          <a:solidFill>
+                            <a:srgbClr val="F7FAFC"/>
+                          </a:solidFill>
+                          <a:latin typeface="Aptos"/>
+                        </a:defRPr>
+                      </a:pPr>
+                      <a:r>
+                        <a:t>CPU Interface Card_PQC</a:t>
+                      </a:r>
+                    </a:p>
+                  </a:txBody>
+                  <a:tcPr marL="54864" marR="36576" marT="22860" marB="18288">
+                    <a:solidFill>
+                      <a:srgbClr val="3B1D28"/>
+                    </a:solidFill>
+                  </a:tcPr>
+                </a:tc>
+                <a:tc>
+                  <a:txBody>
+                    <a:bodyPr wrap="square" anchor="ctr"/>
+                    <a:lstStyle/>
+                    <a:p>
+                      <a:pPr>
+                        <a:defRPr sz="810">
+                          <a:solidFill>
+                            <a:srgbClr val="F7FAFC"/>
+                          </a:solidFill>
+                          <a:latin typeface="Aptos"/>
+                        </a:defRPr>
+                      </a:pPr>
+                      <a:r>
+                        <a:t>Identify</a:t>
+                      </a:r>
+                    </a:p>
+                  </a:txBody>
+                  <a:tcPr marL="54864" marR="36576" marT="22860" marB="18288">
+                    <a:solidFill>
+                      <a:srgbClr val="3B1D28"/>
+                    </a:solidFill>
+                  </a:tcPr>
+                </a:tc>
+                <a:tc>
+                  <a:txBody>
+                    <a:bodyPr wrap="square" anchor="ctr"/>
+                    <a:lstStyle/>
+                    <a:p>
+                      <a:pPr>
+                        <a:defRPr sz="810">
+                          <a:solidFill>
+                            <a:srgbClr val="F7FAFC"/>
+                          </a:solidFill>
+                          <a:latin typeface="Aptos"/>
+                        </a:defRPr>
+                      </a:pPr>
+                      <a:r>
+                        <a:t>0%</a:t>
+                      </a:r>
+                    </a:p>
+                  </a:txBody>
+                  <a:tcPr marL="54864" marR="36576" marT="22860" marB="18288">
+                    <a:solidFill>
+                      <a:srgbClr val="3B1D28"/>
+                    </a:solidFill>
+                  </a:tcPr>
+                </a:tc>
+                <a:tc>
+                  <a:txBody>
+                    <a:bodyPr wrap="square" anchor="ctr"/>
+                    <a:lstStyle/>
+                    <a:p>
+                      <a:pPr>
+                        <a:defRPr sz="810">
+                          <a:solidFill>
+                            <a:srgbClr val="F7FAFC"/>
+                          </a:solidFill>
+                          <a:latin typeface="Aptos"/>
+                        </a:defRPr>
+                      </a:pPr>
+                      <a:r>
+                        <a:t>29 Dec 2027</a:t>
+                      </a:r>
+                    </a:p>
+                  </a:txBody>
+                  <a:tcPr marL="54864" marR="36576" marT="22860" marB="18288">
+                    <a:solidFill>
+                      <a:srgbClr val="3B1D28"/>
+                    </a:solidFill>
+                  </a:tcPr>
+                </a:tc>
+                <a:tc>
+                  <a:txBody>
+                    <a:bodyPr wrap="square" anchor="ctr"/>
+                    <a:lstStyle/>
+                    <a:p>
+                      <a:pPr>
+                        <a:defRPr sz="810">
+                          <a:solidFill>
+                            <a:srgbClr val="F7FAFC"/>
+                          </a:solidFill>
+                          <a:latin typeface="Aptos"/>
+                        </a:defRPr>
+                      </a:pPr>
+                      <a:r>
+                        <a:t>600K</a:t>
+                      </a:r>
+                    </a:p>
+                  </a:txBody>
+                  <a:tcPr marL="54864" marR="36576" marT="22860" marB="18288">
+                    <a:solidFill>
+                      <a:srgbClr val="3B1D28"/>
+                    </a:solidFill>
+                  </a:tcPr>
+                </a:tc>
+                <a:tc>
+                  <a:txBody>
+                    <a:bodyPr wrap="square" anchor="ctr"/>
+                    <a:lstStyle/>
+                    <a:p>
+                      <a:pPr>
+                        <a:defRPr sz="810">
+                          <a:solidFill>
+                            <a:srgbClr val="F7FAFC"/>
+                          </a:solidFill>
+                          <a:latin typeface="Aptos"/>
+                        </a:defRPr>
+                      </a:pPr>
+                      <a:r>
+                        <a:t>Qualify use case, sponsor, budget and 0→25% gate</a:t>
+                      </a:r>
+                    </a:p>
+                  </a:txBody>
+                  <a:tcPr marL="54864" marR="36576" marT="22860" marB="18288">
+                    <a:solidFill>
+                      <a:srgbClr val="3B1D28"/>
                     </a:solidFill>
                   </a:tcPr>
                 </a:tc>
@@ -32990,7 +32990,7 @@
               </a:defRPr>
             </a:pPr>
             <a:r>
-              <a:t>The source contains 14 distinct Sahil opportunities—not 15. Use the open slot to create, qualify and name the next strategic play.</a:t>
+              <a:t>Ranks 13–14 are 0% Identify plays outside both open exports; slot 15 remains a new qualified creation commitment.</a:t>
             </a:r>
           </a:p>
         </p:txBody>
@@ -33088,7 +33088,7 @@
               </a:defRPr>
             </a:pPr>
             <a:r>
-              <a:t>Customer portfolio: Outdu and Honeywell Aerospace dominate peak value</a:t>
+              <a:t>Qualified customer portfolio: Outdu is 60% of open value</a:t>
             </a:r>
           </a:p>
         </p:txBody>
@@ -33471,7 +33471,7 @@
               </a:defRPr>
             </a:pPr>
             <a:r>
-              <a:t>Honeywell Aerospace</a:t>
+              <a:t>GE HealthCare</a:t>
             </a:r>
           </a:p>
         </p:txBody>
@@ -33530,7 +33530,7 @@
         <p:spPr>
           <a:xfrm>
             <a:off x="2148840" y="1911095"/>
-            <a:ext cx="2909454" cy="310896"/>
+            <a:ext cx="979560" cy="310896"/>
           </a:xfrm>
           <a:prstGeom prst="rect">
             <a:avLst/>
@@ -33595,7 +33595,7 @@
               </a:defRPr>
             </a:pPr>
             <a:r>
-              <a:t>3.00M</a:t>
+              <a:t>1.01M</a:t>
             </a:r>
           </a:p>
         </p:txBody>
@@ -33631,7 +33631,7 @@
               </a:defRPr>
             </a:pPr>
             <a:r>
-              <a:t>W 0</a:t>
+              <a:t>W 242K</a:t>
             </a:r>
           </a:p>
         </p:txBody>
@@ -33667,7 +33667,7 @@
               </a:defRPr>
             </a:pPr>
             <a:r>
-              <a:t>1 opps</a:t>
+              <a:t>3 opps</a:t>
             </a:r>
           </a:p>
         </p:txBody>
@@ -33762,7 +33762,7 @@
         <p:spPr>
           <a:xfrm>
             <a:off x="2148840" y="2542032"/>
-            <a:ext cx="1454727" cy="310896"/>
+            <a:ext cx="872836" cy="310896"/>
           </a:xfrm>
           <a:prstGeom prst="rect">
             <a:avLst/>
@@ -33827,7 +33827,7 @@
               </a:defRPr>
             </a:pPr>
             <a:r>
-              <a:t>1.50M</a:t>
+              <a:t>900K</a:t>
             </a:r>
           </a:p>
         </p:txBody>
@@ -33899,7 +33899,7 @@
               </a:defRPr>
             </a:pPr>
             <a:r>
-              <a:t>2 opps</a:t>
+              <a:t>1 opps</a:t>
             </a:r>
           </a:p>
         </p:txBody>
@@ -33935,7 +33935,7 @@
               </a:defRPr>
             </a:pPr>
             <a:r>
-              <a:t>GE HealthCare</a:t>
+              <a:t>Emerson</a:t>
             </a:r>
           </a:p>
         </p:txBody>
@@ -33994,7 +33994,7 @@
         <p:spPr>
           <a:xfrm>
             <a:off x="2148840" y="3172968"/>
-            <a:ext cx="979560" cy="310896"/>
+            <a:ext cx="751609" cy="310896"/>
           </a:xfrm>
           <a:prstGeom prst="rect">
             <a:avLst/>
@@ -34059,7 +34059,7 @@
               </a:defRPr>
             </a:pPr>
             <a:r>
-              <a:t>1.01M</a:t>
+              <a:t>775K</a:t>
             </a:r>
           </a:p>
         </p:txBody>
@@ -34095,7 +34095,7 @@
               </a:defRPr>
             </a:pPr>
             <a:r>
-              <a:t>W 242K</a:t>
+              <a:t>W 194K</a:t>
             </a:r>
           </a:p>
         </p:txBody>
@@ -34131,7 +34131,7 @@
               </a:defRPr>
             </a:pPr>
             <a:r>
-              <a:t>3 opps</a:t>
+              <a:t>1 opps</a:t>
             </a:r>
           </a:p>
         </p:txBody>
@@ -34167,7 +34167,7 @@
               </a:defRPr>
             </a:pPr>
             <a:r>
-              <a:t>Emerson</a:t>
+              <a:t>Honeywell Tech.</a:t>
             </a:r>
           </a:p>
         </p:txBody>
@@ -34226,7 +34226,7 @@
         <p:spPr>
           <a:xfrm>
             <a:off x="2148840" y="3803904"/>
-            <a:ext cx="751609" cy="310896"/>
+            <a:ext cx="290945" cy="310896"/>
           </a:xfrm>
           <a:prstGeom prst="rect">
             <a:avLst/>
@@ -34291,7 +34291,7 @@
               </a:defRPr>
             </a:pPr>
             <a:r>
-              <a:t>775K</a:t>
+              <a:t>300K</a:t>
             </a:r>
           </a:p>
         </p:txBody>
@@ -34327,7 +34327,7 @@
               </a:defRPr>
             </a:pPr>
             <a:r>
-              <a:t>W 194K</a:t>
+              <a:t>W 180K</a:t>
             </a:r>
           </a:p>
         </p:txBody>
@@ -34363,7 +34363,7 @@
               </a:defRPr>
             </a:pPr>
             <a:r>
-              <a:t>1 opps</a:t>
+              <a:t>3 opps</a:t>
             </a:r>
           </a:p>
         </p:txBody>
@@ -34399,7 +34399,7 @@
               </a:defRPr>
             </a:pPr>
             <a:r>
-              <a:t>Honeywell Tech.</a:t>
+              <a:t>Philips</a:t>
             </a:r>
           </a:p>
         </p:txBody>
@@ -34458,7 +34458,7 @@
         <p:spPr>
           <a:xfrm>
             <a:off x="2148840" y="4434840"/>
-            <a:ext cx="290945" cy="310896"/>
+            <a:ext cx="271549" cy="310896"/>
           </a:xfrm>
           <a:prstGeom prst="rect">
             <a:avLst/>
@@ -34523,7 +34523,7 @@
               </a:defRPr>
             </a:pPr>
             <a:r>
-              <a:t>300K</a:t>
+              <a:t>280K</a:t>
             </a:r>
           </a:p>
         </p:txBody>
@@ -34559,7 +34559,7 @@
               </a:defRPr>
             </a:pPr>
             <a:r>
-              <a:t>W 180K</a:t>
+              <a:t>W 205K</a:t>
             </a:r>
           </a:p>
         </p:txBody>
@@ -34595,67 +34595,31 @@
               </a:defRPr>
             </a:pPr>
             <a:r>
-              <a:t>3 opps</a:t>
-            </a:r>
-          </a:p>
-        </p:txBody>
-      </p:sp>
-      <p:sp>
-        <p:nvSpPr>
-          <p:cNvPr id="43" name="TextBox 42"/>
-          <p:cNvSpPr txBox="1"/>
-          <p:nvPr/>
-        </p:nvSpPr>
-        <p:spPr>
-          <a:xfrm>
-            <a:off x="566928" y="5093207"/>
-            <a:ext cx="1508760" cy="201168"/>
-          </a:xfrm>
-          <a:prstGeom prst="rect">
-            <a:avLst/>
-          </a:prstGeom>
-          <a:noFill/>
-        </p:spPr>
-        <p:txBody>
-          <a:bodyPr wrap="square" lIns="36576" rIns="36576" tIns="36576" bIns="36576" anchor="t">
-            <a:spAutoFit/>
-          </a:bodyPr>
-          <a:lstStyle/>
-          <a:p>
-            <a:pPr algn="l">
-              <a:defRPr sz="950" b="1">
-                <a:solidFill>
-                  <a:srgbClr val="F7FAFC"/>
-                </a:solidFill>
-                <a:latin typeface="Aptos"/>
-              </a:defRPr>
-            </a:pPr>
-            <a:r>
-              <a:t>Philips</a:t>
-            </a:r>
-          </a:p>
-        </p:txBody>
-      </p:sp>
-      <p:sp>
-        <p:nvSpPr>
-          <p:cNvPr id="44" name="Rectangle 43"/>
+              <a:t>2 opps</a:t>
+            </a:r>
+          </a:p>
+        </p:txBody>
+      </p:sp>
+      <p:sp>
+        <p:nvSpPr>
+          <p:cNvPr id="43" name="Rounded Rectangle 42"/>
           <p:cNvSpPr/>
           <p:nvPr/>
         </p:nvSpPr>
         <p:spPr>
           <a:xfrm>
-            <a:off x="2148840" y="5065775"/>
-            <a:ext cx="4800600" cy="310896"/>
-          </a:xfrm>
-          <a:prstGeom prst="rect">
+            <a:off x="502920" y="5870448"/>
+            <a:ext cx="11109960" cy="384048"/>
+          </a:xfrm>
+          <a:prstGeom prst="roundRect">
             <a:avLst/>
           </a:prstGeom>
           <a:solidFill>
-            <a:srgbClr val="152446"/>
+            <a:srgbClr val="14213D"/>
           </a:solidFill>
           <a:ln w="12700">
             <a:solidFill>
-              <a:srgbClr val="152446"/>
+              <a:srgbClr val="2A3658"/>
             </a:solidFill>
           </a:ln>
         </p:spPr>
@@ -34683,203 +34647,7 @@
       </p:sp>
       <p:sp>
         <p:nvSpPr>
-          <p:cNvPr id="45" name="Rectangle 44"/>
-          <p:cNvSpPr/>
-          <p:nvPr/>
-        </p:nvSpPr>
-        <p:spPr>
-          <a:xfrm>
-            <a:off x="2148840" y="5065775"/>
-            <a:ext cx="271549" cy="310896"/>
-          </a:xfrm>
-          <a:prstGeom prst="rect">
-            <a:avLst/>
-          </a:prstGeom>
-          <a:solidFill>
-            <a:srgbClr val="3A86FF"/>
-          </a:solidFill>
-          <a:ln>
-            <a:noFill/>
-          </a:ln>
-        </p:spPr>
-        <p:style>
-          <a:lnRef idx="1">
-            <a:schemeClr val="accent1"/>
-          </a:lnRef>
-          <a:fillRef idx="3">
-            <a:schemeClr val="accent1"/>
-          </a:fillRef>
-          <a:effectRef idx="2">
-            <a:schemeClr val="accent1"/>
-          </a:effectRef>
-          <a:fontRef idx="minor">
-            <a:schemeClr val="lt1"/>
-          </a:fontRef>
-        </p:style>
-        <p:txBody>
-          <a:bodyPr rtlCol="0" anchor="ctr"/>
-          <a:lstStyle/>
-          <a:p>
-            <a:pPr algn="ctr"/>
-          </a:p>
-        </p:txBody>
-      </p:sp>
-      <p:sp>
-        <p:nvSpPr>
-          <p:cNvPr id="46" name="TextBox 45"/>
-          <p:cNvSpPr txBox="1"/>
-          <p:nvPr/>
-        </p:nvSpPr>
-        <p:spPr>
-          <a:xfrm>
-            <a:off x="7114032" y="5056631"/>
-            <a:ext cx="777240" cy="201168"/>
-          </a:xfrm>
-          <a:prstGeom prst="rect">
-            <a:avLst/>
-          </a:prstGeom>
-          <a:noFill/>
-        </p:spPr>
-        <p:txBody>
-          <a:bodyPr wrap="square" lIns="36576" rIns="36576" tIns="36576" bIns="36576" anchor="t">
-            <a:spAutoFit/>
-          </a:bodyPr>
-          <a:lstStyle/>
-          <a:p>
-            <a:pPr algn="r">
-              <a:defRPr sz="1050" b="1">
-                <a:solidFill>
-                  <a:srgbClr val="F7FAFC"/>
-                </a:solidFill>
-                <a:latin typeface="Aptos"/>
-              </a:defRPr>
-            </a:pPr>
-            <a:r>
-              <a:t>280K</a:t>
-            </a:r>
-          </a:p>
-        </p:txBody>
-      </p:sp>
-      <p:sp>
-        <p:nvSpPr>
-          <p:cNvPr id="47" name="TextBox 46"/>
-          <p:cNvSpPr txBox="1"/>
-          <p:nvPr/>
-        </p:nvSpPr>
-        <p:spPr>
-          <a:xfrm>
-            <a:off x="8010144" y="5056631"/>
-            <a:ext cx="1005840" cy="201168"/>
-          </a:xfrm>
-          <a:prstGeom prst="rect">
-            <a:avLst/>
-          </a:prstGeom>
-          <a:noFill/>
-        </p:spPr>
-        <p:txBody>
-          <a:bodyPr wrap="square" lIns="36576" rIns="36576" tIns="36576" bIns="36576" anchor="t">
-            <a:spAutoFit/>
-          </a:bodyPr>
-          <a:lstStyle/>
-          <a:p>
-            <a:pPr algn="l">
-              <a:defRPr sz="850" b="0">
-                <a:solidFill>
-                  <a:srgbClr val="A8B2C7"/>
-                </a:solidFill>
-                <a:latin typeface="Aptos"/>
-              </a:defRPr>
-            </a:pPr>
-            <a:r>
-              <a:t>W 205K</a:t>
-            </a:r>
-          </a:p>
-        </p:txBody>
-      </p:sp>
-      <p:sp>
-        <p:nvSpPr>
-          <p:cNvPr id="48" name="TextBox 47"/>
-          <p:cNvSpPr txBox="1"/>
-          <p:nvPr/>
-        </p:nvSpPr>
-        <p:spPr>
-          <a:xfrm>
-            <a:off x="9198864" y="5056631"/>
-            <a:ext cx="777240" cy="201168"/>
-          </a:xfrm>
-          <a:prstGeom prst="rect">
-            <a:avLst/>
-          </a:prstGeom>
-          <a:noFill/>
-        </p:spPr>
-        <p:txBody>
-          <a:bodyPr wrap="square" lIns="36576" rIns="36576" tIns="36576" bIns="36576" anchor="t">
-            <a:spAutoFit/>
-          </a:bodyPr>
-          <a:lstStyle/>
-          <a:p>
-            <a:pPr algn="l">
-              <a:defRPr sz="850" b="0">
-                <a:solidFill>
-                  <a:srgbClr val="A8B2C7"/>
-                </a:solidFill>
-                <a:latin typeface="Aptos"/>
-              </a:defRPr>
-            </a:pPr>
-            <a:r>
-              <a:t>2 opps</a:t>
-            </a:r>
-          </a:p>
-        </p:txBody>
-      </p:sp>
-      <p:sp>
-        <p:nvSpPr>
-          <p:cNvPr id="49" name="Rounded Rectangle 48"/>
-          <p:cNvSpPr/>
-          <p:nvPr/>
-        </p:nvSpPr>
-        <p:spPr>
-          <a:xfrm>
-            <a:off x="502920" y="5870448"/>
-            <a:ext cx="11109960" cy="384048"/>
-          </a:xfrm>
-          <a:prstGeom prst="roundRect">
-            <a:avLst/>
-          </a:prstGeom>
-          <a:solidFill>
-            <a:srgbClr val="14213D"/>
-          </a:solidFill>
-          <a:ln w="12700">
-            <a:solidFill>
-              <a:srgbClr val="2A3658"/>
-            </a:solidFill>
-          </a:ln>
-        </p:spPr>
-        <p:style>
-          <a:lnRef idx="1">
-            <a:schemeClr val="accent1"/>
-          </a:lnRef>
-          <a:fillRef idx="3">
-            <a:schemeClr val="accent1"/>
-          </a:fillRef>
-          <a:effectRef idx="2">
-            <a:schemeClr val="accent1"/>
-          </a:effectRef>
-          <a:fontRef idx="minor">
-            <a:schemeClr val="lt1"/>
-          </a:fontRef>
-        </p:style>
-        <p:txBody>
-          <a:bodyPr rtlCol="0" anchor="ctr"/>
-          <a:lstStyle/>
-          <a:p>
-            <a:pPr algn="ctr"/>
-          </a:p>
-        </p:txBody>
-      </p:sp>
-      <p:sp>
-        <p:nvSpPr>
-          <p:cNvPr id="50" name="TextBox 49"/>
+          <p:cNvPr id="44" name="TextBox 43"/>
           <p:cNvSpPr txBox="1"/>
           <p:nvPr/>
         </p:nvSpPr>
@@ -34908,7 +34676,7 @@
               </a:defRPr>
             </a:pPr>
             <a:r>
-              <a:t>Coverage check: 14/14 are direct “Altera Opportunity”; distributor account is blank on every Sahil line item.</a:t>
+              <a:t>Coverage check: 12/12 qualified open opportunities are direct; distributor account is blank in both uploaded Sahil exports.</a:t>
             </a:r>
           </a:p>
         </p:txBody>

</xml_diff>

<commit_message>
Align QBR to Altera fiscal calendar
Co-authored-by: Sahil Patni <sahilpat28@users.noreply.github.com>
</commit_message>
<xml_diff>
--- a/qbr/output/Sahil_QBR_2026-07-29.pptx
+++ b/qbr/output/Sahil_QBR_2026-07-29.pptx
@@ -3239,7 +3239,7 @@
             </a:r>
             <a:br/>
             <a:r>
-              <a:t>Build the 2027 engine.</a:t>
+              <a:t>Build the FY2027 engine.</a:t>
             </a:r>
           </a:p>
         </p:txBody>
@@ -3318,7 +3318,43 @@
       </p:sp>
       <p:sp>
         <p:nvSpPr>
-          <p:cNvPr id="7" name="Rounded Rectangle 6"/>
+          <p:cNvPr id="7" name="TextBox 6"/>
+          <p:cNvSpPr txBox="1"/>
+          <p:nvPr/>
+        </p:nvSpPr>
+        <p:spPr>
+          <a:xfrm>
+            <a:off x="731520" y="3346704"/>
+            <a:ext cx="7223760" cy="256032"/>
+          </a:xfrm>
+          <a:prstGeom prst="rect">
+            <a:avLst/>
+          </a:prstGeom>
+          <a:noFill/>
+        </p:spPr>
+        <p:txBody>
+          <a:bodyPr wrap="square" lIns="36576" rIns="36576" tIns="36576" bIns="36576" anchor="t">
+            <a:spAutoFit/>
+          </a:bodyPr>
+          <a:lstStyle/>
+          <a:p>
+            <a:pPr algn="l">
+              <a:defRPr sz="1100" b="1">
+                <a:solidFill>
+                  <a:srgbClr val="FF9F1C"/>
+                </a:solidFill>
+                <a:latin typeface="Aptos"/>
+              </a:defRPr>
+            </a:pPr>
+            <a:r>
+              <a:t>Joined FAE team: 01 Jun 2026  •  Review point: FY2026 Q3 close</a:t>
+            </a:r>
+          </a:p>
+        </p:txBody>
+      </p:sp>
+      <p:sp>
+        <p:nvSpPr>
+          <p:cNvPr id="8" name="Rounded Rectangle 7"/>
           <p:cNvSpPr/>
           <p:nvPr/>
         </p:nvSpPr>
@@ -3363,7 +3399,7 @@
       </p:sp>
       <p:sp>
         <p:nvSpPr>
-          <p:cNvPr id="8" name="TextBox 7"/>
+          <p:cNvPr id="9" name="TextBox 8"/>
           <p:cNvSpPr txBox="1"/>
           <p:nvPr/>
         </p:nvSpPr>
@@ -3399,7 +3435,7 @@
       </p:sp>
       <p:sp>
         <p:nvSpPr>
-          <p:cNvPr id="9" name="TextBox 8"/>
+          <p:cNvPr id="10" name="TextBox 9"/>
           <p:cNvSpPr txBox="1"/>
           <p:nvPr/>
         </p:nvSpPr>
@@ -3435,7 +3471,7 @@
       </p:sp>
       <p:sp>
         <p:nvSpPr>
-          <p:cNvPr id="10" name="TextBox 9"/>
+          <p:cNvPr id="11" name="TextBox 10"/>
           <p:cNvSpPr txBox="1"/>
           <p:nvPr/>
         </p:nvSpPr>
@@ -3471,7 +3507,7 @@
       </p:sp>
       <p:sp>
         <p:nvSpPr>
-          <p:cNvPr id="11" name="TextBox 10"/>
+          <p:cNvPr id="12" name="TextBox 11"/>
           <p:cNvSpPr txBox="1"/>
           <p:nvPr/>
         </p:nvSpPr>
@@ -3507,7 +3543,7 @@
       </p:sp>
       <p:sp>
         <p:nvSpPr>
-          <p:cNvPr id="12" name="TextBox 11"/>
+          <p:cNvPr id="13" name="TextBox 12"/>
           <p:cNvSpPr txBox="1"/>
           <p:nvPr/>
         </p:nvSpPr>
@@ -3543,7 +3579,7 @@
       </p:sp>
       <p:sp>
         <p:nvSpPr>
-          <p:cNvPr id="13" name="TextBox 12"/>
+          <p:cNvPr id="14" name="TextBox 13"/>
           <p:cNvSpPr txBox="1"/>
           <p:nvPr/>
         </p:nvSpPr>
@@ -3579,7 +3615,7 @@
       </p:sp>
       <p:sp>
         <p:nvSpPr>
-          <p:cNvPr id="14" name="TextBox 13"/>
+          <p:cNvPr id="15" name="TextBox 14"/>
           <p:cNvSpPr txBox="1"/>
           <p:nvPr/>
         </p:nvSpPr>
@@ -3615,7 +3651,7 @@
       </p:sp>
       <p:sp>
         <p:nvSpPr>
-          <p:cNvPr id="15" name="TextBox 14"/>
+          <p:cNvPr id="16" name="TextBox 15"/>
           <p:cNvSpPr txBox="1"/>
           <p:nvPr/>
         </p:nvSpPr>
@@ -3655,7 +3691,7 @@
       </p:sp>
       <p:sp>
         <p:nvSpPr>
-          <p:cNvPr id="16" name="TextBox 15"/>
+          <p:cNvPr id="17" name="TextBox 16"/>
           <p:cNvSpPr txBox="1"/>
           <p:nvPr/>
         </p:nvSpPr>
@@ -3684,7 +3720,7 @@
               </a:defRPr>
             </a:pPr>
             <a:r>
-              <a:t>Prepared from master + 2026/2027 open-pipeline exports  •  Values shown without assumed currency</a:t>
+              <a:t>Fiscal year: 01 Nov–31 Oct  •  Values shown without assumed currency</a:t>
             </a:r>
           </a:p>
         </p:txBody>
@@ -3897,7 +3933,7 @@
               </a:defRPr>
             </a:pPr>
             <a:r>
-              <a:t>Prepared 27 Jul 2026  •  Source: Sahil Report.xlsx  •  Values are in source units (currency not encoded)</a:t>
+              <a:t>Prepared 28 Jul 2026  •  Source values are in source units (currency not encoded)</a:t>
             </a:r>
           </a:p>
         </p:txBody>
@@ -6598,7 +6634,7 @@
               </a:defRPr>
             </a:pPr>
             <a:r>
-              <a:t>Prepared 27 Jul 2026  •  Source: Sahil Report.xlsx  •  Values are in source units (currency not encoded)</a:t>
+              <a:t>Prepared 28 Jul 2026  •  Source values are in source units (currency not encoded)</a:t>
             </a:r>
           </a:p>
         </p:txBody>
@@ -6832,7 +6868,7 @@
               </a:defRPr>
             </a:pPr>
             <a:r>
-              <a:t>COVERAGE WINDOW</a:t>
+              <a:t>FAE TEAM START</a:t>
             </a:r>
           </a:p>
         </p:txBody>
@@ -6868,7 +6904,7 @@
               </a:defRPr>
             </a:pPr>
             <a:r>
-              <a:t>75 days</a:t>
+              <a:t>01 Jun</a:t>
             </a:r>
           </a:p>
         </p:txBody>
@@ -6904,7 +6940,7 @@
               </a:defRPr>
             </a:pPr>
             <a:r>
-              <a:t>external technical email</a:t>
+              <a:t>3 threads latest pre-start</a:t>
             </a:r>
           </a:p>
         </p:txBody>
@@ -8162,7 +8198,7 @@
               </a:defRPr>
             </a:pPr>
             <a:r>
-              <a:t>Source: user-provided distinct external email-thread analysis, 15 May–28 Jul 2026. Internal-only/admin threads excluded.</a:t>
+              <a:t>75-day ledger. Sahil joined FAE on 01 Jun 2026; three threads show latest activity before that date and should be framed as transition/pre-start support.</a:t>
             </a:r>
           </a:p>
         </p:txBody>
@@ -8375,7 +8411,7 @@
               </a:defRPr>
             </a:pPr>
             <a:r>
-              <a:t>Prepared 27 Jul 2026  •  Source: Sahil Report.xlsx  •  Values are in source units (currency not encoded)</a:t>
+              <a:t>Prepared 28 Jul 2026  •  Source values are in source units (currency not encoded)</a:t>
             </a:r>
           </a:p>
         </p:txBody>
@@ -9279,7 +9315,7 @@
               </a:defRPr>
             </a:pPr>
             <a:r>
-              <a:t>07 / 2027 CREATION</a:t>
+              <a:t>07 / FY2027 CREATION</a:t>
             </a:r>
           </a:p>
         </p:txBody>
@@ -9315,7 +9351,7 @@
               </a:defRPr>
             </a:pPr>
             <a:r>
-              <a:t>FY2027 demand creation: three repeatable motions</a:t>
+              <a:t>FY2027 demand creation (Nov 2026–Oct 2027): three motions</a:t>
             </a:r>
           </a:p>
         </p:txBody>
@@ -9430,7 +9466,7 @@
               </a:defRPr>
             </a:pPr>
             <a:r>
-              <a:t>Prepared 27 Jul 2026  •  Source: Sahil Report.xlsx  •  Values are in source units (currency not encoded)</a:t>
+              <a:t>Prepared 28 Jul 2026  •  Source values are in source units (currency not encoded)</a:t>
             </a:r>
           </a:p>
         </p:txBody>
@@ -10357,7 +10393,7 @@
               </a:defRPr>
             </a:pPr>
             <a:r>
-              <a:t>Review decision: choose numeric 2027 creation targets after the 2027 sales objective is confirmed.</a:t>
+              <a:t>Review decision: approve numeric FY2027 creation targets after the FY2027 sales objective is confirmed.</a:t>
             </a:r>
           </a:p>
         </p:txBody>
@@ -10570,7 +10606,7 @@
               </a:defRPr>
             </a:pPr>
             <a:r>
-              <a:t>Prepared 27 Jul 2026  •  Source: Sahil Report.xlsx  •  Values are in source units (currency not encoded)</a:t>
+              <a:t>Prepared 28 Jul 2026  •  Source values are in source units (currency not encoded)</a:t>
             </a:r>
           </a:p>
         </p:txBody>
@@ -11418,7 +11454,7 @@
               </a:defRPr>
             </a:pPr>
             <a:r>
-              <a:t>Review decision: approve the joint Altera–Arrow–Macnica tiger team, owners, readiness dates and Q4 scorecard.</a:t>
+              <a:t>Review decision: approve the joint tiger team, readiness dates and Q4 FY2026 scorecard.</a:t>
             </a:r>
           </a:p>
         </p:txBody>
@@ -11631,7 +11667,7 @@
               </a:defRPr>
             </a:pPr>
             <a:r>
-              <a:t>Prepared 27 Jul 2026  •  Source: Sahil Report.xlsx  •  Values are in source units (currency not encoded)</a:t>
+              <a:t>Prepared 28 Jul 2026  •  Source values are in source units (currency not encoded)</a:t>
             </a:r>
           </a:p>
         </p:txBody>
@@ -13527,7 +13563,7 @@
               </a:defRPr>
             </a:pPr>
             <a:r>
-              <a:t>Prepared 27 Jul 2026  •  Source: Sahil Report.xlsx  •  Values are in source units (currency not encoded)</a:t>
+              <a:t>Prepared 28 Jul 2026  •  Source values are in source units (currency not encoded)</a:t>
             </a:r>
           </a:p>
         </p:txBody>
@@ -14903,7 +14939,7 @@
               </a:defRPr>
             </a:pPr>
             <a:r>
-              <a:t>Prepared 27 Jul 2026  •  Source: Sahil Report.xlsx  •  Values are in source units (currency not encoded)</a:t>
+              <a:t>Prepared 28 Jul 2026  •  Source values are in source units (currency not encoded)</a:t>
             </a:r>
           </a:p>
         </p:txBody>
@@ -16475,7 +16511,7 @@
               </a:defRPr>
             </a:pPr>
             <a:r>
-              <a:t>Prepared 27 Jul 2026  •  Source: Sahil Report.xlsx  •  Values are in source units (currency not encoded)</a:t>
+              <a:t>Prepared 28 Jul 2026  •  Source values are in source units (currency not encoded)</a:t>
             </a:r>
           </a:p>
         </p:txBody>
@@ -17348,7 +17384,7 @@
               </a:defRPr>
             </a:pPr>
             <a:r>
-              <a:t>Q4 CLOSE</a:t>
+              <a:t>Q4 FY26</a:t>
             </a:r>
           </a:p>
         </p:txBody>
@@ -17465,7 +17501,7 @@
               </a:defRPr>
             </a:pPr>
             <a:r>
-              <a:t>Proposed target: 6 qualified opportunities, 3 Develop/Design-stage plays and 2 DWINs.</a:t>
+              <a:t>By 31 Oct: 6 qualified opportunities, 3 Develop/Design-stage plays and 2 DWINs.</a:t>
             </a:r>
           </a:p>
         </p:txBody>
@@ -17759,7 +17795,7 @@
               </a:defRPr>
             </a:pPr>
             <a:r>
-              <a:t>Prepared 27 Jul 2026  •  Source: Sahil Report.xlsx  •  Values are in source units (currency not encoded)</a:t>
+              <a:t>Prepared 28 Jul 2026  •  Source values are in source units (currency not encoded)</a:t>
             </a:r>
           </a:p>
         </p:txBody>
@@ -18791,7 +18827,7 @@
               </a:defRPr>
             </a:pPr>
             <a:r>
-              <a:t>Prepared 27 Jul 2026  •  Source: Sahil Report.xlsx  •  Values are in source units (currency not encoded)</a:t>
+              <a:t>Prepared 28 Jul 2026  •  Source values are in source units (currency not encoded)</a:t>
             </a:r>
           </a:p>
         </p:txBody>
@@ -19178,7 +19214,7 @@
               </a:defRPr>
             </a:pPr>
             <a:r>
-              <a:t>2026 OPEN EXPORT</a:t>
+              <a:t>FY2026 OPEN EXPORT</a:t>
             </a:r>
           </a:p>
         </p:txBody>
@@ -19331,7 +19367,7 @@
               </a:defRPr>
             </a:pPr>
             <a:r>
-              <a:t>2027 OPEN EXPORT</a:t>
+              <a:t>FY2027 OPEN EXPORT</a:t>
             </a:r>
           </a:p>
         </p:txBody>
@@ -19535,7 +19571,7 @@
               </a:defRPr>
             </a:pPr>
             <a:r>
-              <a:t>• Q4 2026 DWIN-dated pipeline is 6.71M, yet weighted value is only 1.62M.</a:t>
+              <a:t>• Q4 FY2026 (Aug–Oct) DWIN-dated pipeline is 4.95M; weighted value is 1.37M.</a:t>
             </a:r>
           </a:p>
           <a:p>
@@ -19651,7 +19687,7 @@
               </a:defRPr>
             </a:pPr>
             <a:r>
-              <a:t>1  Confirm 2026 target and YTD actual.</a:t>
+              <a:t>1  Confirm FY2026 target and YTD actual.</a:t>
             </a:r>
           </a:p>
           <a:p>
@@ -19667,7 +19703,7 @@
               </a:defRPr>
             </a:pPr>
             <a:r>
-              <a:t>2  Agree stage-exit evidence for 8 Q4 DWINs.</a:t>
+              <a:t>2  Agree stage-exit evidence for 4 Q4 FY2026 DWINs.</a:t>
             </a:r>
           </a:p>
           <a:p>
@@ -19912,7 +19948,7 @@
               </a:defRPr>
             </a:pPr>
             <a:r>
-              <a:t>Prepared 27 Jul 2026  •  Source: Sahil Report.xlsx  •  Values are in source units (currency not encoded)</a:t>
+              <a:t>Prepared 28 Jul 2026  •  Source values are in source units (currency not encoded)</a:t>
             </a:r>
           </a:p>
         </p:txBody>
@@ -20377,7 +20413,7 @@
               </a:defRPr>
             </a:pPr>
             <a:r>
-              <a:t>PROPOSED 2027 MOTION</a:t>
+              <a:t>PROPOSED FY2027 MOTION</a:t>
             </a:r>
           </a:p>
         </p:txBody>
@@ -20745,7 +20781,7 @@
               </a:defRPr>
             </a:pPr>
             <a:r>
-              <a:t>Prepared 27 Jul 2026  •  Source: Sahil Report.xlsx  •  Values are in source units (currency not encoded)</a:t>
+              <a:t>Prepared 28 Jul 2026  •  Source values are in source units (currency not encoded)</a:t>
             </a:r>
           </a:p>
         </p:txBody>
@@ -21210,7 +21246,7 @@
               </a:defRPr>
             </a:pPr>
             <a:r>
-              <a:t>PROPOSED 2027 MOTION</a:t>
+              <a:t>PROPOSED FY2027 MOTION</a:t>
             </a:r>
           </a:p>
         </p:txBody>
@@ -21578,7 +21614,7 @@
               </a:defRPr>
             </a:pPr>
             <a:r>
-              <a:t>Prepared 27 Jul 2026  •  Source: Sahil Report.xlsx  •  Values are in source units (currency not encoded)</a:t>
+              <a:t>Prepared 28 Jul 2026  •  Source values are in source units (currency not encoded)</a:t>
             </a:r>
           </a:p>
         </p:txBody>
@@ -22043,7 +22079,7 @@
               </a:defRPr>
             </a:pPr>
             <a:r>
-              <a:t>PROPOSED 2027 MOTION</a:t>
+              <a:t>PROPOSED FY2027 MOTION</a:t>
             </a:r>
           </a:p>
         </p:txBody>
@@ -22411,7 +22447,7 @@
               </a:defRPr>
             </a:pPr>
             <a:r>
-              <a:t>Prepared 27 Jul 2026  •  Source: Sahil Report.xlsx  •  Values are in source units (currency not encoded)</a:t>
+              <a:t>Prepared 28 Jul 2026  •  Source values are in source units (currency not encoded)</a:t>
             </a:r>
           </a:p>
         </p:txBody>
@@ -23214,7 +23250,7 @@
               </a:defRPr>
             </a:pPr>
             <a:r>
-              <a:t>Prepared 27 Jul 2026  •  Source: Sahil Report.xlsx  •  Values are in source units (currency not encoded)</a:t>
+              <a:t>Prepared 28 Jul 2026  •  Source values are in source units (currency not encoded)</a:t>
             </a:r>
           </a:p>
         </p:txBody>
@@ -24177,7 +24213,7 @@
               </a:defRPr>
             </a:pPr>
             <a:r>
-              <a:t>Prepared 27 Jul 2026  •  Source: Sahil Report.xlsx  •  Values are in source units (currency not encoded)</a:t>
+              <a:t>Prepared 28 Jul 2026  •  Source values are in source units (currency not encoded)</a:t>
             </a:r>
           </a:p>
         </p:txBody>
@@ -25281,7 +25317,7 @@
               </a:defRPr>
             </a:pPr>
             <a:r>
-              <a:t>Prepared 27 Jul 2026  •  Source: Sahil Report.xlsx  •  Values are in source units (currency not encoded)</a:t>
+              <a:t>Prepared 28 Jul 2026  •  Source values are in source units (currency not encoded)</a:t>
             </a:r>
           </a:p>
         </p:txBody>
@@ -26475,7 +26511,7 @@
               </a:defRPr>
             </a:pPr>
             <a:r>
-              <a:t>Prepared 27 Jul 2026  •  Source: Sahil Report.xlsx  •  Values are in source units (currency not encoded)</a:t>
+              <a:t>Prepared 28 Jul 2026  •  Source values are in source units (currency not encoded)</a:t>
             </a:r>
           </a:p>
         </p:txBody>
@@ -27069,7 +27105,7 @@
               </a:defRPr>
             </a:pPr>
             <a:r>
-              <a:t>2026 target</a:t>
+              <a:t>FY2026 target</a:t>
             </a:r>
           </a:p>
         </p:txBody>
@@ -27754,7 +27790,7 @@
               </a:defRPr>
             </a:pPr>
             <a:r>
-              <a:t>Prepared 27 Jul 2026  •  Source: Sahil Report.xlsx  •  Values are in source units (currency not encoded)</a:t>
+              <a:t>Prepared 28 Jul 2026  •  Source values are in source units (currency not encoded)</a:t>
             </a:r>
           </a:p>
         </p:txBody>
@@ -27826,7 +27862,7 @@
               </a:defRPr>
             </a:pPr>
             <a:r>
-              <a:t>Reporting scope attributes Sahil Patni + Kasturi Rangan to Sahil. Master: 21 opportunities; open exports: 18.</a:t>
+              <a:t>Sahil joined FAE on 01 Jun 2026. Reporting attributes Sahil Patni + Kasturi Rangan to Sahil: 21 discovered / 18 open.</a:t>
             </a:r>
           </a:p>
         </p:txBody>
@@ -27862,7 +27898,7 @@
               </a:defRPr>
             </a:pPr>
             <a:r>
-              <a:t>BUCKETS</a:t>
+              <a:t>FISCAL</a:t>
             </a:r>
           </a:p>
         </p:txBody>
@@ -27898,7 +27934,7 @@
               </a:defRPr>
             </a:pPr>
             <a:r>
-              <a:t>“2026” and “2027” are the user-provided export labels. Membership is not inferred from Design Win Date; the 2027 export includes some 2026 DWIN dates.</a:t>
+              <a:t>Altera FY runs 01 Nov–31 Oct. FY2026 Q4 is 01 Aug–31 Oct 2026; FY2027 is 01 Nov 2026–31 Oct 2027.</a:t>
             </a:r>
           </a:p>
         </p:txBody>
@@ -27934,7 +27970,7 @@
               </a:defRPr>
             </a:pPr>
             <a:r>
-              <a:t>PEAK VALUE</a:t>
+              <a:t>BUCKETS</a:t>
             </a:r>
           </a:p>
         </p:txBody>
@@ -27970,7 +28006,7 @@
               </a:defRPr>
             </a:pPr>
             <a:r>
-              <a:t>Product-line Peak Value summed within each Opportunity ID. Source file does not encode currency.</a:t>
+              <a:t>Uploaded 2026/2027 files are treated as fiscal planning buckets; membership is retained from each file rather than recalculated from DWIN Date.</a:t>
             </a:r>
           </a:p>
         </p:txBody>
@@ -28006,7 +28042,7 @@
               </a:defRPr>
             </a:pPr>
             <a:r>
-              <a:t>WEIGHTED VALUE</a:t>
+              <a:t>PEAK VALUE</a:t>
             </a:r>
           </a:p>
         </p:txBody>
@@ -28042,7 +28078,7 @@
               </a:defRPr>
             </a:pPr>
             <a:r>
-              <a:t>Consolidated peak value × source probability. Identify opportunities at 0% therefore contribute zero.</a:t>
+              <a:t>Product-line Peak Value summed within each Opportunity ID. Source file does not encode currency.</a:t>
             </a:r>
           </a:p>
         </p:txBody>
@@ -28078,7 +28114,7 @@
               </a:defRPr>
             </a:pPr>
             <a:r>
-              <a:t>DWIN-DATED</a:t>
+              <a:t>WEIGHTED VALUE</a:t>
             </a:r>
           </a:p>
         </p:txBody>
@@ -28114,7 +28150,7 @@
               </a:defRPr>
             </a:pPr>
             <a:r>
-              <a:t>Opportunity Design Win Date falls in the stated year. This is a scheduled date, not proof of an achieved design win.</a:t>
+              <a:t>Consolidated peak value × source probability. Identify opportunities at 0% therefore contribute zero.</a:t>
             </a:r>
           </a:p>
         </p:txBody>
@@ -28150,7 +28186,7 @@
               </a:defRPr>
             </a:pPr>
             <a:r>
-              <a:t>DATES</a:t>
+              <a:t>DWIN-DATED</a:t>
             </a:r>
           </a:p>
         </p:txBody>
@@ -28186,7 +28222,7 @@
               </a:defRPr>
             </a:pPr>
             <a:r>
-              <a:t>Source mixes Excel dates and text dates; both were normalized for analysis.</a:t>
+              <a:t>Opportunity Design Win Date falls in the stated year. This is a scheduled date, not proof of an achieved design win.</a:t>
             </a:r>
           </a:p>
         </p:txBody>
@@ -28507,7 +28543,7 @@
               </a:defRPr>
             </a:pPr>
             <a:r>
-              <a:t>Prepared 27 Jul 2026  •  Source: Sahil Report.xlsx  •  Values are in source units (currency not encoded)</a:t>
+              <a:t>Prepared 28 Jul 2026  •  Source values are in source units (currency not encoded)</a:t>
             </a:r>
           </a:p>
         </p:txBody>
@@ -29721,7 +29757,7 @@
               </a:defRPr>
             </a:pPr>
             <a:r>
-              <a:t>2026 target vs current achievement: source inputs are incomplete</a:t>
+              <a:t>FY2026 target vs current achievement: source inputs are incomplete</a:t>
             </a:r>
           </a:p>
         </p:txBody>
@@ -29836,7 +29872,7 @@
               </a:defRPr>
             </a:pPr>
             <a:r>
-              <a:t>Prepared 27 Jul 2026  •  Source: Sahil Report.xlsx  •  Values are in source units (currency not encoded)</a:t>
+              <a:t>Prepared 28 Jul 2026  •  Source values are in source units (currency not encoded)</a:t>
             </a:r>
           </a:p>
         </p:txBody>
@@ -29953,7 +29989,7 @@
               </a:defRPr>
             </a:pPr>
             <a:r>
-              <a:t>2026 ANNUAL TARGET</a:t>
+              <a:t>FY2026 ANNUAL TARGET</a:t>
             </a:r>
           </a:p>
         </p:txBody>
@@ -30592,7 +30628,7 @@
               </a:defRPr>
             </a:pPr>
             <a:r>
-              <a:t>2026 export</a:t>
+              <a:t>FY2026 export</a:t>
             </a:r>
           </a:p>
         </p:txBody>
@@ -30664,7 +30700,7 @@
               </a:defRPr>
             </a:pPr>
             <a:r>
-              <a:t>2027 export</a:t>
+              <a:t>FY2027 export</a:t>
             </a:r>
           </a:p>
         </p:txBody>
@@ -30949,7 +30985,7 @@
               </a:defRPr>
             </a:pPr>
             <a:r>
-              <a:t>Prepared 27 Jul 2026  •  Source: Sahil Report.xlsx  •  Values are in source units (currency not encoded)</a:t>
+              <a:t>Prepared 28 Jul 2026  •  Source values are in source units (currency not encoded)</a:t>
             </a:r>
           </a:p>
         </p:txBody>
@@ -32278,7 +32314,7 @@
               </a:defRPr>
             </a:pPr>
             <a:r>
-              <a:t>Prepared 27 Jul 2026  •  Source: Sahil Report.xlsx  •  Values are in source units (currency not encoded)</a:t>
+              <a:t>Prepared 28 Jul 2026  •  Source values are in source units (currency not encoded)</a:t>
             </a:r>
           </a:p>
         </p:txBody>
@@ -33457,7 +33493,7 @@
               </a:defRPr>
             </a:pPr>
             <a:r>
-              <a:t>2026 DWIN-dated pipeline: convert 11 named plays</a:t>
+              <a:t>Q4 FY2026 DWIN pipeline: convert 4 named plays</a:t>
             </a:r>
           </a:p>
         </p:txBody>
@@ -33572,7 +33608,7 @@
               </a:defRPr>
             </a:pPr>
             <a:r>
-              <a:t>Prepared 27 Jul 2026  •  Source: Sahil Report.xlsx  •  Values are in source units (currency not encoded)</a:t>
+              <a:t>Prepared 28 Jul 2026  •  Source values are in source units (currency not encoded)</a:t>
             </a:r>
           </a:p>
         </p:txBody>
@@ -33604,7 +33640,7 @@
                 <a:gridCol w="704088"/>
                 <a:gridCol w="4937760"/>
               </a:tblGrid>
-              <a:tr h="270510">
+              <a:tr h="649224">
                 <a:tc>
                   <a:txBody>
                     <a:bodyPr/>
@@ -33774,7 +33810,7 @@
                   </a:tcPr>
                 </a:tc>
               </a:tr>
-              <a:tr h="270510">
+              <a:tr h="649224">
                 <a:tc>
                   <a:txBody>
                     <a:bodyPr wrap="square" anchor="ctr"/>
@@ -33944,7 +33980,7 @@
                   </a:tcPr>
                 </a:tc>
               </a:tr>
-              <a:tr h="270510">
+              <a:tr h="649224">
                 <a:tc>
                   <a:txBody>
                     <a:bodyPr wrap="square" anchor="ctr"/>
@@ -34114,7 +34150,7 @@
                   </a:tcPr>
                 </a:tc>
               </a:tr>
-              <a:tr h="270510">
+              <a:tr h="649224">
                 <a:tc>
                   <a:txBody>
                     <a:bodyPr wrap="square" anchor="ctr"/>
@@ -34284,7 +34320,7 @@
                   </a:tcPr>
                 </a:tc>
               </a:tr>
-              <a:tr h="270510">
+              <a:tr h="649224">
                 <a:tc>
                   <a:txBody>
                     <a:bodyPr wrap="square" anchor="ctr"/>
@@ -34454,1196 +34490,6 @@
                   </a:tcPr>
                 </a:tc>
               </a:tr>
-              <a:tr h="270510">
-                <a:tc>
-                  <a:txBody>
-                    <a:bodyPr wrap="square" anchor="ctr"/>
-                    <a:lstStyle/>
-                    <a:p>
-                      <a:pPr>
-                        <a:defRPr sz="840">
-                          <a:solidFill>
-                            <a:srgbClr val="F7FAFC"/>
-                          </a:solidFill>
-                          <a:latin typeface="Aptos"/>
-                        </a:defRPr>
-                      </a:pPr>
-                      <a:r>
-                        <a:t>Ciena</a:t>
-                      </a:r>
-                    </a:p>
-                  </a:txBody>
-                  <a:tcPr marL="54864" marR="36576" marT="22860" marB="18288">
-                    <a:solidFill>
-                      <a:srgbClr val="111C3A"/>
-                    </a:solidFill>
-                  </a:tcPr>
-                </a:tc>
-                <a:tc>
-                  <a:txBody>
-                    <a:bodyPr wrap="square" anchor="ctr"/>
-                    <a:lstStyle/>
-                    <a:p>
-                      <a:pPr>
-                        <a:defRPr sz="840">
-                          <a:solidFill>
-                            <a:srgbClr val="F7FAFC"/>
-                          </a:solidFill>
-                          <a:latin typeface="Aptos"/>
-                        </a:defRPr>
-                      </a:pPr>
-                      <a:r>
-                        <a:t>5134_Aggregation Router</a:t>
-                      </a:r>
-                    </a:p>
-                  </a:txBody>
-                  <a:tcPr marL="54864" marR="36576" marT="22860" marB="18288">
-                    <a:solidFill>
-                      <a:srgbClr val="111C3A"/>
-                    </a:solidFill>
-                  </a:tcPr>
-                </a:tc>
-                <a:tc>
-                  <a:txBody>
-                    <a:bodyPr wrap="square" anchor="ctr"/>
-                    <a:lstStyle/>
-                    <a:p>
-                      <a:pPr>
-                        <a:defRPr sz="840">
-                          <a:solidFill>
-                            <a:srgbClr val="F7FAFC"/>
-                          </a:solidFill>
-                          <a:latin typeface="Aptos"/>
-                        </a:defRPr>
-                      </a:pPr>
-                      <a:r>
-                        <a:t>Define</a:t>
-                      </a:r>
-                    </a:p>
-                  </a:txBody>
-                  <a:tcPr marL="54864" marR="36576" marT="22860" marB="18288">
-                    <a:solidFill>
-                      <a:srgbClr val="111C3A"/>
-                    </a:solidFill>
-                  </a:tcPr>
-                </a:tc>
-                <a:tc>
-                  <a:txBody>
-                    <a:bodyPr wrap="square" anchor="ctr"/>
-                    <a:lstStyle/>
-                    <a:p>
-                      <a:pPr>
-                        <a:defRPr sz="840">
-                          <a:solidFill>
-                            <a:srgbClr val="F7FAFC"/>
-                          </a:solidFill>
-                          <a:latin typeface="Aptos"/>
-                        </a:defRPr>
-                      </a:pPr>
-                      <a:r>
-                        <a:t>25%</a:t>
-                      </a:r>
-                    </a:p>
-                  </a:txBody>
-                  <a:tcPr marL="54864" marR="36576" marT="22860" marB="18288">
-                    <a:solidFill>
-                      <a:srgbClr val="111C3A"/>
-                    </a:solidFill>
-                  </a:tcPr>
-                </a:tc>
-                <a:tc>
-                  <a:txBody>
-                    <a:bodyPr wrap="square" anchor="ctr"/>
-                    <a:lstStyle/>
-                    <a:p>
-                      <a:pPr>
-                        <a:defRPr sz="840">
-                          <a:solidFill>
-                            <a:srgbClr val="F7FAFC"/>
-                          </a:solidFill>
-                          <a:latin typeface="Aptos"/>
-                        </a:defRPr>
-                      </a:pPr>
-                      <a:r>
-                        <a:t>13 Nov 2026</a:t>
-                      </a:r>
-                    </a:p>
-                  </a:txBody>
-                  <a:tcPr marL="54864" marR="36576" marT="22860" marB="18288">
-                    <a:solidFill>
-                      <a:srgbClr val="111C3A"/>
-                    </a:solidFill>
-                  </a:tcPr>
-                </a:tc>
-                <a:tc>
-                  <a:txBody>
-                    <a:bodyPr wrap="square" anchor="ctr"/>
-                    <a:lstStyle/>
-                    <a:p>
-                      <a:pPr>
-                        <a:defRPr sz="840">
-                          <a:solidFill>
-                            <a:srgbClr val="F7FAFC"/>
-                          </a:solidFill>
-                          <a:latin typeface="Aptos"/>
-                        </a:defRPr>
-                      </a:pPr>
-                      <a:r>
-                        <a:t>429K</a:t>
-                      </a:r>
-                    </a:p>
-                  </a:txBody>
-                  <a:tcPr marL="54864" marR="36576" marT="22860" marB="18288">
-                    <a:solidFill>
-                      <a:srgbClr val="111C3A"/>
-                    </a:solidFill>
-                  </a:tcPr>
-                </a:tc>
-                <a:tc>
-                  <a:txBody>
-                    <a:bodyPr wrap="square" anchor="ctr"/>
-                    <a:lstStyle/>
-                    <a:p>
-                      <a:pPr>
-                        <a:defRPr sz="840">
-                          <a:solidFill>
-                            <a:srgbClr val="F7FAFC"/>
-                          </a:solidFill>
-                          <a:latin typeface="Aptos"/>
-                        </a:defRPr>
-                      </a:pPr>
-                      <a:r>
-                        <a:t>Freeze architecture/BOM and evaluation plan</a:t>
-                      </a:r>
-                    </a:p>
-                  </a:txBody>
-                  <a:tcPr marL="54864" marR="36576" marT="22860" marB="18288">
-                    <a:solidFill>
-                      <a:srgbClr val="111C3A"/>
-                    </a:solidFill>
-                  </a:tcPr>
-                </a:tc>
-              </a:tr>
-              <a:tr h="270510">
-                <a:tc>
-                  <a:txBody>
-                    <a:bodyPr wrap="square" anchor="ctr"/>
-                    <a:lstStyle/>
-                    <a:p>
-                      <a:pPr>
-                        <a:defRPr sz="840">
-                          <a:solidFill>
-                            <a:srgbClr val="F7FAFC"/>
-                          </a:solidFill>
-                          <a:latin typeface="Aptos"/>
-                        </a:defRPr>
-                      </a:pPr>
-                      <a:r>
-                        <a:t>Ciena</a:t>
-                      </a:r>
-                    </a:p>
-                  </a:txBody>
-                  <a:tcPr marL="54864" marR="36576" marT="22860" marB="18288">
-                    <a:solidFill>
-                      <a:srgbClr val="152446"/>
-                    </a:solidFill>
-                  </a:tcPr>
-                </a:tc>
-                <a:tc>
-                  <a:txBody>
-                    <a:bodyPr wrap="square" anchor="ctr"/>
-                    <a:lstStyle/>
-                    <a:p>
-                      <a:pPr>
-                        <a:defRPr sz="840">
-                          <a:solidFill>
-                            <a:srgbClr val="F7FAFC"/>
-                          </a:solidFill>
-                          <a:latin typeface="Aptos"/>
-                        </a:defRPr>
-                      </a:pPr>
-                      <a:r>
-                        <a:t>3949 Router</a:t>
-                      </a:r>
-                    </a:p>
-                  </a:txBody>
-                  <a:tcPr marL="54864" marR="36576" marT="22860" marB="18288">
-                    <a:solidFill>
-                      <a:srgbClr val="152446"/>
-                    </a:solidFill>
-                  </a:tcPr>
-                </a:tc>
-                <a:tc>
-                  <a:txBody>
-                    <a:bodyPr wrap="square" anchor="ctr"/>
-                    <a:lstStyle/>
-                    <a:p>
-                      <a:pPr>
-                        <a:defRPr sz="840">
-                          <a:solidFill>
-                            <a:srgbClr val="F7FAFC"/>
-                          </a:solidFill>
-                          <a:latin typeface="Aptos"/>
-                        </a:defRPr>
-                      </a:pPr>
-                      <a:r>
-                        <a:t>Define</a:t>
-                      </a:r>
-                    </a:p>
-                  </a:txBody>
-                  <a:tcPr marL="54864" marR="36576" marT="22860" marB="18288">
-                    <a:solidFill>
-                      <a:srgbClr val="152446"/>
-                    </a:solidFill>
-                  </a:tcPr>
-                </a:tc>
-                <a:tc>
-                  <a:txBody>
-                    <a:bodyPr wrap="square" anchor="ctr"/>
-                    <a:lstStyle/>
-                    <a:p>
-                      <a:pPr>
-                        <a:defRPr sz="840">
-                          <a:solidFill>
-                            <a:srgbClr val="F7FAFC"/>
-                          </a:solidFill>
-                          <a:latin typeface="Aptos"/>
-                        </a:defRPr>
-                      </a:pPr>
-                      <a:r>
-                        <a:t>25%</a:t>
-                      </a:r>
-                    </a:p>
-                  </a:txBody>
-                  <a:tcPr marL="54864" marR="36576" marT="22860" marB="18288">
-                    <a:solidFill>
-                      <a:srgbClr val="152446"/>
-                    </a:solidFill>
-                  </a:tcPr>
-                </a:tc>
-                <a:tc>
-                  <a:txBody>
-                    <a:bodyPr wrap="square" anchor="ctr"/>
-                    <a:lstStyle/>
-                    <a:p>
-                      <a:pPr>
-                        <a:defRPr sz="840">
-                          <a:solidFill>
-                            <a:srgbClr val="F7FAFC"/>
-                          </a:solidFill>
-                          <a:latin typeface="Aptos"/>
-                        </a:defRPr>
-                      </a:pPr>
-                      <a:r>
-                        <a:t>15 Nov 2026</a:t>
-                      </a:r>
-                    </a:p>
-                  </a:txBody>
-                  <a:tcPr marL="54864" marR="36576" marT="22860" marB="18288">
-                    <a:solidFill>
-                      <a:srgbClr val="152446"/>
-                    </a:solidFill>
-                  </a:tcPr>
-                </a:tc>
-                <a:tc>
-                  <a:txBody>
-                    <a:bodyPr wrap="square" anchor="ctr"/>
-                    <a:lstStyle/>
-                    <a:p>
-                      <a:pPr>
-                        <a:defRPr sz="840">
-                          <a:solidFill>
-                            <a:srgbClr val="F7FAFC"/>
-                          </a:solidFill>
-                          <a:latin typeface="Aptos"/>
-                        </a:defRPr>
-                      </a:pPr>
-                      <a:r>
-                        <a:t>128K</a:t>
-                      </a:r>
-                    </a:p>
-                  </a:txBody>
-                  <a:tcPr marL="54864" marR="36576" marT="22860" marB="18288">
-                    <a:solidFill>
-                      <a:srgbClr val="152446"/>
-                    </a:solidFill>
-                  </a:tcPr>
-                </a:tc>
-                <a:tc>
-                  <a:txBody>
-                    <a:bodyPr wrap="square" anchor="ctr"/>
-                    <a:lstStyle/>
-                    <a:p>
-                      <a:pPr>
-                        <a:defRPr sz="840">
-                          <a:solidFill>
-                            <a:srgbClr val="F7FAFC"/>
-                          </a:solidFill>
-                          <a:latin typeface="Aptos"/>
-                        </a:defRPr>
-                      </a:pPr>
-                      <a:r>
-                        <a:t>Freeze architecture/BOM and evaluation plan</a:t>
-                      </a:r>
-                    </a:p>
-                  </a:txBody>
-                  <a:tcPr marL="54864" marR="36576" marT="22860" marB="18288">
-                    <a:solidFill>
-                      <a:srgbClr val="152446"/>
-                    </a:solidFill>
-                  </a:tcPr>
-                </a:tc>
-              </a:tr>
-              <a:tr h="270510">
-                <a:tc>
-                  <a:txBody>
-                    <a:bodyPr wrap="square" anchor="ctr"/>
-                    <a:lstStyle/>
-                    <a:p>
-                      <a:pPr>
-                        <a:defRPr sz="840">
-                          <a:solidFill>
-                            <a:srgbClr val="F7FAFC"/>
-                          </a:solidFill>
-                          <a:latin typeface="Aptos"/>
-                        </a:defRPr>
-                      </a:pPr>
-                      <a:r>
-                        <a:t>Ciena</a:t>
-                      </a:r>
-                    </a:p>
-                  </a:txBody>
-                  <a:tcPr marL="54864" marR="36576" marT="22860" marB="18288">
-                    <a:solidFill>
-                      <a:srgbClr val="111C3A"/>
-                    </a:solidFill>
-                  </a:tcPr>
-                </a:tc>
-                <a:tc>
-                  <a:txBody>
-                    <a:bodyPr wrap="square" anchor="ctr"/>
-                    <a:lstStyle/>
-                    <a:p>
-                      <a:pPr>
-                        <a:defRPr sz="840">
-                          <a:solidFill>
-                            <a:srgbClr val="F7FAFC"/>
-                          </a:solidFill>
-                          <a:latin typeface="Aptos"/>
-                        </a:defRPr>
-                      </a:pPr>
-                      <a:r>
-                        <a:t>5136_Aggregation Router</a:t>
-                      </a:r>
-                    </a:p>
-                  </a:txBody>
-                  <a:tcPr marL="54864" marR="36576" marT="22860" marB="18288">
-                    <a:solidFill>
-                      <a:srgbClr val="111C3A"/>
-                    </a:solidFill>
-                  </a:tcPr>
-                </a:tc>
-                <a:tc>
-                  <a:txBody>
-                    <a:bodyPr wrap="square" anchor="ctr"/>
-                    <a:lstStyle/>
-                    <a:p>
-                      <a:pPr>
-                        <a:defRPr sz="840">
-                          <a:solidFill>
-                            <a:srgbClr val="F7FAFC"/>
-                          </a:solidFill>
-                          <a:latin typeface="Aptos"/>
-                        </a:defRPr>
-                      </a:pPr>
-                      <a:r>
-                        <a:t>Define</a:t>
-                      </a:r>
-                    </a:p>
-                  </a:txBody>
-                  <a:tcPr marL="54864" marR="36576" marT="22860" marB="18288">
-                    <a:solidFill>
-                      <a:srgbClr val="111C3A"/>
-                    </a:solidFill>
-                  </a:tcPr>
-                </a:tc>
-                <a:tc>
-                  <a:txBody>
-                    <a:bodyPr wrap="square" anchor="ctr"/>
-                    <a:lstStyle/>
-                    <a:p>
-                      <a:pPr>
-                        <a:defRPr sz="840">
-                          <a:solidFill>
-                            <a:srgbClr val="F7FAFC"/>
-                          </a:solidFill>
-                          <a:latin typeface="Aptos"/>
-                        </a:defRPr>
-                      </a:pPr>
-                      <a:r>
-                        <a:t>25%</a:t>
-                      </a:r>
-                    </a:p>
-                  </a:txBody>
-                  <a:tcPr marL="54864" marR="36576" marT="22860" marB="18288">
-                    <a:solidFill>
-                      <a:srgbClr val="111C3A"/>
-                    </a:solidFill>
-                  </a:tcPr>
-                </a:tc>
-                <a:tc>
-                  <a:txBody>
-                    <a:bodyPr wrap="square" anchor="ctr"/>
-                    <a:lstStyle/>
-                    <a:p>
-                      <a:pPr>
-                        <a:defRPr sz="840">
-                          <a:solidFill>
-                            <a:srgbClr val="F7FAFC"/>
-                          </a:solidFill>
-                          <a:latin typeface="Aptos"/>
-                        </a:defRPr>
-                      </a:pPr>
-                      <a:r>
-                        <a:t>21 Nov 2026</a:t>
-                      </a:r>
-                    </a:p>
-                  </a:txBody>
-                  <a:tcPr marL="54864" marR="36576" marT="22860" marB="18288">
-                    <a:solidFill>
-                      <a:srgbClr val="111C3A"/>
-                    </a:solidFill>
-                  </a:tcPr>
-                </a:tc>
-                <a:tc>
-                  <a:txBody>
-                    <a:bodyPr wrap="square" anchor="ctr"/>
-                    <a:lstStyle/>
-                    <a:p>
-                      <a:pPr>
-                        <a:defRPr sz="840">
-                          <a:solidFill>
-                            <a:srgbClr val="F7FAFC"/>
-                          </a:solidFill>
-                          <a:latin typeface="Aptos"/>
-                        </a:defRPr>
-                      </a:pPr>
-                      <a:r>
-                        <a:t>492K</a:t>
-                      </a:r>
-                    </a:p>
-                  </a:txBody>
-                  <a:tcPr marL="54864" marR="36576" marT="22860" marB="18288">
-                    <a:solidFill>
-                      <a:srgbClr val="111C3A"/>
-                    </a:solidFill>
-                  </a:tcPr>
-                </a:tc>
-                <a:tc>
-                  <a:txBody>
-                    <a:bodyPr wrap="square" anchor="ctr"/>
-                    <a:lstStyle/>
-                    <a:p>
-                      <a:pPr>
-                        <a:defRPr sz="840">
-                          <a:solidFill>
-                            <a:srgbClr val="F7FAFC"/>
-                          </a:solidFill>
-                          <a:latin typeface="Aptos"/>
-                        </a:defRPr>
-                      </a:pPr>
-                      <a:r>
-                        <a:t>Freeze architecture/BOM and evaluation plan</a:t>
-                      </a:r>
-                    </a:p>
-                  </a:txBody>
-                  <a:tcPr marL="54864" marR="36576" marT="22860" marB="18288">
-                    <a:solidFill>
-                      <a:srgbClr val="111C3A"/>
-                    </a:solidFill>
-                  </a:tcPr>
-                </a:tc>
-              </a:tr>
-              <a:tr h="270510">
-                <a:tc>
-                  <a:txBody>
-                    <a:bodyPr wrap="square" anchor="ctr"/>
-                    <a:lstStyle/>
-                    <a:p>
-                      <a:pPr>
-                        <a:defRPr sz="840">
-                          <a:solidFill>
-                            <a:srgbClr val="F7FAFC"/>
-                          </a:solidFill>
-                          <a:latin typeface="Aptos"/>
-                        </a:defRPr>
-                      </a:pPr>
-                      <a:r>
-                        <a:t>GE HealthCare</a:t>
-                      </a:r>
-                    </a:p>
-                  </a:txBody>
-                  <a:tcPr marL="54864" marR="36576" marT="22860" marB="18288">
-                    <a:solidFill>
-                      <a:srgbClr val="152446"/>
-                    </a:solidFill>
-                  </a:tcPr>
-                </a:tc>
-                <a:tc>
-                  <a:txBody>
-                    <a:bodyPr wrap="square" anchor="ctr"/>
-                    <a:lstStyle/>
-                    <a:p>
-                      <a:pPr>
-                        <a:defRPr sz="840">
-                          <a:solidFill>
-                            <a:srgbClr val="F7FAFC"/>
-                          </a:solidFill>
-                          <a:latin typeface="Aptos"/>
-                        </a:defRPr>
-                      </a:pPr>
-                      <a:r>
-                        <a:t>SP-PDU CONTROL BOARD</a:t>
-                      </a:r>
-                    </a:p>
-                  </a:txBody>
-                  <a:tcPr marL="54864" marR="36576" marT="22860" marB="18288">
-                    <a:solidFill>
-                      <a:srgbClr val="152446"/>
-                    </a:solidFill>
-                  </a:tcPr>
-                </a:tc>
-                <a:tc>
-                  <a:txBody>
-                    <a:bodyPr wrap="square" anchor="ctr"/>
-                    <a:lstStyle/>
-                    <a:p>
-                      <a:pPr>
-                        <a:defRPr sz="840">
-                          <a:solidFill>
-                            <a:srgbClr val="F7FAFC"/>
-                          </a:solidFill>
-                          <a:latin typeface="Aptos"/>
-                        </a:defRPr>
-                      </a:pPr>
-                      <a:r>
-                        <a:t>Define</a:t>
-                      </a:r>
-                    </a:p>
-                  </a:txBody>
-                  <a:tcPr marL="54864" marR="36576" marT="22860" marB="18288">
-                    <a:solidFill>
-                      <a:srgbClr val="152446"/>
-                    </a:solidFill>
-                  </a:tcPr>
-                </a:tc>
-                <a:tc>
-                  <a:txBody>
-                    <a:bodyPr wrap="square" anchor="ctr"/>
-                    <a:lstStyle/>
-                    <a:p>
-                      <a:pPr>
-                        <a:defRPr sz="840">
-                          <a:solidFill>
-                            <a:srgbClr val="F7FAFC"/>
-                          </a:solidFill>
-                          <a:latin typeface="Aptos"/>
-                        </a:defRPr>
-                      </a:pPr>
-                      <a:r>
-                        <a:t>15%</a:t>
-                      </a:r>
-                    </a:p>
-                  </a:txBody>
-                  <a:tcPr marL="54864" marR="36576" marT="22860" marB="18288">
-                    <a:solidFill>
-                      <a:srgbClr val="152446"/>
-                    </a:solidFill>
-                  </a:tcPr>
-                </a:tc>
-                <a:tc>
-                  <a:txBody>
-                    <a:bodyPr wrap="square" anchor="ctr"/>
-                    <a:lstStyle/>
-                    <a:p>
-                      <a:pPr>
-                        <a:defRPr sz="840">
-                          <a:solidFill>
-                            <a:srgbClr val="F7FAFC"/>
-                          </a:solidFill>
-                          <a:latin typeface="Aptos"/>
-                        </a:defRPr>
-                      </a:pPr>
-                      <a:r>
-                        <a:t>25 Nov 2026</a:t>
-                      </a:r>
-                    </a:p>
-                  </a:txBody>
-                  <a:tcPr marL="54864" marR="36576" marT="22860" marB="18288">
-                    <a:solidFill>
-                      <a:srgbClr val="152446"/>
-                    </a:solidFill>
-                  </a:tcPr>
-                </a:tc>
-                <a:tc>
-                  <a:txBody>
-                    <a:bodyPr wrap="square" anchor="ctr"/>
-                    <a:lstStyle/>
-                    <a:p>
-                      <a:pPr>
-                        <a:defRPr sz="840">
-                          <a:solidFill>
-                            <a:srgbClr val="F7FAFC"/>
-                          </a:solidFill>
-                          <a:latin typeface="Aptos"/>
-                        </a:defRPr>
-                      </a:pPr>
-                      <a:r>
-                        <a:t>110K</a:t>
-                      </a:r>
-                    </a:p>
-                  </a:txBody>
-                  <a:tcPr marL="54864" marR="36576" marT="22860" marB="18288">
-                    <a:solidFill>
-                      <a:srgbClr val="152446"/>
-                    </a:solidFill>
-                  </a:tcPr>
-                </a:tc>
-                <a:tc>
-                  <a:txBody>
-                    <a:bodyPr wrap="square" anchor="ctr"/>
-                    <a:lstStyle/>
-                    <a:p>
-                      <a:pPr>
-                        <a:defRPr sz="840">
-                          <a:solidFill>
-                            <a:srgbClr val="F7FAFC"/>
-                          </a:solidFill>
-                          <a:latin typeface="Aptos"/>
-                        </a:defRPr>
-                      </a:pPr>
-                      <a:r>
-                        <a:t>Freeze architecture/BOM and evaluation plan</a:t>
-                      </a:r>
-                    </a:p>
-                  </a:txBody>
-                  <a:tcPr marL="54864" marR="36576" marT="22860" marB="18288">
-                    <a:solidFill>
-                      <a:srgbClr val="152446"/>
-                    </a:solidFill>
-                  </a:tcPr>
-                </a:tc>
-              </a:tr>
-              <a:tr h="270510">
-                <a:tc>
-                  <a:txBody>
-                    <a:bodyPr wrap="square" anchor="ctr"/>
-                    <a:lstStyle/>
-                    <a:p>
-                      <a:pPr>
-                        <a:defRPr sz="840">
-                          <a:solidFill>
-                            <a:srgbClr val="F7FAFC"/>
-                          </a:solidFill>
-                          <a:latin typeface="Aptos"/>
-                        </a:defRPr>
-                      </a:pPr>
-                      <a:r>
-                        <a:t>Honeywell Tech.</a:t>
-                      </a:r>
-                    </a:p>
-                  </a:txBody>
-                  <a:tcPr marL="54864" marR="36576" marT="22860" marB="18288">
-                    <a:solidFill>
-                      <a:srgbClr val="111C3A"/>
-                    </a:solidFill>
-                  </a:tcPr>
-                </a:tc>
-                <a:tc>
-                  <a:txBody>
-                    <a:bodyPr wrap="square" anchor="ctr"/>
-                    <a:lstStyle/>
-                    <a:p>
-                      <a:pPr>
-                        <a:defRPr sz="840">
-                          <a:solidFill>
-                            <a:srgbClr val="F7FAFC"/>
-                          </a:solidFill>
-                          <a:latin typeface="Aptos"/>
-                        </a:defRPr>
-                      </a:pPr>
-                      <a:r>
-                        <a:t>Industrial automation controller - Process manager</a:t>
-                      </a:r>
-                    </a:p>
-                  </a:txBody>
-                  <a:tcPr marL="54864" marR="36576" marT="22860" marB="18288">
-                    <a:solidFill>
-                      <a:srgbClr val="111C3A"/>
-                    </a:solidFill>
-                  </a:tcPr>
-                </a:tc>
-                <a:tc>
-                  <a:txBody>
-                    <a:bodyPr wrap="square" anchor="ctr"/>
-                    <a:lstStyle/>
-                    <a:p>
-                      <a:pPr>
-                        <a:defRPr sz="840">
-                          <a:solidFill>
-                            <a:srgbClr val="F7FAFC"/>
-                          </a:solidFill>
-                          <a:latin typeface="Aptos"/>
-                        </a:defRPr>
-                      </a:pPr>
-                      <a:r>
-                        <a:t>Design</a:t>
-                      </a:r>
-                    </a:p>
-                  </a:txBody>
-                  <a:tcPr marL="54864" marR="36576" marT="22860" marB="18288">
-                    <a:solidFill>
-                      <a:srgbClr val="111C3A"/>
-                    </a:solidFill>
-                  </a:tcPr>
-                </a:tc>
-                <a:tc>
-                  <a:txBody>
-                    <a:bodyPr wrap="square" anchor="ctr"/>
-                    <a:lstStyle/>
-                    <a:p>
-                      <a:pPr>
-                        <a:defRPr sz="840">
-                          <a:solidFill>
-                            <a:srgbClr val="F7FAFC"/>
-                          </a:solidFill>
-                          <a:latin typeface="Aptos"/>
-                        </a:defRPr>
-                      </a:pPr>
-                      <a:r>
-                        <a:t>75%</a:t>
-                      </a:r>
-                    </a:p>
-                  </a:txBody>
-                  <a:tcPr marL="54864" marR="36576" marT="22860" marB="18288">
-                    <a:solidFill>
-                      <a:srgbClr val="111C3A"/>
-                    </a:solidFill>
-                  </a:tcPr>
-                </a:tc>
-                <a:tc>
-                  <a:txBody>
-                    <a:bodyPr wrap="square" anchor="ctr"/>
-                    <a:lstStyle/>
-                    <a:p>
-                      <a:pPr>
-                        <a:defRPr sz="840">
-                          <a:solidFill>
-                            <a:srgbClr val="F7FAFC"/>
-                          </a:solidFill>
-                          <a:latin typeface="Aptos"/>
-                        </a:defRPr>
-                      </a:pPr>
-                      <a:r>
-                        <a:t>30 Nov 2026</a:t>
-                      </a:r>
-                    </a:p>
-                  </a:txBody>
-                  <a:tcPr marL="54864" marR="36576" marT="22860" marB="18288">
-                    <a:solidFill>
-                      <a:srgbClr val="111C3A"/>
-                    </a:solidFill>
-                  </a:tcPr>
-                </a:tc>
-                <a:tc>
-                  <a:txBody>
-                    <a:bodyPr wrap="square" anchor="ctr"/>
-                    <a:lstStyle/>
-                    <a:p>
-                      <a:pPr>
-                        <a:defRPr sz="840">
-                          <a:solidFill>
-                            <a:srgbClr val="F7FAFC"/>
-                          </a:solidFill>
-                          <a:latin typeface="Aptos"/>
-                        </a:defRPr>
-                      </a:pPr>
-                      <a:r>
-                        <a:t>25K</a:t>
-                      </a:r>
-                    </a:p>
-                  </a:txBody>
-                  <a:tcPr marL="54864" marR="36576" marT="22860" marB="18288">
-                    <a:solidFill>
-                      <a:srgbClr val="111C3A"/>
-                    </a:solidFill>
-                  </a:tcPr>
-                </a:tc>
-                <a:tc>
-                  <a:txBody>
-                    <a:bodyPr wrap="square" anchor="ctr"/>
-                    <a:lstStyle/>
-                    <a:p>
-                      <a:pPr>
-                        <a:defRPr sz="840">
-                          <a:solidFill>
-                            <a:srgbClr val="F7FAFC"/>
-                          </a:solidFill>
-                          <a:latin typeface="Aptos"/>
-                        </a:defRPr>
-                      </a:pPr>
-                      <a:r>
-                        <a:t>Secure DW evidence and production handoff</a:t>
-                      </a:r>
-                    </a:p>
-                  </a:txBody>
-                  <a:tcPr marL="54864" marR="36576" marT="22860" marB="18288">
-                    <a:solidFill>
-                      <a:srgbClr val="111C3A"/>
-                    </a:solidFill>
-                  </a:tcPr>
-                </a:tc>
-              </a:tr>
-              <a:tr h="270510">
-                <a:tc>
-                  <a:txBody>
-                    <a:bodyPr wrap="square" anchor="ctr"/>
-                    <a:lstStyle/>
-                    <a:p>
-                      <a:pPr>
-                        <a:defRPr sz="840">
-                          <a:solidFill>
-                            <a:srgbClr val="F7FAFC"/>
-                          </a:solidFill>
-                          <a:latin typeface="Aptos"/>
-                        </a:defRPr>
-                      </a:pPr>
-                      <a:r>
-                        <a:t>Emerson</a:t>
-                      </a:r>
-                    </a:p>
-                  </a:txBody>
-                  <a:tcPr marL="54864" marR="36576" marT="22860" marB="18288">
-                    <a:solidFill>
-                      <a:srgbClr val="152446"/>
-                    </a:solidFill>
-                  </a:tcPr>
-                </a:tc>
-                <a:tc>
-                  <a:txBody>
-                    <a:bodyPr wrap="square" anchor="ctr"/>
-                    <a:lstStyle/>
-                    <a:p>
-                      <a:pPr>
-                        <a:defRPr sz="840">
-                          <a:solidFill>
-                            <a:srgbClr val="F7FAFC"/>
-                          </a:solidFill>
-                          <a:latin typeface="Aptos"/>
-                        </a:defRPr>
-                      </a:pPr>
-                      <a:r>
-                        <a:t>RX3i CEP002</a:t>
-                      </a:r>
-                    </a:p>
-                  </a:txBody>
-                  <a:tcPr marL="54864" marR="36576" marT="22860" marB="18288">
-                    <a:solidFill>
-                      <a:srgbClr val="152446"/>
-                    </a:solidFill>
-                  </a:tcPr>
-                </a:tc>
-                <a:tc>
-                  <a:txBody>
-                    <a:bodyPr wrap="square" anchor="ctr"/>
-                    <a:lstStyle/>
-                    <a:p>
-                      <a:pPr>
-                        <a:defRPr sz="840">
-                          <a:solidFill>
-                            <a:srgbClr val="F7FAFC"/>
-                          </a:solidFill>
-                          <a:latin typeface="Aptos"/>
-                        </a:defRPr>
-                      </a:pPr>
-                      <a:r>
-                        <a:t>Define</a:t>
-                      </a:r>
-                    </a:p>
-                  </a:txBody>
-                  <a:tcPr marL="54864" marR="36576" marT="22860" marB="18288">
-                    <a:solidFill>
-                      <a:srgbClr val="152446"/>
-                    </a:solidFill>
-                  </a:tcPr>
-                </a:tc>
-                <a:tc>
-                  <a:txBody>
-                    <a:bodyPr wrap="square" anchor="ctr"/>
-                    <a:lstStyle/>
-                    <a:p>
-                      <a:pPr>
-                        <a:defRPr sz="840">
-                          <a:solidFill>
-                            <a:srgbClr val="F7FAFC"/>
-                          </a:solidFill>
-                          <a:latin typeface="Aptos"/>
-                        </a:defRPr>
-                      </a:pPr>
-                      <a:r>
-                        <a:t>25%</a:t>
-                      </a:r>
-                    </a:p>
-                  </a:txBody>
-                  <a:tcPr marL="54864" marR="36576" marT="22860" marB="18288">
-                    <a:solidFill>
-                      <a:srgbClr val="152446"/>
-                    </a:solidFill>
-                  </a:tcPr>
-                </a:tc>
-                <a:tc>
-                  <a:txBody>
-                    <a:bodyPr wrap="square" anchor="ctr"/>
-                    <a:lstStyle/>
-                    <a:p>
-                      <a:pPr>
-                        <a:defRPr sz="840">
-                          <a:solidFill>
-                            <a:srgbClr val="F7FAFC"/>
-                          </a:solidFill>
-                          <a:latin typeface="Aptos"/>
-                        </a:defRPr>
-                      </a:pPr>
-                      <a:r>
-                        <a:t>16 Dec 2026</a:t>
-                      </a:r>
-                    </a:p>
-                  </a:txBody>
-                  <a:tcPr marL="54864" marR="36576" marT="22860" marB="18288">
-                    <a:solidFill>
-                      <a:srgbClr val="152446"/>
-                    </a:solidFill>
-                  </a:tcPr>
-                </a:tc>
-                <a:tc>
-                  <a:txBody>
-                    <a:bodyPr wrap="square" anchor="ctr"/>
-                    <a:lstStyle/>
-                    <a:p>
-                      <a:pPr>
-                        <a:defRPr sz="840">
-                          <a:solidFill>
-                            <a:srgbClr val="F7FAFC"/>
-                          </a:solidFill>
-                          <a:latin typeface="Aptos"/>
-                        </a:defRPr>
-                      </a:pPr>
-                      <a:r>
-                        <a:t>775K</a:t>
-                      </a:r>
-                    </a:p>
-                  </a:txBody>
-                  <a:tcPr marL="54864" marR="36576" marT="22860" marB="18288">
-                    <a:solidFill>
-                      <a:srgbClr val="152446"/>
-                    </a:solidFill>
-                  </a:tcPr>
-                </a:tc>
-                <a:tc>
-                  <a:txBody>
-                    <a:bodyPr wrap="square" anchor="ctr"/>
-                    <a:lstStyle/>
-                    <a:p>
-                      <a:pPr>
-                        <a:defRPr sz="840">
-                          <a:solidFill>
-                            <a:srgbClr val="F7FAFC"/>
-                          </a:solidFill>
-                          <a:latin typeface="Aptos"/>
-                        </a:defRPr>
-                      </a:pPr>
-                      <a:r>
-                        <a:t>Freeze architecture/BOM and evaluation plan</a:t>
-                      </a:r>
-                    </a:p>
-                  </a:txBody>
-                  <a:tcPr marL="54864" marR="36576" marT="22860" marB="18288">
-                    <a:solidFill>
-                      <a:srgbClr val="152446"/>
-                    </a:solidFill>
-                  </a:tcPr>
-                </a:tc>
-              </a:tr>
-              <a:tr h="270510">
-                <a:tc>
-                  <a:txBody>
-                    <a:bodyPr wrap="square" anchor="ctr"/>
-                    <a:lstStyle/>
-                    <a:p>
-                      <a:pPr>
-                        <a:defRPr sz="840">
-                          <a:solidFill>
-                            <a:srgbClr val="F7FAFC"/>
-                          </a:solidFill>
-                          <a:latin typeface="Aptos"/>
-                        </a:defRPr>
-                      </a:pPr>
-                      <a:r>
-                        <a:t>Ciena</a:t>
-                      </a:r>
-                    </a:p>
-                  </a:txBody>
-                  <a:tcPr marL="54864" marR="36576" marT="22860" marB="18288">
-                    <a:solidFill>
-                      <a:srgbClr val="111C3A"/>
-                    </a:solidFill>
-                  </a:tcPr>
-                </a:tc>
-                <a:tc>
-                  <a:txBody>
-                    <a:bodyPr wrap="square" anchor="ctr"/>
-                    <a:lstStyle/>
-                    <a:p>
-                      <a:pPr>
-                        <a:defRPr sz="840">
-                          <a:solidFill>
-                            <a:srgbClr val="F7FAFC"/>
-                          </a:solidFill>
-                          <a:latin typeface="Aptos"/>
-                        </a:defRPr>
-                      </a:pPr>
-                      <a:r>
-                        <a:t>NID _ Network Interface Device_OTN</a:t>
-                      </a:r>
-                    </a:p>
-                  </a:txBody>
-                  <a:tcPr marL="54864" marR="36576" marT="22860" marB="18288">
-                    <a:solidFill>
-                      <a:srgbClr val="111C3A"/>
-                    </a:solidFill>
-                  </a:tcPr>
-                </a:tc>
-                <a:tc>
-                  <a:txBody>
-                    <a:bodyPr wrap="square" anchor="ctr"/>
-                    <a:lstStyle/>
-                    <a:p>
-                      <a:pPr>
-                        <a:defRPr sz="840">
-                          <a:solidFill>
-                            <a:srgbClr val="F7FAFC"/>
-                          </a:solidFill>
-                          <a:latin typeface="Aptos"/>
-                        </a:defRPr>
-                      </a:pPr>
-                      <a:r>
-                        <a:t>Define</a:t>
-                      </a:r>
-                    </a:p>
-                  </a:txBody>
-                  <a:tcPr marL="54864" marR="36576" marT="22860" marB="18288">
-                    <a:solidFill>
-                      <a:srgbClr val="111C3A"/>
-                    </a:solidFill>
-                  </a:tcPr>
-                </a:tc>
-                <a:tc>
-                  <a:txBody>
-                    <a:bodyPr wrap="square" anchor="ctr"/>
-                    <a:lstStyle/>
-                    <a:p>
-                      <a:pPr>
-                        <a:defRPr sz="840">
-                          <a:solidFill>
-                            <a:srgbClr val="F7FAFC"/>
-                          </a:solidFill>
-                          <a:latin typeface="Aptos"/>
-                        </a:defRPr>
-                      </a:pPr>
-                      <a:r>
-                        <a:t>15%</a:t>
-                      </a:r>
-                    </a:p>
-                  </a:txBody>
-                  <a:tcPr marL="54864" marR="36576" marT="22860" marB="18288">
-                    <a:solidFill>
-                      <a:srgbClr val="111C3A"/>
-                    </a:solidFill>
-                  </a:tcPr>
-                </a:tc>
-                <a:tc>
-                  <a:txBody>
-                    <a:bodyPr wrap="square" anchor="ctr"/>
-                    <a:lstStyle/>
-                    <a:p>
-                      <a:pPr>
-                        <a:defRPr sz="840">
-                          <a:solidFill>
-                            <a:srgbClr val="F7FAFC"/>
-                          </a:solidFill>
-                          <a:latin typeface="Aptos"/>
-                        </a:defRPr>
-                      </a:pPr>
-                      <a:r>
-                        <a:t>24 Dec 2026</a:t>
-                      </a:r>
-                    </a:p>
-                  </a:txBody>
-                  <a:tcPr marL="54864" marR="36576" marT="22860" marB="18288">
-                    <a:solidFill>
-                      <a:srgbClr val="111C3A"/>
-                    </a:solidFill>
-                  </a:tcPr>
-                </a:tc>
-                <a:tc>
-                  <a:txBody>
-                    <a:bodyPr wrap="square" anchor="ctr"/>
-                    <a:lstStyle/>
-                    <a:p>
-                      <a:pPr>
-                        <a:defRPr sz="840">
-                          <a:solidFill>
-                            <a:srgbClr val="F7FAFC"/>
-                          </a:solidFill>
-                          <a:latin typeface="Aptos"/>
-                        </a:defRPr>
-                      </a:pPr>
-                      <a:r>
-                        <a:t>625K</a:t>
-                      </a:r>
-                    </a:p>
-                  </a:txBody>
-                  <a:tcPr marL="54864" marR="36576" marT="22860" marB="18288">
-                    <a:solidFill>
-                      <a:srgbClr val="111C3A"/>
-                    </a:solidFill>
-                  </a:tcPr>
-                </a:tc>
-                <a:tc>
-                  <a:txBody>
-                    <a:bodyPr wrap="square" anchor="ctr"/>
-                    <a:lstStyle/>
-                    <a:p>
-                      <a:pPr>
-                        <a:defRPr sz="840">
-                          <a:solidFill>
-                            <a:srgbClr val="F7FAFC"/>
-                          </a:solidFill>
-                          <a:latin typeface="Aptos"/>
-                        </a:defRPr>
-                      </a:pPr>
-                      <a:r>
-                        <a:t>Freeze architecture/BOM and evaluation plan</a:t>
-                      </a:r>
-                    </a:p>
-                  </a:txBody>
-                  <a:tcPr marL="54864" marR="36576" marT="22860" marB="18288">
-                    <a:solidFill>
-                      <a:srgbClr val="111C3A"/>
-                    </a:solidFill>
-                  </a:tcPr>
-                </a:tc>
-              </a:tr>
             </a:tbl>
           </a:graphicData>
         </a:graphic>
@@ -35973,7 +34819,7 @@
               </a:defRPr>
             </a:pPr>
             <a:r>
-              <a:t>Prepared 27 Jul 2026  •  Source: Sahil Report.xlsx  •  Values are in source units (currency not encoded)</a:t>
+              <a:t>Prepared 28 Jul 2026  •  Source values are in source units (currency not encoded)</a:t>
             </a:r>
           </a:p>
         </p:txBody>
@@ -37806,7 +36652,7 @@
               </a:defRPr>
             </a:pPr>
             <a:r>
-              <a:t>Prepared 27 Jul 2026  •  Source: Sahil Report.xlsx  •  Values are in source units (currency not encoded)</a:t>
+              <a:t>Prepared 28 Jul 2026  •  Source values are in source units (currency not encoded)</a:t>
             </a:r>
           </a:p>
         </p:txBody>
@@ -39833,7 +38679,7 @@
               </a:defRPr>
             </a:pPr>
             <a:r>
-              <a:t>Prepared 27 Jul 2026  •  Source: Sahil Report.xlsx  •  Values are in source units (currency not encoded)</a:t>
+              <a:t>Prepared 28 Jul 2026  •  Source values are in source units (currency not encoded)</a:t>
             </a:r>
           </a:p>
         </p:txBody>
@@ -41636,7 +40482,7 @@
               </a:defRPr>
             </a:pPr>
             <a:r>
-              <a:t>Q4 2026 / 2027 account plans: convert now, then expand adjacencies</a:t>
+              <a:t>Q4 FY2026 / FY2027 account plans: convert, then expand</a:t>
             </a:r>
           </a:p>
         </p:txBody>
@@ -41751,7 +40597,7 @@
               </a:defRPr>
             </a:pPr>
             <a:r>
-              <a:t>Prepared 27 Jul 2026  •  Source: Sahil Report.xlsx  •  Values are in source units (currency not encoded)</a:t>
+              <a:t>Prepared 28 Jul 2026  •  Source values are in source units (currency not encoded)</a:t>
             </a:r>
           </a:p>
         </p:txBody>
@@ -41843,7 +40689,7 @@
                         </a:defRPr>
                       </a:pPr>
                       <a:r>
-                        <a:t>Q4 2026 proposed focus</a:t>
+                        <a:t>Q4 FY2026 (Aug–Oct)</a:t>
                       </a:r>
                     </a:p>
                   </a:txBody>
@@ -41867,7 +40713,7 @@
                         </a:defRPr>
                       </a:pPr>
                       <a:r>
-                        <a:t>2027 proposed expansion</a:t>
+                        <a:t>FY2027 expansion (Nov–Oct)</a:t>
                       </a:r>
                     </a:p>
                   </a:txBody>
@@ -42235,7 +41081,7 @@
                         </a:defRPr>
                       </a:pPr>
                       <a:r>
-                        <a:t>Recover 2026 SP-PDU gate; define CT/anesthesia evaluations</a:t>
+                        <a:t>Recover SP-PDU gate; define CT/anesthesia evaluations</a:t>
                       </a:r>
                     </a:p>
                   </a:txBody>

</xml_diff>

<commit_message>
Add total open pipeline snapshot
Co-authored-by: Sahil Patni <sahilpat28@users.noreply.github.com>
</commit_message>
<xml_diff>
--- a/qbr/output/Sahil_QBR_2026-07-29.pptx
+++ b/qbr/output/Sahil_QBR_2026-07-29.pptx
@@ -3428,7 +3428,7 @@
               </a:defRPr>
             </a:pPr>
             <a:r>
-              <a:t>PIPELINE SNAPSHOT</a:t>
+              <a:t>SAHIL DIRECT SCOPE</a:t>
             </a:r>
           </a:p>
         </p:txBody>
@@ -18712,7 +18712,7 @@
               </a:defRPr>
             </a:pPr>
             <a:r>
-              <a:t>Executive snapshot: 10.45M qualified open; 3.94M outside exports</a:t>
+              <a:t>Pipeline snapshot: 17.3M FY2026 / 64.5M FY2027</a:t>
             </a:r>
           </a:p>
         </p:txBody>
@@ -18908,7 +18908,7 @@
               </a:defRPr>
             </a:pPr>
             <a:r>
-              <a:t>QUALIFIED OPEN</a:t>
+              <a:t>FY2026 TOTAL OPEN</a:t>
             </a:r>
           </a:p>
         </p:txBody>
@@ -18944,7 +18944,7 @@
               </a:defRPr>
             </a:pPr>
             <a:r>
-              <a:t>10.45M</a:t>
+              <a:t>17.3M</a:t>
             </a:r>
           </a:p>
         </p:txBody>
@@ -18980,7 +18980,7 @@
               </a:defRPr>
             </a:pPr>
             <a:r>
-              <a:t>18 opportunities</a:t>
+              <a:t>2 direct records • 2 customers</a:t>
             </a:r>
           </a:p>
         </p:txBody>
@@ -19061,7 +19061,7 @@
               </a:defRPr>
             </a:pPr>
             <a:r>
-              <a:t>WEIGHTED PIPELINE</a:t>
+              <a:t>FY2027 TOTAL OPEN</a:t>
             </a:r>
           </a:p>
         </p:txBody>
@@ -19097,7 +19097,7 @@
               </a:defRPr>
             </a:pPr>
             <a:r>
-              <a:t>3.00M</a:t>
+              <a:t>64.5M</a:t>
             </a:r>
           </a:p>
         </p:txBody>
@@ -19133,7 +19133,7 @@
               </a:defRPr>
             </a:pPr>
             <a:r>
-              <a:t>probability × peak</a:t>
+              <a:t>22 direct records • 7 customers</a:t>
             </a:r>
           </a:p>
         </p:txBody>
@@ -19214,7 +19214,7 @@
               </a:defRPr>
             </a:pPr>
             <a:r>
-              <a:t>FY2026 OPEN EXPORT</a:t>
+              <a:t>SAHIL DIRECT QUALIFIED</a:t>
             </a:r>
           </a:p>
         </p:txBody>
@@ -19250,7 +19250,7 @@
               </a:defRPr>
             </a:pPr>
             <a:r>
-              <a:t>4.25M</a:t>
+              <a:t>10.45M</a:t>
             </a:r>
           </a:p>
         </p:txBody>
@@ -19286,7 +19286,7 @@
               </a:defRPr>
             </a:pPr>
             <a:r>
-              <a:t>2 opportunities</a:t>
+              <a:t>18 distinct opportunities</a:t>
             </a:r>
           </a:p>
         </p:txBody>
@@ -19367,7 +19367,7 @@
               </a:defRPr>
             </a:pPr>
             <a:r>
-              <a:t>FY2027 OPEN EXPORT</a:t>
+              <a:t>SAHIL WEIGHTED</a:t>
             </a:r>
           </a:p>
         </p:txBody>
@@ -19403,7 +19403,7 @@
               </a:defRPr>
             </a:pPr>
             <a:r>
-              <a:t>6.19M</a:t>
+              <a:t>3.00M</a:t>
             </a:r>
           </a:p>
         </p:txBody>
@@ -19439,7 +19439,7 @@
               </a:defRPr>
             </a:pPr>
             <a:r>
-              <a:t>16 opportunities</a:t>
+              <a:t>probability × peak</a:t>
             </a:r>
           </a:p>
         </p:txBody>
@@ -19539,7 +19539,7 @@
               </a:defRPr>
             </a:pPr>
             <a:r>
-              <a:t>• 3.94M across 3 plays is outside both exports: 3.60M Identify + 338K Define.</a:t>
+              <a:t>• FY2026 splits into 4.25M direct + 13.09M channel.</a:t>
             </a:r>
           </a:p>
           <a:p>
@@ -19547,7 +19547,7 @@
               <a:spcAft>
                 <a:spcPts val="500"/>
               </a:spcAft>
-              <a:defRPr sz="1500" b="0">
+              <a:defRPr sz="1400" b="0">
                 <a:solidFill>
                   <a:srgbClr val="F7FAFC"/>
                 </a:solidFill>
@@ -19555,7 +19555,7 @@
               </a:defRPr>
             </a:pPr>
             <a:r>
-              <a:t>• Outdu AI is 4.12M (39% of qualified open value) but remains Define.</a:t>
+              <a:t>• FY2027 splits into 6.19M direct + 58.32M channel.</a:t>
             </a:r>
           </a:p>
           <a:p>
@@ -19563,7 +19563,7 @@
               <a:spcAft>
                 <a:spcPts val="500"/>
               </a:spcAft>
-              <a:defRPr sz="1500" b="0">
+              <a:defRPr sz="1400" b="0">
                 <a:solidFill>
                   <a:srgbClr val="F7FAFC"/>
                 </a:solidFill>
@@ -19571,7 +19571,7 @@
               </a:defRPr>
             </a:pPr>
             <a:r>
-              <a:t>• Q4 FY2026 (Aug–Oct) DWIN-dated pipeline is 4.95M; weighted value is 1.37M.</a:t>
+              <a:t>• The supplied “22 Altera Opportunity” is 22 source rows, consolidating to 16 distinct opportunity IDs.</a:t>
             </a:r>
           </a:p>
           <a:p>
@@ -19579,7 +19579,7 @@
               <a:spcAft>
                 <a:spcPts val="500"/>
               </a:spcAft>
-              <a:defRPr sz="1500" b="0">
+              <a:defRPr sz="1400" b="0">
                 <a:solidFill>
                   <a:srgbClr val="F7FAFC"/>
                 </a:solidFill>
@@ -19587,7 +19587,7 @@
               </a:defRPr>
             </a:pPr>
             <a:r>
-              <a:t>• Bucket membership comes from the uploaded files; it is not derived from Design Win Date.</a:t>
+              <a:t>• Sahil's direct scope is 10.45M across 18 distinct qualified opportunities; do not mix row counts and opportunity counts.</a:t>
             </a:r>
           </a:p>
         </p:txBody>
@@ -30628,7 +30628,7 @@
               </a:defRPr>
             </a:pPr>
             <a:r>
-              <a:t>FY2026 export</a:t>
+              <a:t>Sahil FY2026 direct</a:t>
             </a:r>
           </a:p>
         </p:txBody>
@@ -30700,7 +30700,7 @@
               </a:defRPr>
             </a:pPr>
             <a:r>
-              <a:t>FY2027 export</a:t>
+              <a:t>Sahil FY2027 direct</a:t>
             </a:r>
           </a:p>
         </p:txBody>

</xml_diff>

<commit_message>
Add FY2026 and FY2027 stage funnels
Co-authored-by: Sahil Patni <sahilpat28@users.noreply.github.com>
</commit_message>
<xml_diff>
--- a/qbr/output/Sahil_QBR_2026-07-29.pptx
+++ b/qbr/output/Sahil_QBR_2026-07-29.pptx
@@ -32199,7 +32199,7 @@
               </a:defRPr>
             </a:pPr>
             <a:r>
-              <a:t>Opportunity funnel: separate qualified open from 0% identification</a:t>
+              <a:t>Opportunity stage funnel: FY2026 versus FY2027</a:t>
             </a:r>
           </a:p>
         </p:txBody>
@@ -32321,96 +32321,24 @@
       </p:sp>
       <p:sp>
         <p:nvSpPr>
-          <p:cNvPr id="7" name="TextBox 6"/>
-          <p:cNvSpPr txBox="1"/>
-          <p:nvPr/>
-        </p:nvSpPr>
-        <p:spPr>
-          <a:xfrm>
-            <a:off x="566928" y="1399032"/>
-            <a:ext cx="1051560" cy="201168"/>
-          </a:xfrm>
-          <a:prstGeom prst="rect">
-            <a:avLst/>
-          </a:prstGeom>
-          <a:noFill/>
-        </p:spPr>
-        <p:txBody>
-          <a:bodyPr wrap="square" lIns="36576" rIns="36576" tIns="36576" bIns="36576" anchor="t">
-            <a:spAutoFit/>
-          </a:bodyPr>
-          <a:lstStyle/>
-          <a:p>
-            <a:pPr algn="l">
-              <a:defRPr sz="1200" b="1">
-                <a:solidFill>
-                  <a:srgbClr val="F7FAFC"/>
-                </a:solidFill>
-                <a:latin typeface="Aptos"/>
-              </a:defRPr>
-            </a:pPr>
-            <a:r>
-              <a:t>Identify</a:t>
-            </a:r>
-          </a:p>
-        </p:txBody>
-      </p:sp>
-      <p:sp>
-        <p:nvSpPr>
-          <p:cNvPr id="8" name="TextBox 7"/>
-          <p:cNvSpPr txBox="1"/>
-          <p:nvPr/>
-        </p:nvSpPr>
-        <p:spPr>
-          <a:xfrm>
-            <a:off x="1444752" y="1399032"/>
-            <a:ext cx="594360" cy="201168"/>
-          </a:xfrm>
-          <a:prstGeom prst="rect">
-            <a:avLst/>
-          </a:prstGeom>
-          <a:noFill/>
-        </p:spPr>
-        <p:txBody>
-          <a:bodyPr wrap="square" lIns="36576" rIns="36576" tIns="36576" bIns="36576" anchor="t">
-            <a:spAutoFit/>
-          </a:bodyPr>
-          <a:lstStyle/>
-          <a:p>
-            <a:pPr algn="l">
-              <a:defRPr sz="900" b="0">
-                <a:solidFill>
-                  <a:srgbClr val="A8B2C7"/>
-                </a:solidFill>
-                <a:latin typeface="Aptos"/>
-              </a:defRPr>
-            </a:pPr>
-            <a:r>
-              <a:t>2 opps</a:t>
-            </a:r>
-          </a:p>
-        </p:txBody>
-      </p:sp>
-      <p:sp>
-        <p:nvSpPr>
-          <p:cNvPr id="9" name="Rectangle 8"/>
+          <p:cNvPr id="7" name="Rounded Rectangle 6"/>
           <p:cNvSpPr/>
           <p:nvPr/>
         </p:nvSpPr>
         <p:spPr>
           <a:xfrm>
-            <a:off x="2148840" y="1325880"/>
-            <a:ext cx="5806440" cy="438912"/>
-          </a:xfrm>
-          <a:prstGeom prst="rect">
+            <a:off x="502920" y="1234440"/>
+            <a:ext cx="5468112" cy="4663440"/>
+          </a:xfrm>
+          <a:prstGeom prst="roundRect">
             <a:avLst/>
           </a:prstGeom>
           <a:solidFill>
-            <a:srgbClr val="152446"/>
+            <a:srgbClr val="14213D"/>
           </a:solidFill>
           <a:ln w="12700">
             <a:solidFill>
-              <a:srgbClr val="152446"/>
+              <a:srgbClr val="00B8A9"/>
             </a:solidFill>
           </a:ln>
         </p:spPr>
@@ -32438,23 +32366,169 @@
       </p:sp>
       <p:sp>
         <p:nvSpPr>
-          <p:cNvPr id="10" name="Rectangle 9"/>
+          <p:cNvPr id="8" name="TextBox 7"/>
+          <p:cNvSpPr txBox="1"/>
+          <p:nvPr/>
+        </p:nvSpPr>
+        <p:spPr>
+          <a:xfrm>
+            <a:off x="704088" y="1499616"/>
+            <a:ext cx="1920240" cy="219456"/>
+          </a:xfrm>
+          <a:prstGeom prst="rect">
+            <a:avLst/>
+          </a:prstGeom>
+          <a:noFill/>
+        </p:spPr>
+        <p:txBody>
+          <a:bodyPr wrap="square" lIns="36576" rIns="36576" tIns="36576" bIns="36576" anchor="t">
+            <a:spAutoFit/>
+          </a:bodyPr>
+          <a:lstStyle/>
+          <a:p>
+            <a:pPr algn="l">
+              <a:defRPr sz="1300" b="1">
+                <a:solidFill>
+                  <a:srgbClr val="00B8A9"/>
+                </a:solidFill>
+                <a:latin typeface="Aptos"/>
+              </a:defRPr>
+            </a:pPr>
+            <a:r>
+              <a:t>FY2026</a:t>
+            </a:r>
+          </a:p>
+        </p:txBody>
+      </p:sp>
+      <p:sp>
+        <p:nvSpPr>
+          <p:cNvPr id="9" name="TextBox 8"/>
+          <p:cNvSpPr txBox="1"/>
+          <p:nvPr/>
+        </p:nvSpPr>
+        <p:spPr>
+          <a:xfrm>
+            <a:off x="2606039" y="1463040"/>
+            <a:ext cx="1554480" cy="310896"/>
+          </a:xfrm>
+          <a:prstGeom prst="rect">
+            <a:avLst/>
+          </a:prstGeom>
+          <a:noFill/>
+        </p:spPr>
+        <p:txBody>
+          <a:bodyPr wrap="square" lIns="36576" rIns="36576" tIns="36576" bIns="36576" anchor="t">
+            <a:spAutoFit/>
+          </a:bodyPr>
+          <a:lstStyle/>
+          <a:p>
+            <a:pPr algn="r">
+              <a:defRPr sz="2100" b="1">
+                <a:solidFill>
+                  <a:srgbClr val="F7FAFC"/>
+                </a:solidFill>
+                <a:latin typeface="Aptos"/>
+              </a:defRPr>
+            </a:pPr>
+            <a:r>
+              <a:t>17.3M</a:t>
+            </a:r>
+          </a:p>
+        </p:txBody>
+      </p:sp>
+      <p:sp>
+        <p:nvSpPr>
+          <p:cNvPr id="10" name="TextBox 9"/>
+          <p:cNvSpPr txBox="1"/>
+          <p:nvPr/>
+        </p:nvSpPr>
+        <p:spPr>
+          <a:xfrm>
+            <a:off x="4251959" y="1536192"/>
+            <a:ext cx="1417320" cy="182880"/>
+          </a:xfrm>
+          <a:prstGeom prst="rect">
+            <a:avLst/>
+          </a:prstGeom>
+          <a:noFill/>
+        </p:spPr>
+        <p:txBody>
+          <a:bodyPr wrap="square" lIns="36576" rIns="36576" tIns="36576" bIns="36576" anchor="t">
+            <a:spAutoFit/>
+          </a:bodyPr>
+          <a:lstStyle/>
+          <a:p>
+            <a:pPr algn="r">
+              <a:defRPr sz="819" b="0">
+                <a:solidFill>
+                  <a:srgbClr val="A8B2C7"/>
+                </a:solidFill>
+                <a:latin typeface="Aptos"/>
+              </a:defRPr>
+            </a:pPr>
+            <a:r>
+              <a:t>20 distinct opps</a:t>
+            </a:r>
+          </a:p>
+        </p:txBody>
+      </p:sp>
+      <p:sp>
+        <p:nvSpPr>
+          <p:cNvPr id="11" name="TextBox 10"/>
+          <p:cNvSpPr txBox="1"/>
+          <p:nvPr/>
+        </p:nvSpPr>
+        <p:spPr>
+          <a:xfrm>
+            <a:off x="704088" y="2130551"/>
+            <a:ext cx="749808" cy="201168"/>
+          </a:xfrm>
+          <a:prstGeom prst="rect">
+            <a:avLst/>
+          </a:prstGeom>
+          <a:noFill/>
+        </p:spPr>
+        <p:txBody>
+          <a:bodyPr wrap="square" lIns="36576" rIns="36576" tIns="36576" bIns="36576" anchor="t">
+            <a:spAutoFit/>
+          </a:bodyPr>
+          <a:lstStyle/>
+          <a:p>
+            <a:pPr algn="l">
+              <a:defRPr sz="1050" b="1">
+                <a:solidFill>
+                  <a:srgbClr val="F7FAFC"/>
+                </a:solidFill>
+                <a:latin typeface="Aptos"/>
+              </a:defRPr>
+            </a:pPr>
+            <a:r>
+              <a:t>Define</a:t>
+            </a:r>
+          </a:p>
+        </p:txBody>
+      </p:sp>
+      <p:sp>
+        <p:nvSpPr>
+          <p:cNvPr id="12" name="Rectangle 11"/>
           <p:cNvSpPr/>
           <p:nvPr/>
         </p:nvSpPr>
         <p:spPr>
           <a:xfrm>
-            <a:off x="2148840" y="1325880"/>
-            <a:ext cx="2223141" cy="438912"/>
+            <a:off x="1490472" y="2103120"/>
+            <a:ext cx="2542032" cy="310896"/>
           </a:xfrm>
           <a:prstGeom prst="rect">
             <a:avLst/>
           </a:prstGeom>
           <a:solidFill>
-            <a:srgbClr val="FF5A5F"/>
+            <a:srgbClr val="152446"/>
           </a:solidFill>
-          <a:ln>
-            <a:noFill/>
+          <a:ln w="12700">
+            <a:solidFill>
+              <a:srgbClr val="152446"/>
+            </a:solidFill>
           </a:ln>
         </p:spPr>
         <p:style>
@@ -32481,169 +32555,23 @@
       </p:sp>
       <p:sp>
         <p:nvSpPr>
-          <p:cNvPr id="11" name="TextBox 10"/>
-          <p:cNvSpPr txBox="1"/>
-          <p:nvPr/>
-        </p:nvSpPr>
-        <p:spPr>
-          <a:xfrm>
-            <a:off x="8119872" y="1353312"/>
-            <a:ext cx="1051560" cy="219456"/>
-          </a:xfrm>
-          <a:prstGeom prst="rect">
-            <a:avLst/>
-          </a:prstGeom>
-          <a:noFill/>
-        </p:spPr>
-        <p:txBody>
-          <a:bodyPr wrap="square" lIns="36576" rIns="36576" tIns="36576" bIns="36576" anchor="t">
-            <a:spAutoFit/>
-          </a:bodyPr>
-          <a:lstStyle/>
-          <a:p>
-            <a:pPr algn="r">
-              <a:defRPr sz="1300" b="1">
-                <a:solidFill>
-                  <a:srgbClr val="F7FAFC"/>
-                </a:solidFill>
-                <a:latin typeface="Aptos"/>
-              </a:defRPr>
-            </a:pPr>
-            <a:r>
-              <a:t>3.60M</a:t>
-            </a:r>
-          </a:p>
-        </p:txBody>
-      </p:sp>
-      <p:sp>
-        <p:nvSpPr>
-          <p:cNvPr id="12" name="TextBox 11"/>
-          <p:cNvSpPr txBox="1"/>
-          <p:nvPr/>
-        </p:nvSpPr>
-        <p:spPr>
-          <a:xfrm>
-            <a:off x="9308592" y="1353312"/>
-            <a:ext cx="1389888" cy="219456"/>
-          </a:xfrm>
-          <a:prstGeom prst="rect">
-            <a:avLst/>
-          </a:prstGeom>
-          <a:noFill/>
-        </p:spPr>
-        <p:txBody>
-          <a:bodyPr wrap="square" lIns="36576" rIns="36576" tIns="36576" bIns="36576" anchor="t">
-            <a:spAutoFit/>
-          </a:bodyPr>
-          <a:lstStyle/>
-          <a:p>
-            <a:pPr algn="l">
-              <a:defRPr sz="900" b="0">
-                <a:solidFill>
-                  <a:srgbClr val="A8B2C7"/>
-                </a:solidFill>
-                <a:latin typeface="Aptos"/>
-              </a:defRPr>
-            </a:pPr>
-            <a:r>
-              <a:t>weighted 0</a:t>
-            </a:r>
-          </a:p>
-        </p:txBody>
-      </p:sp>
-      <p:sp>
-        <p:nvSpPr>
-          <p:cNvPr id="13" name="TextBox 12"/>
-          <p:cNvSpPr txBox="1"/>
-          <p:nvPr/>
-        </p:nvSpPr>
-        <p:spPr>
-          <a:xfrm>
-            <a:off x="566928" y="2359152"/>
-            <a:ext cx="1051560" cy="201168"/>
-          </a:xfrm>
-          <a:prstGeom prst="rect">
-            <a:avLst/>
-          </a:prstGeom>
-          <a:noFill/>
-        </p:spPr>
-        <p:txBody>
-          <a:bodyPr wrap="square" lIns="36576" rIns="36576" tIns="36576" bIns="36576" anchor="t">
-            <a:spAutoFit/>
-          </a:bodyPr>
-          <a:lstStyle/>
-          <a:p>
-            <a:pPr algn="l">
-              <a:defRPr sz="1200" b="1">
-                <a:solidFill>
-                  <a:srgbClr val="F7FAFC"/>
-                </a:solidFill>
-                <a:latin typeface="Aptos"/>
-              </a:defRPr>
-            </a:pPr>
-            <a:r>
-              <a:t>Define</a:t>
-            </a:r>
-          </a:p>
-        </p:txBody>
-      </p:sp>
-      <p:sp>
-        <p:nvSpPr>
-          <p:cNvPr id="14" name="TextBox 13"/>
-          <p:cNvSpPr txBox="1"/>
-          <p:nvPr/>
-        </p:nvSpPr>
-        <p:spPr>
-          <a:xfrm>
-            <a:off x="1444752" y="2359152"/>
-            <a:ext cx="594360" cy="201168"/>
-          </a:xfrm>
-          <a:prstGeom prst="rect">
-            <a:avLst/>
-          </a:prstGeom>
-          <a:noFill/>
-        </p:spPr>
-        <p:txBody>
-          <a:bodyPr wrap="square" lIns="36576" rIns="36576" tIns="36576" bIns="36576" anchor="t">
-            <a:spAutoFit/>
-          </a:bodyPr>
-          <a:lstStyle/>
-          <a:p>
-            <a:pPr algn="l">
-              <a:defRPr sz="900" b="0">
-                <a:solidFill>
-                  <a:srgbClr val="A8B2C7"/>
-                </a:solidFill>
-                <a:latin typeface="Aptos"/>
-              </a:defRPr>
-            </a:pPr>
-            <a:r>
-              <a:t>15 opps</a:t>
-            </a:r>
-          </a:p>
-        </p:txBody>
-      </p:sp>
-      <p:sp>
-        <p:nvSpPr>
-          <p:cNvPr id="15" name="Rectangle 14"/>
+          <p:cNvPr id="13" name="Rectangle 12"/>
           <p:cNvSpPr/>
           <p:nvPr/>
         </p:nvSpPr>
         <p:spPr>
           <a:xfrm>
-            <a:off x="2148840" y="2286000"/>
-            <a:ext cx="5806440" cy="438912"/>
+            <a:off x="1490472" y="2103120"/>
+            <a:ext cx="2542032" cy="310896"/>
           </a:xfrm>
           <a:prstGeom prst="rect">
             <a:avLst/>
           </a:prstGeom>
           <a:solidFill>
-            <a:srgbClr val="152446"/>
+            <a:srgbClr val="FF9F1C"/>
           </a:solidFill>
-          <a:ln w="12700">
-            <a:solidFill>
-              <a:srgbClr val="152446"/>
-            </a:solidFill>
+          <a:ln>
+            <a:noFill/>
           </a:ln>
         </p:spPr>
         <p:style>
@@ -32670,23 +32598,137 @@
       </p:sp>
       <p:sp>
         <p:nvSpPr>
-          <p:cNvPr id="16" name="Rectangle 15"/>
+          <p:cNvPr id="14" name="TextBox 13"/>
+          <p:cNvSpPr txBox="1"/>
+          <p:nvPr/>
+        </p:nvSpPr>
+        <p:spPr>
+          <a:xfrm>
+            <a:off x="4142232" y="2093976"/>
+            <a:ext cx="822960" cy="219456"/>
+          </a:xfrm>
+          <a:prstGeom prst="rect">
+            <a:avLst/>
+          </a:prstGeom>
+          <a:noFill/>
+        </p:spPr>
+        <p:txBody>
+          <a:bodyPr wrap="square" lIns="36576" rIns="36576" tIns="36576" bIns="36576" anchor="t">
+            <a:spAutoFit/>
+          </a:bodyPr>
+          <a:lstStyle/>
+          <a:p>
+            <a:pPr algn="r">
+              <a:defRPr sz="1120" b="1">
+                <a:solidFill>
+                  <a:srgbClr val="F7FAFC"/>
+                </a:solidFill>
+                <a:latin typeface="Aptos"/>
+              </a:defRPr>
+            </a:pPr>
+            <a:r>
+              <a:t>12.66M</a:t>
+            </a:r>
+          </a:p>
+        </p:txBody>
+      </p:sp>
+      <p:sp>
+        <p:nvSpPr>
+          <p:cNvPr id="15" name="TextBox 14"/>
+          <p:cNvSpPr txBox="1"/>
+          <p:nvPr/>
+        </p:nvSpPr>
+        <p:spPr>
+          <a:xfrm>
+            <a:off x="5056632" y="2093976"/>
+            <a:ext cx="658368" cy="274320"/>
+          </a:xfrm>
+          <a:prstGeom prst="rect">
+            <a:avLst/>
+          </a:prstGeom>
+          <a:noFill/>
+        </p:spPr>
+        <p:txBody>
+          <a:bodyPr wrap="square" lIns="36576" rIns="36576" tIns="36576" bIns="36576" anchor="t">
+            <a:spAutoFit/>
+          </a:bodyPr>
+          <a:lstStyle/>
+          <a:p>
+            <a:pPr algn="r">
+              <a:defRPr sz="760" b="0">
+                <a:solidFill>
+                  <a:srgbClr val="A8B2C7"/>
+                </a:solidFill>
+                <a:latin typeface="Aptos"/>
+              </a:defRPr>
+            </a:pPr>
+            <a:r>
+              <a:t>14 opps</a:t>
+            </a:r>
+            <a:br/>
+            <a:r>
+              <a:t>14 rows</a:t>
+            </a:r>
+          </a:p>
+        </p:txBody>
+      </p:sp>
+      <p:sp>
+        <p:nvSpPr>
+          <p:cNvPr id="16" name="TextBox 15"/>
+          <p:cNvSpPr txBox="1"/>
+          <p:nvPr/>
+        </p:nvSpPr>
+        <p:spPr>
+          <a:xfrm>
+            <a:off x="704088" y="3090671"/>
+            <a:ext cx="749808" cy="201168"/>
+          </a:xfrm>
+          <a:prstGeom prst="rect">
+            <a:avLst/>
+          </a:prstGeom>
+          <a:noFill/>
+        </p:spPr>
+        <p:txBody>
+          <a:bodyPr wrap="square" lIns="36576" rIns="36576" tIns="36576" bIns="36576" anchor="t">
+            <a:spAutoFit/>
+          </a:bodyPr>
+          <a:lstStyle/>
+          <a:p>
+            <a:pPr algn="l">
+              <a:defRPr sz="1050" b="1">
+                <a:solidFill>
+                  <a:srgbClr val="F7FAFC"/>
+                </a:solidFill>
+                <a:latin typeface="Aptos"/>
+              </a:defRPr>
+            </a:pPr>
+            <a:r>
+              <a:t>Develop</a:t>
+            </a:r>
+          </a:p>
+        </p:txBody>
+      </p:sp>
+      <p:sp>
+        <p:nvSpPr>
+          <p:cNvPr id="17" name="Rectangle 16"/>
           <p:cNvSpPr/>
           <p:nvPr/>
         </p:nvSpPr>
         <p:spPr>
           <a:xfrm>
-            <a:off x="2148840" y="2286000"/>
-            <a:ext cx="5806440" cy="438912"/>
+            <a:off x="1490472" y="3063239"/>
+            <a:ext cx="2542032" cy="310896"/>
           </a:xfrm>
           <a:prstGeom prst="rect">
             <a:avLst/>
           </a:prstGeom>
           <a:solidFill>
-            <a:srgbClr val="FF9F1C"/>
+            <a:srgbClr val="152446"/>
           </a:solidFill>
-          <a:ln>
-            <a:noFill/>
+          <a:ln w="12700">
+            <a:solidFill>
+              <a:srgbClr val="152446"/>
+            </a:solidFill>
           </a:ln>
         </p:spPr>
         <p:style>
@@ -32713,169 +32755,23 @@
       </p:sp>
       <p:sp>
         <p:nvSpPr>
-          <p:cNvPr id="17" name="TextBox 16"/>
-          <p:cNvSpPr txBox="1"/>
-          <p:nvPr/>
-        </p:nvSpPr>
-        <p:spPr>
-          <a:xfrm>
-            <a:off x="8119872" y="2313432"/>
-            <a:ext cx="1051560" cy="219456"/>
-          </a:xfrm>
-          <a:prstGeom prst="rect">
-            <a:avLst/>
-          </a:prstGeom>
-          <a:noFill/>
-        </p:spPr>
-        <p:txBody>
-          <a:bodyPr wrap="square" lIns="36576" rIns="36576" tIns="36576" bIns="36576" anchor="t">
-            <a:spAutoFit/>
-          </a:bodyPr>
-          <a:lstStyle/>
-          <a:p>
-            <a:pPr algn="r">
-              <a:defRPr sz="1300" b="1">
-                <a:solidFill>
-                  <a:srgbClr val="F7FAFC"/>
-                </a:solidFill>
-                <a:latin typeface="Aptos"/>
-              </a:defRPr>
-            </a:pPr>
-            <a:r>
-              <a:t>9.40M</a:t>
-            </a:r>
-          </a:p>
-        </p:txBody>
-      </p:sp>
-      <p:sp>
-        <p:nvSpPr>
-          <p:cNvPr id="18" name="TextBox 17"/>
-          <p:cNvSpPr txBox="1"/>
-          <p:nvPr/>
-        </p:nvSpPr>
-        <p:spPr>
-          <a:xfrm>
-            <a:off x="9308592" y="2313432"/>
-            <a:ext cx="1389888" cy="219456"/>
-          </a:xfrm>
-          <a:prstGeom prst="rect">
-            <a:avLst/>
-          </a:prstGeom>
-          <a:noFill/>
-        </p:spPr>
-        <p:txBody>
-          <a:bodyPr wrap="square" lIns="36576" rIns="36576" tIns="36576" bIns="36576" anchor="t">
-            <a:spAutoFit/>
-          </a:bodyPr>
-          <a:lstStyle/>
-          <a:p>
-            <a:pPr algn="l">
-              <a:defRPr sz="900" b="0">
-                <a:solidFill>
-                  <a:srgbClr val="A8B2C7"/>
-                </a:solidFill>
-                <a:latin typeface="Aptos"/>
-              </a:defRPr>
-            </a:pPr>
-            <a:r>
-              <a:t>weighted 2.28M</a:t>
-            </a:r>
-          </a:p>
-        </p:txBody>
-      </p:sp>
-      <p:sp>
-        <p:nvSpPr>
-          <p:cNvPr id="19" name="TextBox 18"/>
-          <p:cNvSpPr txBox="1"/>
-          <p:nvPr/>
-        </p:nvSpPr>
-        <p:spPr>
-          <a:xfrm>
-            <a:off x="566928" y="3319272"/>
-            <a:ext cx="1051560" cy="201168"/>
-          </a:xfrm>
-          <a:prstGeom prst="rect">
-            <a:avLst/>
-          </a:prstGeom>
-          <a:noFill/>
-        </p:spPr>
-        <p:txBody>
-          <a:bodyPr wrap="square" lIns="36576" rIns="36576" tIns="36576" bIns="36576" anchor="t">
-            <a:spAutoFit/>
-          </a:bodyPr>
-          <a:lstStyle/>
-          <a:p>
-            <a:pPr algn="l">
-              <a:defRPr sz="1200" b="1">
-                <a:solidFill>
-                  <a:srgbClr val="F7FAFC"/>
-                </a:solidFill>
-                <a:latin typeface="Aptos"/>
-              </a:defRPr>
-            </a:pPr>
-            <a:r>
-              <a:t>Develop</a:t>
-            </a:r>
-          </a:p>
-        </p:txBody>
-      </p:sp>
-      <p:sp>
-        <p:nvSpPr>
-          <p:cNvPr id="20" name="TextBox 19"/>
-          <p:cNvSpPr txBox="1"/>
-          <p:nvPr/>
-        </p:nvSpPr>
-        <p:spPr>
-          <a:xfrm>
-            <a:off x="1444752" y="3319272"/>
-            <a:ext cx="594360" cy="201168"/>
-          </a:xfrm>
-          <a:prstGeom prst="rect">
-            <a:avLst/>
-          </a:prstGeom>
-          <a:noFill/>
-        </p:spPr>
-        <p:txBody>
-          <a:bodyPr wrap="square" lIns="36576" rIns="36576" tIns="36576" bIns="36576" anchor="t">
-            <a:spAutoFit/>
-          </a:bodyPr>
-          <a:lstStyle/>
-          <a:p>
-            <a:pPr algn="l">
-              <a:defRPr sz="900" b="0">
-                <a:solidFill>
-                  <a:srgbClr val="A8B2C7"/>
-                </a:solidFill>
-                <a:latin typeface="Aptos"/>
-              </a:defRPr>
-            </a:pPr>
-            <a:r>
-              <a:t>1 opps</a:t>
-            </a:r>
-          </a:p>
-        </p:txBody>
-      </p:sp>
-      <p:sp>
-        <p:nvSpPr>
-          <p:cNvPr id="21" name="Rectangle 20"/>
+          <p:cNvPr id="18" name="Rectangle 17"/>
           <p:cNvSpPr/>
           <p:nvPr/>
         </p:nvSpPr>
         <p:spPr>
           <a:xfrm>
-            <a:off x="2148840" y="3246120"/>
-            <a:ext cx="5806440" cy="438912"/>
+            <a:off x="1490472" y="3063239"/>
+            <a:ext cx="740702" cy="310896"/>
           </a:xfrm>
           <a:prstGeom prst="rect">
             <a:avLst/>
           </a:prstGeom>
           <a:solidFill>
-            <a:srgbClr val="152446"/>
+            <a:srgbClr val="3A86FF"/>
           </a:solidFill>
-          <a:ln w="12700">
-            <a:solidFill>
-              <a:srgbClr val="152446"/>
-            </a:solidFill>
+          <a:ln>
+            <a:noFill/>
           </a:ln>
         </p:spPr>
         <p:style>
@@ -32902,23 +32798,137 @@
       </p:sp>
       <p:sp>
         <p:nvSpPr>
+          <p:cNvPr id="19" name="TextBox 18"/>
+          <p:cNvSpPr txBox="1"/>
+          <p:nvPr/>
+        </p:nvSpPr>
+        <p:spPr>
+          <a:xfrm>
+            <a:off x="4142232" y="3054096"/>
+            <a:ext cx="822960" cy="219456"/>
+          </a:xfrm>
+          <a:prstGeom prst="rect">
+            <a:avLst/>
+          </a:prstGeom>
+          <a:noFill/>
+        </p:spPr>
+        <p:txBody>
+          <a:bodyPr wrap="square" lIns="36576" rIns="36576" tIns="36576" bIns="36576" anchor="t">
+            <a:spAutoFit/>
+          </a:bodyPr>
+          <a:lstStyle/>
+          <a:p>
+            <a:pPr algn="r">
+              <a:defRPr sz="1120" b="1">
+                <a:solidFill>
+                  <a:srgbClr val="F7FAFC"/>
+                </a:solidFill>
+                <a:latin typeface="Aptos"/>
+              </a:defRPr>
+            </a:pPr>
+            <a:r>
+              <a:t>3.69M</a:t>
+            </a:r>
+          </a:p>
+        </p:txBody>
+      </p:sp>
+      <p:sp>
+        <p:nvSpPr>
+          <p:cNvPr id="20" name="TextBox 19"/>
+          <p:cNvSpPr txBox="1"/>
+          <p:nvPr/>
+        </p:nvSpPr>
+        <p:spPr>
+          <a:xfrm>
+            <a:off x="5056632" y="3054096"/>
+            <a:ext cx="658368" cy="274320"/>
+          </a:xfrm>
+          <a:prstGeom prst="rect">
+            <a:avLst/>
+          </a:prstGeom>
+          <a:noFill/>
+        </p:spPr>
+        <p:txBody>
+          <a:bodyPr wrap="square" lIns="36576" rIns="36576" tIns="36576" bIns="36576" anchor="t">
+            <a:spAutoFit/>
+          </a:bodyPr>
+          <a:lstStyle/>
+          <a:p>
+            <a:pPr algn="r">
+              <a:defRPr sz="760" b="0">
+                <a:solidFill>
+                  <a:srgbClr val="A8B2C7"/>
+                </a:solidFill>
+                <a:latin typeface="Aptos"/>
+              </a:defRPr>
+            </a:pPr>
+            <a:r>
+              <a:t>5 opps</a:t>
+            </a:r>
+            <a:br/>
+            <a:r>
+              <a:t>8 rows</a:t>
+            </a:r>
+          </a:p>
+        </p:txBody>
+      </p:sp>
+      <p:sp>
+        <p:nvSpPr>
+          <p:cNvPr id="21" name="TextBox 20"/>
+          <p:cNvSpPr txBox="1"/>
+          <p:nvPr/>
+        </p:nvSpPr>
+        <p:spPr>
+          <a:xfrm>
+            <a:off x="704088" y="4050792"/>
+            <a:ext cx="749808" cy="201168"/>
+          </a:xfrm>
+          <a:prstGeom prst="rect">
+            <a:avLst/>
+          </a:prstGeom>
+          <a:noFill/>
+        </p:spPr>
+        <p:txBody>
+          <a:bodyPr wrap="square" lIns="36576" rIns="36576" tIns="36576" bIns="36576" anchor="t">
+            <a:spAutoFit/>
+          </a:bodyPr>
+          <a:lstStyle/>
+          <a:p>
+            <a:pPr algn="l">
+              <a:defRPr sz="1050" b="1">
+                <a:solidFill>
+                  <a:srgbClr val="F7FAFC"/>
+                </a:solidFill>
+                <a:latin typeface="Aptos"/>
+              </a:defRPr>
+            </a:pPr>
+            <a:r>
+              <a:t>Design</a:t>
+            </a:r>
+          </a:p>
+        </p:txBody>
+      </p:sp>
+      <p:sp>
+        <p:nvSpPr>
           <p:cNvPr id="22" name="Rectangle 21"/>
           <p:cNvSpPr/>
           <p:nvPr/>
         </p:nvSpPr>
         <p:spPr>
           <a:xfrm>
-            <a:off x="2148840" y="3246120"/>
-            <a:ext cx="555785" cy="438912"/>
+            <a:off x="1490472" y="4023360"/>
+            <a:ext cx="2542032" cy="310896"/>
           </a:xfrm>
           <a:prstGeom prst="rect">
             <a:avLst/>
           </a:prstGeom>
           <a:solidFill>
-            <a:srgbClr val="3A86FF"/>
+            <a:srgbClr val="152446"/>
           </a:solidFill>
-          <a:ln>
-            <a:noFill/>
+          <a:ln w="12700">
+            <a:solidFill>
+              <a:srgbClr val="152446"/>
+            </a:solidFill>
           </a:ln>
         </p:spPr>
         <p:style>
@@ -32945,169 +32955,23 @@
       </p:sp>
       <p:sp>
         <p:nvSpPr>
-          <p:cNvPr id="23" name="TextBox 22"/>
-          <p:cNvSpPr txBox="1"/>
-          <p:nvPr/>
-        </p:nvSpPr>
-        <p:spPr>
-          <a:xfrm>
-            <a:off x="8119872" y="3273551"/>
-            <a:ext cx="1051560" cy="219456"/>
-          </a:xfrm>
-          <a:prstGeom prst="rect">
-            <a:avLst/>
-          </a:prstGeom>
-          <a:noFill/>
-        </p:spPr>
-        <p:txBody>
-          <a:bodyPr wrap="square" lIns="36576" rIns="36576" tIns="36576" bIns="36576" anchor="t">
-            <a:spAutoFit/>
-          </a:bodyPr>
-          <a:lstStyle/>
-          <a:p>
-            <a:pPr algn="r">
-              <a:defRPr sz="1300" b="1">
-                <a:solidFill>
-                  <a:srgbClr val="F7FAFC"/>
-                </a:solidFill>
-                <a:latin typeface="Aptos"/>
-              </a:defRPr>
-            </a:pPr>
-            <a:r>
-              <a:t>900K</a:t>
-            </a:r>
-          </a:p>
-        </p:txBody>
-      </p:sp>
-      <p:sp>
-        <p:nvSpPr>
-          <p:cNvPr id="24" name="TextBox 23"/>
-          <p:cNvSpPr txBox="1"/>
-          <p:nvPr/>
-        </p:nvSpPr>
-        <p:spPr>
-          <a:xfrm>
-            <a:off x="9308592" y="3273551"/>
-            <a:ext cx="1389888" cy="219456"/>
-          </a:xfrm>
-          <a:prstGeom prst="rect">
-            <a:avLst/>
-          </a:prstGeom>
-          <a:noFill/>
-        </p:spPr>
-        <p:txBody>
-          <a:bodyPr wrap="square" lIns="36576" rIns="36576" tIns="36576" bIns="36576" anchor="t">
-            <a:spAutoFit/>
-          </a:bodyPr>
-          <a:lstStyle/>
-          <a:p>
-            <a:pPr algn="l">
-              <a:defRPr sz="900" b="0">
-                <a:solidFill>
-                  <a:srgbClr val="A8B2C7"/>
-                </a:solidFill>
-                <a:latin typeface="Aptos"/>
-              </a:defRPr>
-            </a:pPr>
-            <a:r>
-              <a:t>weighted 450K</a:t>
-            </a:r>
-          </a:p>
-        </p:txBody>
-      </p:sp>
-      <p:sp>
-        <p:nvSpPr>
-          <p:cNvPr id="25" name="TextBox 24"/>
-          <p:cNvSpPr txBox="1"/>
-          <p:nvPr/>
-        </p:nvSpPr>
-        <p:spPr>
-          <a:xfrm>
-            <a:off x="566928" y="4279392"/>
-            <a:ext cx="1051560" cy="201168"/>
-          </a:xfrm>
-          <a:prstGeom prst="rect">
-            <a:avLst/>
-          </a:prstGeom>
-          <a:noFill/>
-        </p:spPr>
-        <p:txBody>
-          <a:bodyPr wrap="square" lIns="36576" rIns="36576" tIns="36576" bIns="36576" anchor="t">
-            <a:spAutoFit/>
-          </a:bodyPr>
-          <a:lstStyle/>
-          <a:p>
-            <a:pPr algn="l">
-              <a:defRPr sz="1200" b="1">
-                <a:solidFill>
-                  <a:srgbClr val="F7FAFC"/>
-                </a:solidFill>
-                <a:latin typeface="Aptos"/>
-              </a:defRPr>
-            </a:pPr>
-            <a:r>
-              <a:t>Design</a:t>
-            </a:r>
-          </a:p>
-        </p:txBody>
-      </p:sp>
-      <p:sp>
-        <p:nvSpPr>
-          <p:cNvPr id="26" name="TextBox 25"/>
-          <p:cNvSpPr txBox="1"/>
-          <p:nvPr/>
-        </p:nvSpPr>
-        <p:spPr>
-          <a:xfrm>
-            <a:off x="1444752" y="4279392"/>
-            <a:ext cx="594360" cy="201168"/>
-          </a:xfrm>
-          <a:prstGeom prst="rect">
-            <a:avLst/>
-          </a:prstGeom>
-          <a:noFill/>
-        </p:spPr>
-        <p:txBody>
-          <a:bodyPr wrap="square" lIns="36576" rIns="36576" tIns="36576" bIns="36576" anchor="t">
-            <a:spAutoFit/>
-          </a:bodyPr>
-          <a:lstStyle/>
-          <a:p>
-            <a:pPr algn="l">
-              <a:defRPr sz="900" b="0">
-                <a:solidFill>
-                  <a:srgbClr val="A8B2C7"/>
-                </a:solidFill>
-                <a:latin typeface="Aptos"/>
-              </a:defRPr>
-            </a:pPr>
-            <a:r>
-              <a:t>3 opps</a:t>
-            </a:r>
-          </a:p>
-        </p:txBody>
-      </p:sp>
-      <p:sp>
-        <p:nvSpPr>
-          <p:cNvPr id="27" name="Rectangle 26"/>
+          <p:cNvPr id="23" name="Rectangle 22"/>
           <p:cNvSpPr/>
           <p:nvPr/>
         </p:nvSpPr>
         <p:spPr>
           <a:xfrm>
-            <a:off x="2148840" y="4206240"/>
-            <a:ext cx="5806440" cy="438912"/>
+            <a:off x="1490472" y="4023360"/>
+            <a:ext cx="200868" cy="310896"/>
           </a:xfrm>
           <a:prstGeom prst="rect">
             <a:avLst/>
           </a:prstGeom>
           <a:solidFill>
-            <a:srgbClr val="152446"/>
+            <a:srgbClr val="3DDC97"/>
           </a:solidFill>
-          <a:ln w="12700">
-            <a:solidFill>
-              <a:srgbClr val="152446"/>
-            </a:solidFill>
+          <a:ln>
+            <a:noFill/>
           </a:ln>
         </p:spPr>
         <p:style>
@@ -33134,23 +32998,173 @@
       </p:sp>
       <p:sp>
         <p:nvSpPr>
-          <p:cNvPr id="28" name="Rectangle 27"/>
+          <p:cNvPr id="24" name="TextBox 23"/>
+          <p:cNvSpPr txBox="1"/>
+          <p:nvPr/>
+        </p:nvSpPr>
+        <p:spPr>
+          <a:xfrm>
+            <a:off x="4142232" y="4014216"/>
+            <a:ext cx="822960" cy="219456"/>
+          </a:xfrm>
+          <a:prstGeom prst="rect">
+            <a:avLst/>
+          </a:prstGeom>
+          <a:noFill/>
+        </p:spPr>
+        <p:txBody>
+          <a:bodyPr wrap="square" lIns="36576" rIns="36576" tIns="36576" bIns="36576" anchor="t">
+            <a:spAutoFit/>
+          </a:bodyPr>
+          <a:lstStyle/>
+          <a:p>
+            <a:pPr algn="r">
+              <a:defRPr sz="1120" b="1">
+                <a:solidFill>
+                  <a:srgbClr val="F7FAFC"/>
+                </a:solidFill>
+                <a:latin typeface="Aptos"/>
+              </a:defRPr>
+            </a:pPr>
+            <a:r>
+              <a:t>1.00M</a:t>
+            </a:r>
+          </a:p>
+        </p:txBody>
+      </p:sp>
+      <p:sp>
+        <p:nvSpPr>
+          <p:cNvPr id="25" name="TextBox 24"/>
+          <p:cNvSpPr txBox="1"/>
+          <p:nvPr/>
+        </p:nvSpPr>
+        <p:spPr>
+          <a:xfrm>
+            <a:off x="5056632" y="4014216"/>
+            <a:ext cx="658368" cy="274320"/>
+          </a:xfrm>
+          <a:prstGeom prst="rect">
+            <a:avLst/>
+          </a:prstGeom>
+          <a:noFill/>
+        </p:spPr>
+        <p:txBody>
+          <a:bodyPr wrap="square" lIns="36576" rIns="36576" tIns="36576" bIns="36576" anchor="t">
+            <a:spAutoFit/>
+          </a:bodyPr>
+          <a:lstStyle/>
+          <a:p>
+            <a:pPr algn="r">
+              <a:defRPr sz="760" b="0">
+                <a:solidFill>
+                  <a:srgbClr val="A8B2C7"/>
+                </a:solidFill>
+                <a:latin typeface="Aptos"/>
+              </a:defRPr>
+            </a:pPr>
+            <a:r>
+              <a:t>1 opps</a:t>
+            </a:r>
+            <a:br/>
+            <a:r>
+              <a:t>1 rows</a:t>
+            </a:r>
+          </a:p>
+        </p:txBody>
+      </p:sp>
+      <p:sp>
+        <p:nvSpPr>
+          <p:cNvPr id="26" name="TextBox 25"/>
+          <p:cNvSpPr txBox="1"/>
+          <p:nvPr/>
+        </p:nvSpPr>
+        <p:spPr>
+          <a:xfrm>
+            <a:off x="704088" y="5029200"/>
+            <a:ext cx="5010912" cy="201168"/>
+          </a:xfrm>
+          <a:prstGeom prst="rect">
+            <a:avLst/>
+          </a:prstGeom>
+          <a:noFill/>
+        </p:spPr>
+        <p:txBody>
+          <a:bodyPr wrap="square" lIns="36576" rIns="36576" tIns="36576" bIns="36576" anchor="t">
+            <a:spAutoFit/>
+          </a:bodyPr>
+          <a:lstStyle/>
+          <a:p>
+            <a:pPr algn="l">
+              <a:defRPr sz="1050" b="1">
+                <a:solidFill>
+                  <a:srgbClr val="DDE6F3"/>
+                </a:solidFill>
+                <a:latin typeface="Aptos"/>
+              </a:defRPr>
+            </a:pPr>
+            <a:r>
+              <a:t>Direct 4.25M  •  Channel 13.09M</a:t>
+            </a:r>
+          </a:p>
+        </p:txBody>
+      </p:sp>
+      <p:sp>
+        <p:nvSpPr>
+          <p:cNvPr id="27" name="TextBox 26"/>
+          <p:cNvSpPr txBox="1"/>
+          <p:nvPr/>
+        </p:nvSpPr>
+        <p:spPr>
+          <a:xfrm>
+            <a:off x="704088" y="5376672"/>
+            <a:ext cx="5010912" cy="201168"/>
+          </a:xfrm>
+          <a:prstGeom prst="rect">
+            <a:avLst/>
+          </a:prstGeom>
+          <a:noFill/>
+        </p:spPr>
+        <p:txBody>
+          <a:bodyPr wrap="square" lIns="36576" rIns="36576" tIns="36576" bIns="36576" anchor="t">
+            <a:spAutoFit/>
+          </a:bodyPr>
+          <a:lstStyle/>
+          <a:p>
+            <a:pPr algn="l">
+              <a:defRPr sz="950" b="1">
+                <a:solidFill>
+                  <a:srgbClr val="FF9F1C"/>
+                </a:solidFill>
+                <a:latin typeface="Aptos"/>
+              </a:defRPr>
+            </a:pPr>
+            <a:r>
+              <a:t>Define stage = 73% of value</a:t>
+            </a:r>
+          </a:p>
+        </p:txBody>
+      </p:sp>
+      <p:sp>
+        <p:nvSpPr>
+          <p:cNvPr id="28" name="Rounded Rectangle 27"/>
           <p:cNvSpPr/>
           <p:nvPr/>
         </p:nvSpPr>
         <p:spPr>
           <a:xfrm>
-            <a:off x="2148840" y="4206240"/>
-            <a:ext cx="296418" cy="438912"/>
-          </a:xfrm>
-          <a:prstGeom prst="rect">
+            <a:off x="6126480" y="1234440"/>
+            <a:ext cx="5468112" cy="4663440"/>
+          </a:xfrm>
+          <a:prstGeom prst="roundRect">
             <a:avLst/>
           </a:prstGeom>
           <a:solidFill>
-            <a:srgbClr val="3DDC97"/>
+            <a:srgbClr val="14213D"/>
           </a:solidFill>
-          <a:ln>
-            <a:noFill/>
+          <a:ln w="12700">
+            <a:solidFill>
+              <a:srgbClr val="3A86FF"/>
+            </a:solidFill>
           </a:ln>
         </p:spPr>
         <p:style>
@@ -33183,8 +33197,44 @@
         </p:nvSpPr>
         <p:spPr>
           <a:xfrm>
-            <a:off x="8119872" y="4233672"/>
-            <a:ext cx="1051560" cy="219456"/>
+            <a:off x="6327648" y="1499616"/>
+            <a:ext cx="1920240" cy="219456"/>
+          </a:xfrm>
+          <a:prstGeom prst="rect">
+            <a:avLst/>
+          </a:prstGeom>
+          <a:noFill/>
+        </p:spPr>
+        <p:txBody>
+          <a:bodyPr wrap="square" lIns="36576" rIns="36576" tIns="36576" bIns="36576" anchor="t">
+            <a:spAutoFit/>
+          </a:bodyPr>
+          <a:lstStyle/>
+          <a:p>
+            <a:pPr algn="l">
+              <a:defRPr sz="1300" b="1">
+                <a:solidFill>
+                  <a:srgbClr val="3A86FF"/>
+                </a:solidFill>
+                <a:latin typeface="Aptos"/>
+              </a:defRPr>
+            </a:pPr>
+            <a:r>
+              <a:t>FY2027</a:t>
+            </a:r>
+          </a:p>
+        </p:txBody>
+      </p:sp>
+      <p:sp>
+        <p:nvSpPr>
+          <p:cNvPr id="30" name="TextBox 29"/>
+          <p:cNvSpPr txBox="1"/>
+          <p:nvPr/>
+        </p:nvSpPr>
+        <p:spPr>
+          <a:xfrm>
+            <a:off x="8229600" y="1463040"/>
+            <a:ext cx="1554480" cy="310896"/>
           </a:xfrm>
           <a:prstGeom prst="rect">
             <a:avLst/>
@@ -33198,7 +33248,7 @@
           <a:lstStyle/>
           <a:p>
             <a:pPr algn="r">
-              <a:defRPr sz="1300" b="1">
+              <a:defRPr sz="2100" b="1">
                 <a:solidFill>
                   <a:srgbClr val="F7FAFC"/>
                 </a:solidFill>
@@ -33206,35 +33256,35 @@
               </a:defRPr>
             </a:pPr>
             <a:r>
-              <a:t>480K</a:t>
-            </a:r>
-          </a:p>
-        </p:txBody>
-      </p:sp>
-      <p:sp>
-        <p:nvSpPr>
-          <p:cNvPr id="30" name="TextBox 29"/>
-          <p:cNvSpPr txBox="1"/>
-          <p:nvPr/>
-        </p:nvSpPr>
-        <p:spPr>
-          <a:xfrm>
-            <a:off x="9308592" y="4233672"/>
-            <a:ext cx="1389888" cy="219456"/>
-          </a:xfrm>
-          <a:prstGeom prst="rect">
-            <a:avLst/>
-          </a:prstGeom>
-          <a:noFill/>
-        </p:spPr>
-        <p:txBody>
-          <a:bodyPr wrap="square" lIns="36576" rIns="36576" tIns="36576" bIns="36576" anchor="t">
-            <a:spAutoFit/>
-          </a:bodyPr>
-          <a:lstStyle/>
-          <a:p>
-            <a:pPr algn="l">
-              <a:defRPr sz="900" b="0">
+              <a:t>64.5M</a:t>
+            </a:r>
+          </a:p>
+        </p:txBody>
+      </p:sp>
+      <p:sp>
+        <p:nvSpPr>
+          <p:cNvPr id="31" name="TextBox 30"/>
+          <p:cNvSpPr txBox="1"/>
+          <p:nvPr/>
+        </p:nvSpPr>
+        <p:spPr>
+          <a:xfrm>
+            <a:off x="9875520" y="1536192"/>
+            <a:ext cx="1417320" cy="182880"/>
+          </a:xfrm>
+          <a:prstGeom prst="rect">
+            <a:avLst/>
+          </a:prstGeom>
+          <a:noFill/>
+        </p:spPr>
+        <p:txBody>
+          <a:bodyPr wrap="square" lIns="36576" rIns="36576" tIns="36576" bIns="36576" anchor="t">
+            <a:spAutoFit/>
+          </a:bodyPr>
+          <a:lstStyle/>
+          <a:p>
+            <a:pPr algn="r">
+              <a:defRPr sz="819" b="0">
                 <a:solidFill>
                   <a:srgbClr val="A8B2C7"/>
                 </a:solidFill>
@@ -33242,31 +33292,67 @@
               </a:defRPr>
             </a:pPr>
             <a:r>
-              <a:t>weighted 360K</a:t>
-            </a:r>
-          </a:p>
-        </p:txBody>
-      </p:sp>
-      <p:sp>
-        <p:nvSpPr>
-          <p:cNvPr id="31" name="Rounded Rectangle 30"/>
+              <a:t>82 distinct opps</a:t>
+            </a:r>
+          </a:p>
+        </p:txBody>
+      </p:sp>
+      <p:sp>
+        <p:nvSpPr>
+          <p:cNvPr id="32" name="TextBox 31"/>
+          <p:cNvSpPr txBox="1"/>
+          <p:nvPr/>
+        </p:nvSpPr>
+        <p:spPr>
+          <a:xfrm>
+            <a:off x="6327648" y="2130551"/>
+            <a:ext cx="749808" cy="201168"/>
+          </a:xfrm>
+          <a:prstGeom prst="rect">
+            <a:avLst/>
+          </a:prstGeom>
+          <a:noFill/>
+        </p:spPr>
+        <p:txBody>
+          <a:bodyPr wrap="square" lIns="36576" rIns="36576" tIns="36576" bIns="36576" anchor="t">
+            <a:spAutoFit/>
+          </a:bodyPr>
+          <a:lstStyle/>
+          <a:p>
+            <a:pPr algn="l">
+              <a:defRPr sz="1050" b="1">
+                <a:solidFill>
+                  <a:srgbClr val="F7FAFC"/>
+                </a:solidFill>
+                <a:latin typeface="Aptos"/>
+              </a:defRPr>
+            </a:pPr>
+            <a:r>
+              <a:t>Define</a:t>
+            </a:r>
+          </a:p>
+        </p:txBody>
+      </p:sp>
+      <p:sp>
+        <p:nvSpPr>
+          <p:cNvPr id="33" name="Rectangle 32"/>
           <p:cNvSpPr/>
           <p:nvPr/>
         </p:nvSpPr>
         <p:spPr>
           <a:xfrm>
-            <a:off x="502920" y="5230368"/>
-            <a:ext cx="11109960" cy="685800"/>
-          </a:xfrm>
-          <a:prstGeom prst="roundRect">
+            <a:off x="7114032" y="2103120"/>
+            <a:ext cx="2542032" cy="310896"/>
+          </a:xfrm>
+          <a:prstGeom prst="rect">
             <a:avLst/>
           </a:prstGeom>
           <a:solidFill>
-            <a:srgbClr val="14213D"/>
+            <a:srgbClr val="152446"/>
           </a:solidFill>
           <a:ln w="12700">
             <a:solidFill>
-              <a:srgbClr val="2A3658"/>
+              <a:srgbClr val="152446"/>
             </a:solidFill>
           </a:ln>
         </p:spPr>
@@ -33294,28 +33380,583 @@
       </p:sp>
       <p:sp>
         <p:nvSpPr>
-          <p:cNvPr id="32" name="TextBox 31"/>
-          <p:cNvSpPr txBox="1"/>
-          <p:nvPr/>
-        </p:nvSpPr>
-        <p:spPr>
-          <a:xfrm>
-            <a:off x="749808" y="5431536"/>
-            <a:ext cx="3063240" cy="237744"/>
-          </a:xfrm>
-          <a:prstGeom prst="rect">
-            <a:avLst/>
-          </a:prstGeom>
-          <a:noFill/>
-        </p:spPr>
-        <p:txBody>
-          <a:bodyPr wrap="square" lIns="36576" rIns="36576" tIns="36576" bIns="36576" anchor="t">
-            <a:spAutoFit/>
-          </a:bodyPr>
-          <a:lstStyle/>
-          <a:p>
-            <a:pPr algn="l">
-              <a:defRPr sz="1300" b="1">
+          <p:cNvPr id="34" name="Rectangle 33"/>
+          <p:cNvSpPr/>
+          <p:nvPr/>
+        </p:nvSpPr>
+        <p:spPr>
+          <a:xfrm>
+            <a:off x="7114032" y="2103120"/>
+            <a:ext cx="2542032" cy="310896"/>
+          </a:xfrm>
+          <a:prstGeom prst="rect">
+            <a:avLst/>
+          </a:prstGeom>
+          <a:solidFill>
+            <a:srgbClr val="FF9F1C"/>
+          </a:solidFill>
+          <a:ln>
+            <a:noFill/>
+          </a:ln>
+        </p:spPr>
+        <p:style>
+          <a:lnRef idx="1">
+            <a:schemeClr val="accent1"/>
+          </a:lnRef>
+          <a:fillRef idx="3">
+            <a:schemeClr val="accent1"/>
+          </a:fillRef>
+          <a:effectRef idx="2">
+            <a:schemeClr val="accent1"/>
+          </a:effectRef>
+          <a:fontRef idx="minor">
+            <a:schemeClr val="lt1"/>
+          </a:fontRef>
+        </p:style>
+        <p:txBody>
+          <a:bodyPr rtlCol="0" anchor="ctr"/>
+          <a:lstStyle/>
+          <a:p>
+            <a:pPr algn="ctr"/>
+          </a:p>
+        </p:txBody>
+      </p:sp>
+      <p:sp>
+        <p:nvSpPr>
+          <p:cNvPr id="35" name="TextBox 34"/>
+          <p:cNvSpPr txBox="1"/>
+          <p:nvPr/>
+        </p:nvSpPr>
+        <p:spPr>
+          <a:xfrm>
+            <a:off x="9765792" y="2093976"/>
+            <a:ext cx="822960" cy="219456"/>
+          </a:xfrm>
+          <a:prstGeom prst="rect">
+            <a:avLst/>
+          </a:prstGeom>
+          <a:noFill/>
+        </p:spPr>
+        <p:txBody>
+          <a:bodyPr wrap="square" lIns="36576" rIns="36576" tIns="36576" bIns="36576" anchor="t">
+            <a:spAutoFit/>
+          </a:bodyPr>
+          <a:lstStyle/>
+          <a:p>
+            <a:pPr algn="r">
+              <a:defRPr sz="1120" b="1">
+                <a:solidFill>
+                  <a:srgbClr val="F7FAFC"/>
+                </a:solidFill>
+                <a:latin typeface="Aptos"/>
+              </a:defRPr>
+            </a:pPr>
+            <a:r>
+              <a:t>55.93M</a:t>
+            </a:r>
+          </a:p>
+        </p:txBody>
+      </p:sp>
+      <p:sp>
+        <p:nvSpPr>
+          <p:cNvPr id="36" name="TextBox 35"/>
+          <p:cNvSpPr txBox="1"/>
+          <p:nvPr/>
+        </p:nvSpPr>
+        <p:spPr>
+          <a:xfrm>
+            <a:off x="10680192" y="2093976"/>
+            <a:ext cx="658368" cy="274320"/>
+          </a:xfrm>
+          <a:prstGeom prst="rect">
+            <a:avLst/>
+          </a:prstGeom>
+          <a:noFill/>
+        </p:spPr>
+        <p:txBody>
+          <a:bodyPr wrap="square" lIns="36576" rIns="36576" tIns="36576" bIns="36576" anchor="t">
+            <a:spAutoFit/>
+          </a:bodyPr>
+          <a:lstStyle/>
+          <a:p>
+            <a:pPr algn="r">
+              <a:defRPr sz="760" b="0">
+                <a:solidFill>
+                  <a:srgbClr val="A8B2C7"/>
+                </a:solidFill>
+                <a:latin typeface="Aptos"/>
+              </a:defRPr>
+            </a:pPr>
+            <a:r>
+              <a:t>77 opps</a:t>
+            </a:r>
+            <a:br/>
+            <a:r>
+              <a:t>96 rows</a:t>
+            </a:r>
+          </a:p>
+        </p:txBody>
+      </p:sp>
+      <p:sp>
+        <p:nvSpPr>
+          <p:cNvPr id="37" name="TextBox 36"/>
+          <p:cNvSpPr txBox="1"/>
+          <p:nvPr/>
+        </p:nvSpPr>
+        <p:spPr>
+          <a:xfrm>
+            <a:off x="6327648" y="3090671"/>
+            <a:ext cx="749808" cy="201168"/>
+          </a:xfrm>
+          <a:prstGeom prst="rect">
+            <a:avLst/>
+          </a:prstGeom>
+          <a:noFill/>
+        </p:spPr>
+        <p:txBody>
+          <a:bodyPr wrap="square" lIns="36576" rIns="36576" tIns="36576" bIns="36576" anchor="t">
+            <a:spAutoFit/>
+          </a:bodyPr>
+          <a:lstStyle/>
+          <a:p>
+            <a:pPr algn="l">
+              <a:defRPr sz="1050" b="1">
+                <a:solidFill>
+                  <a:srgbClr val="F7FAFC"/>
+                </a:solidFill>
+                <a:latin typeface="Aptos"/>
+              </a:defRPr>
+            </a:pPr>
+            <a:r>
+              <a:t>Develop</a:t>
+            </a:r>
+          </a:p>
+        </p:txBody>
+      </p:sp>
+      <p:sp>
+        <p:nvSpPr>
+          <p:cNvPr id="38" name="Rectangle 37"/>
+          <p:cNvSpPr/>
+          <p:nvPr/>
+        </p:nvSpPr>
+        <p:spPr>
+          <a:xfrm>
+            <a:off x="7114032" y="3063239"/>
+            <a:ext cx="2542032" cy="310896"/>
+          </a:xfrm>
+          <a:prstGeom prst="rect">
+            <a:avLst/>
+          </a:prstGeom>
+          <a:solidFill>
+            <a:srgbClr val="152446"/>
+          </a:solidFill>
+          <a:ln w="12700">
+            <a:solidFill>
+              <a:srgbClr val="152446"/>
+            </a:solidFill>
+          </a:ln>
+        </p:spPr>
+        <p:style>
+          <a:lnRef idx="1">
+            <a:schemeClr val="accent1"/>
+          </a:lnRef>
+          <a:fillRef idx="3">
+            <a:schemeClr val="accent1"/>
+          </a:fillRef>
+          <a:effectRef idx="2">
+            <a:schemeClr val="accent1"/>
+          </a:effectRef>
+          <a:fontRef idx="minor">
+            <a:schemeClr val="lt1"/>
+          </a:fontRef>
+        </p:style>
+        <p:txBody>
+          <a:bodyPr rtlCol="0" anchor="ctr"/>
+          <a:lstStyle/>
+          <a:p>
+            <a:pPr algn="ctr"/>
+          </a:p>
+        </p:txBody>
+      </p:sp>
+      <p:sp>
+        <p:nvSpPr>
+          <p:cNvPr id="39" name="Rectangle 38"/>
+          <p:cNvSpPr/>
+          <p:nvPr/>
+        </p:nvSpPr>
+        <p:spPr>
+          <a:xfrm>
+            <a:off x="7114032" y="3063239"/>
+            <a:ext cx="368148" cy="310896"/>
+          </a:xfrm>
+          <a:prstGeom prst="rect">
+            <a:avLst/>
+          </a:prstGeom>
+          <a:solidFill>
+            <a:srgbClr val="3A86FF"/>
+          </a:solidFill>
+          <a:ln>
+            <a:noFill/>
+          </a:ln>
+        </p:spPr>
+        <p:style>
+          <a:lnRef idx="1">
+            <a:schemeClr val="accent1"/>
+          </a:lnRef>
+          <a:fillRef idx="3">
+            <a:schemeClr val="accent1"/>
+          </a:fillRef>
+          <a:effectRef idx="2">
+            <a:schemeClr val="accent1"/>
+          </a:effectRef>
+          <a:fontRef idx="minor">
+            <a:schemeClr val="lt1"/>
+          </a:fontRef>
+        </p:style>
+        <p:txBody>
+          <a:bodyPr rtlCol="0" anchor="ctr"/>
+          <a:lstStyle/>
+          <a:p>
+            <a:pPr algn="ctr"/>
+          </a:p>
+        </p:txBody>
+      </p:sp>
+      <p:sp>
+        <p:nvSpPr>
+          <p:cNvPr id="40" name="TextBox 39"/>
+          <p:cNvSpPr txBox="1"/>
+          <p:nvPr/>
+        </p:nvSpPr>
+        <p:spPr>
+          <a:xfrm>
+            <a:off x="9765792" y="3054096"/>
+            <a:ext cx="822960" cy="219456"/>
+          </a:xfrm>
+          <a:prstGeom prst="rect">
+            <a:avLst/>
+          </a:prstGeom>
+          <a:noFill/>
+        </p:spPr>
+        <p:txBody>
+          <a:bodyPr wrap="square" lIns="36576" rIns="36576" tIns="36576" bIns="36576" anchor="t">
+            <a:spAutoFit/>
+          </a:bodyPr>
+          <a:lstStyle/>
+          <a:p>
+            <a:pPr algn="r">
+              <a:defRPr sz="1120" b="1">
+                <a:solidFill>
+                  <a:srgbClr val="F7FAFC"/>
+                </a:solidFill>
+                <a:latin typeface="Aptos"/>
+              </a:defRPr>
+            </a:pPr>
+            <a:r>
+              <a:t>8.10M</a:t>
+            </a:r>
+          </a:p>
+        </p:txBody>
+      </p:sp>
+      <p:sp>
+        <p:nvSpPr>
+          <p:cNvPr id="41" name="TextBox 40"/>
+          <p:cNvSpPr txBox="1"/>
+          <p:nvPr/>
+        </p:nvSpPr>
+        <p:spPr>
+          <a:xfrm>
+            <a:off x="10680192" y="3054096"/>
+            <a:ext cx="658368" cy="274320"/>
+          </a:xfrm>
+          <a:prstGeom prst="rect">
+            <a:avLst/>
+          </a:prstGeom>
+          <a:noFill/>
+        </p:spPr>
+        <p:txBody>
+          <a:bodyPr wrap="square" lIns="36576" rIns="36576" tIns="36576" bIns="36576" anchor="t">
+            <a:spAutoFit/>
+          </a:bodyPr>
+          <a:lstStyle/>
+          <a:p>
+            <a:pPr algn="r">
+              <a:defRPr sz="760" b="0">
+                <a:solidFill>
+                  <a:srgbClr val="A8B2C7"/>
+                </a:solidFill>
+                <a:latin typeface="Aptos"/>
+              </a:defRPr>
+            </a:pPr>
+            <a:r>
+              <a:t>2 opps</a:t>
+            </a:r>
+            <a:br/>
+            <a:r>
+              <a:t>2 rows</a:t>
+            </a:r>
+          </a:p>
+        </p:txBody>
+      </p:sp>
+      <p:sp>
+        <p:nvSpPr>
+          <p:cNvPr id="42" name="TextBox 41"/>
+          <p:cNvSpPr txBox="1"/>
+          <p:nvPr/>
+        </p:nvSpPr>
+        <p:spPr>
+          <a:xfrm>
+            <a:off x="6327648" y="4050792"/>
+            <a:ext cx="749808" cy="201168"/>
+          </a:xfrm>
+          <a:prstGeom prst="rect">
+            <a:avLst/>
+          </a:prstGeom>
+          <a:noFill/>
+        </p:spPr>
+        <p:txBody>
+          <a:bodyPr wrap="square" lIns="36576" rIns="36576" tIns="36576" bIns="36576" anchor="t">
+            <a:spAutoFit/>
+          </a:bodyPr>
+          <a:lstStyle/>
+          <a:p>
+            <a:pPr algn="l">
+              <a:defRPr sz="1050" b="1">
+                <a:solidFill>
+                  <a:srgbClr val="F7FAFC"/>
+                </a:solidFill>
+                <a:latin typeface="Aptos"/>
+              </a:defRPr>
+            </a:pPr>
+            <a:r>
+              <a:t>Design</a:t>
+            </a:r>
+          </a:p>
+        </p:txBody>
+      </p:sp>
+      <p:sp>
+        <p:nvSpPr>
+          <p:cNvPr id="43" name="Rectangle 42"/>
+          <p:cNvSpPr/>
+          <p:nvPr/>
+        </p:nvSpPr>
+        <p:spPr>
+          <a:xfrm>
+            <a:off x="7114032" y="4023360"/>
+            <a:ext cx="2542032" cy="310896"/>
+          </a:xfrm>
+          <a:prstGeom prst="rect">
+            <a:avLst/>
+          </a:prstGeom>
+          <a:solidFill>
+            <a:srgbClr val="152446"/>
+          </a:solidFill>
+          <a:ln w="12700">
+            <a:solidFill>
+              <a:srgbClr val="152446"/>
+            </a:solidFill>
+          </a:ln>
+        </p:spPr>
+        <p:style>
+          <a:lnRef idx="1">
+            <a:schemeClr val="accent1"/>
+          </a:lnRef>
+          <a:fillRef idx="3">
+            <a:schemeClr val="accent1"/>
+          </a:fillRef>
+          <a:effectRef idx="2">
+            <a:schemeClr val="accent1"/>
+          </a:effectRef>
+          <a:fontRef idx="minor">
+            <a:schemeClr val="lt1"/>
+          </a:fontRef>
+        </p:style>
+        <p:txBody>
+          <a:bodyPr rtlCol="0" anchor="ctr"/>
+          <a:lstStyle/>
+          <a:p>
+            <a:pPr algn="ctr"/>
+          </a:p>
+        </p:txBody>
+      </p:sp>
+      <p:sp>
+        <p:nvSpPr>
+          <p:cNvPr id="44" name="Rectangle 43"/>
+          <p:cNvSpPr/>
+          <p:nvPr/>
+        </p:nvSpPr>
+        <p:spPr>
+          <a:xfrm>
+            <a:off x="7114032" y="4023360"/>
+            <a:ext cx="21816" cy="310896"/>
+          </a:xfrm>
+          <a:prstGeom prst="rect">
+            <a:avLst/>
+          </a:prstGeom>
+          <a:solidFill>
+            <a:srgbClr val="3DDC97"/>
+          </a:solidFill>
+          <a:ln>
+            <a:noFill/>
+          </a:ln>
+        </p:spPr>
+        <p:style>
+          <a:lnRef idx="1">
+            <a:schemeClr val="accent1"/>
+          </a:lnRef>
+          <a:fillRef idx="3">
+            <a:schemeClr val="accent1"/>
+          </a:fillRef>
+          <a:effectRef idx="2">
+            <a:schemeClr val="accent1"/>
+          </a:effectRef>
+          <a:fontRef idx="minor">
+            <a:schemeClr val="lt1"/>
+          </a:fontRef>
+        </p:style>
+        <p:txBody>
+          <a:bodyPr rtlCol="0" anchor="ctr"/>
+          <a:lstStyle/>
+          <a:p>
+            <a:pPr algn="ctr"/>
+          </a:p>
+        </p:txBody>
+      </p:sp>
+      <p:sp>
+        <p:nvSpPr>
+          <p:cNvPr id="45" name="TextBox 44"/>
+          <p:cNvSpPr txBox="1"/>
+          <p:nvPr/>
+        </p:nvSpPr>
+        <p:spPr>
+          <a:xfrm>
+            <a:off x="9765792" y="4014216"/>
+            <a:ext cx="822960" cy="219456"/>
+          </a:xfrm>
+          <a:prstGeom prst="rect">
+            <a:avLst/>
+          </a:prstGeom>
+          <a:noFill/>
+        </p:spPr>
+        <p:txBody>
+          <a:bodyPr wrap="square" lIns="36576" rIns="36576" tIns="36576" bIns="36576" anchor="t">
+            <a:spAutoFit/>
+          </a:bodyPr>
+          <a:lstStyle/>
+          <a:p>
+            <a:pPr algn="r">
+              <a:defRPr sz="1120" b="1">
+                <a:solidFill>
+                  <a:srgbClr val="F7FAFC"/>
+                </a:solidFill>
+                <a:latin typeface="Aptos"/>
+              </a:defRPr>
+            </a:pPr>
+            <a:r>
+              <a:t>480K</a:t>
+            </a:r>
+          </a:p>
+        </p:txBody>
+      </p:sp>
+      <p:sp>
+        <p:nvSpPr>
+          <p:cNvPr id="46" name="TextBox 45"/>
+          <p:cNvSpPr txBox="1"/>
+          <p:nvPr/>
+        </p:nvSpPr>
+        <p:spPr>
+          <a:xfrm>
+            <a:off x="10680192" y="4014216"/>
+            <a:ext cx="658368" cy="274320"/>
+          </a:xfrm>
+          <a:prstGeom prst="rect">
+            <a:avLst/>
+          </a:prstGeom>
+          <a:noFill/>
+        </p:spPr>
+        <p:txBody>
+          <a:bodyPr wrap="square" lIns="36576" rIns="36576" tIns="36576" bIns="36576" anchor="t">
+            <a:spAutoFit/>
+          </a:bodyPr>
+          <a:lstStyle/>
+          <a:p>
+            <a:pPr algn="r">
+              <a:defRPr sz="760" b="0">
+                <a:solidFill>
+                  <a:srgbClr val="A8B2C7"/>
+                </a:solidFill>
+                <a:latin typeface="Aptos"/>
+              </a:defRPr>
+            </a:pPr>
+            <a:r>
+              <a:t>3 opps</a:t>
+            </a:r>
+            <a:br/>
+            <a:r>
+              <a:t>4 rows</a:t>
+            </a:r>
+          </a:p>
+        </p:txBody>
+      </p:sp>
+      <p:sp>
+        <p:nvSpPr>
+          <p:cNvPr id="47" name="TextBox 46"/>
+          <p:cNvSpPr txBox="1"/>
+          <p:nvPr/>
+        </p:nvSpPr>
+        <p:spPr>
+          <a:xfrm>
+            <a:off x="6327648" y="5029200"/>
+            <a:ext cx="5010912" cy="201168"/>
+          </a:xfrm>
+          <a:prstGeom prst="rect">
+            <a:avLst/>
+          </a:prstGeom>
+          <a:noFill/>
+        </p:spPr>
+        <p:txBody>
+          <a:bodyPr wrap="square" lIns="36576" rIns="36576" tIns="36576" bIns="36576" anchor="t">
+            <a:spAutoFit/>
+          </a:bodyPr>
+          <a:lstStyle/>
+          <a:p>
+            <a:pPr algn="l">
+              <a:defRPr sz="1050" b="1">
+                <a:solidFill>
+                  <a:srgbClr val="DDE6F3"/>
+                </a:solidFill>
+                <a:latin typeface="Aptos"/>
+              </a:defRPr>
+            </a:pPr>
+            <a:r>
+              <a:t>Direct 6.19M  •  Channel 58.32M</a:t>
+            </a:r>
+          </a:p>
+        </p:txBody>
+      </p:sp>
+      <p:sp>
+        <p:nvSpPr>
+          <p:cNvPr id="48" name="TextBox 47"/>
+          <p:cNvSpPr txBox="1"/>
+          <p:nvPr/>
+        </p:nvSpPr>
+        <p:spPr>
+          <a:xfrm>
+            <a:off x="6327648" y="5376672"/>
+            <a:ext cx="5010912" cy="201168"/>
+          </a:xfrm>
+          <a:prstGeom prst="rect">
+            <a:avLst/>
+          </a:prstGeom>
+          <a:noFill/>
+        </p:spPr>
+        <p:txBody>
+          <a:bodyPr wrap="square" lIns="36576" rIns="36576" tIns="36576" bIns="36576" anchor="t">
+            <a:spAutoFit/>
+          </a:bodyPr>
+          <a:lstStyle/>
+          <a:p>
+            <a:pPr algn="l">
+              <a:defRPr sz="950" b="1">
                 <a:solidFill>
                   <a:srgbClr val="FF9F1C"/>
                 </a:solidFill>
@@ -33323,79 +33964,43 @@
               </a:defRPr>
             </a:pPr>
             <a:r>
-              <a:t>Qualified top 3 = 56%</a:t>
-            </a:r>
-          </a:p>
-        </p:txBody>
-      </p:sp>
-      <p:sp>
-        <p:nvSpPr>
-          <p:cNvPr id="33" name="TextBox 32"/>
-          <p:cNvSpPr txBox="1"/>
-          <p:nvPr/>
-        </p:nvSpPr>
-        <p:spPr>
-          <a:xfrm>
-            <a:off x="3977639" y="5431536"/>
-            <a:ext cx="3429000" cy="237744"/>
-          </a:xfrm>
-          <a:prstGeom prst="rect">
-            <a:avLst/>
-          </a:prstGeom>
-          <a:noFill/>
-        </p:spPr>
-        <p:txBody>
-          <a:bodyPr wrap="square" lIns="36576" rIns="36576" tIns="36576" bIns="36576" anchor="t">
-            <a:spAutoFit/>
-          </a:bodyPr>
-          <a:lstStyle/>
-          <a:p>
-            <a:pPr algn="l">
-              <a:defRPr sz="1300" b="1">
-                <a:solidFill>
-                  <a:srgbClr val="00B8A9"/>
-                </a:solidFill>
-                <a:latin typeface="Aptos"/>
-              </a:defRPr>
-            </a:pPr>
-            <a:r>
-              <a:t>Open exports = 10.45M</a:t>
-            </a:r>
-          </a:p>
-        </p:txBody>
-      </p:sp>
-      <p:sp>
-        <p:nvSpPr>
-          <p:cNvPr id="34" name="TextBox 33"/>
-          <p:cNvSpPr txBox="1"/>
-          <p:nvPr/>
-        </p:nvSpPr>
-        <p:spPr>
-          <a:xfrm>
-            <a:off x="7635240" y="5431536"/>
-            <a:ext cx="3520440" cy="237744"/>
-          </a:xfrm>
-          <a:prstGeom prst="rect">
-            <a:avLst/>
-          </a:prstGeom>
-          <a:noFill/>
-        </p:spPr>
-        <p:txBody>
-          <a:bodyPr wrap="square" lIns="36576" rIns="36576" tIns="36576" bIns="36576" anchor="t">
-            <a:spAutoFit/>
-          </a:bodyPr>
-          <a:lstStyle/>
-          <a:p>
-            <a:pPr algn="l">
-              <a:defRPr sz="1300" b="1">
-                <a:solidFill>
-                  <a:srgbClr val="FF5A5F"/>
-                </a:solidFill>
-                <a:latin typeface="Aptos"/>
-              </a:defRPr>
-            </a:pPr>
-            <a:r>
-              <a:t>Identify outside exports = 3.94M</a:t>
+              <a:t>Define stage = 87% of value</a:t>
+            </a:r>
+          </a:p>
+        </p:txBody>
+      </p:sp>
+      <p:sp>
+        <p:nvSpPr>
+          <p:cNvPr id="49" name="TextBox 48"/>
+          <p:cNvSpPr txBox="1"/>
+          <p:nvPr/>
+        </p:nvSpPr>
+        <p:spPr>
+          <a:xfrm>
+            <a:off x="566928" y="6291072"/>
+            <a:ext cx="10972800" cy="164592"/>
+          </a:xfrm>
+          <a:prstGeom prst="rect">
+            <a:avLst/>
+          </a:prstGeom>
+          <a:noFill/>
+        </p:spPr>
+        <p:txBody>
+          <a:bodyPr wrap="square" lIns="36576" rIns="36576" tIns="36576" bIns="36576" anchor="t">
+            <a:spAutoFit/>
+          </a:bodyPr>
+          <a:lstStyle/>
+          <a:p>
+            <a:pPr algn="l">
+              <a:defRPr sz="720" b="0">
+                <a:solidFill>
+                  <a:srgbClr val="A8B2C7"/>
+                </a:solidFill>
+                <a:latin typeface="Aptos"/>
+              </a:defRPr>
+            </a:pPr>
+            <a:r>
+              <a:t>Source: uploaded FY2026/FY2027 open-pipeline exports. “Rows” are product-line records; “opps” are distinct Opportunity IDs.</a:t>
             </a:r>
           </a:p>
         </p:txBody>

</xml_diff>